<commit_message>
Align finals docs, parallel architecture and 30-second film
</commit_message>
<xml_diff>
--- a/deliverables/決賽簡報_AI資安框架.pptx
+++ b/deliverables/決賽簡報_AI資安框架.pptx
@@ -413,7 +413,7 @@
             <a:pPr/>
             <a:r>
               <a:rPr lang="zh-TW" dirty="0"/>
-              <a:t>架構分為四個階段。流量表徵保留內容、時間差與方向，前段模型輸出固定十七類、校準信心與流量表徵；後段以五百二十九維任務向量取得前五筆訓練案例，由本機AI給出支持、複核或不確定。策略閘門檢查範圍與期限，完成套用、讀回和到期撤銷。所有產物透過同一事件識別碼連結，AI不改寫正式分類。</a:t>
+              <a:t>架構分為上下兩層的四個區域。流量表徵保留內容、時間差與方向，同一輸入平行送入兩個偵測模型，再融合為固定十七類、校準信心與流量表徵；後段以五百二十九維任務向量取得前五筆訓練案例，由本機AI給出支持、複核或不確定。策略閘門檢查範圍與期限，完成套用、讀回和到期撤銷。所有產物透過同一事件識別碼連結，AI不改寫正式分類。</a:t>
             </a:r>
           </a:p>
         </p:txBody>
@@ -473,7 +473,7 @@
             <a:pPr/>
             <a:r>
               <a:rPr lang="zh-TW" dirty="0"/>
-              <a:t>前段以兩種互補特徵共同判斷。CTBM閱讀封包內容、時間差與方向；PBCNN補充短視窗位元組模式。校準後由OOF Gate依事件證據融合，輸出固定十七類，並保留信心與表徵交給後段。</a:t>
+              <a:t>前段以兩種互補特徵平行判斷，並非先後串行。CTBM閱讀封包內容、時間差與方向；PBCNN補充短視窗位元組模式。校準後由OOF Gate依事件證據融合，輸出固定十七類，並保留信心與表徵交給後段。</a:t>
             </a:r>
           </a:p>
         </p:txBody>
@@ -773,7 +773,7 @@
             <a:pPr/>
             <a:r>
               <a:rPr lang="zh-TW" dirty="0"/>
-              <a:t>我們以十七類真實前處理張量重跑整合鏈，並以六種隔離情境確認處置回條與回復行為。作品把偵測、證據與處置放在同一個框架，讓判斷有依據、稽核有證據、處置可回復。方法動畫獨立交付，可搭配本機執行紀錄展示。</a:t>
+              <a:t>我們以十七類真實前處理張量重跑整合鏈，並以六種隔離情境確認處置回條與回復行為。作品把偵測、證據與處置放在同一個框架，讓判斷有依據、稽核有證據、處置可回復。前面播放的三十秒動畫以兩倍速說明流程，並可搭配本機執行紀錄展示。</a:t>
             </a:r>
           </a:p>
         </p:txBody>
@@ -1713,12 +1713,12 @@
         </p:nvSpPr>
         <p:spPr>
           <a:xfrm>
-            <a:off x="190500" y="1663446"/>
-            <a:ext cx="2809875" cy="3655314"/>
+            <a:off x="152400" y="1504950"/>
+            <a:ext cx="2152650" cy="1952625"/>
           </a:xfrm>
           <a:prstGeom prst="roundRect">
             <a:avLst>
-              <a:gd name="adj" fmla="val 2712"/>
+              <a:gd name="adj" fmla="val 3902"/>
             </a:avLst>
           </a:prstGeom>
           <a:solidFill>
@@ -1739,26 +1739,26 @@
         </p:nvSpPr>
         <p:spPr>
           <a:xfrm>
-            <a:off x="353568" y="1742567"/>
-            <a:ext cx="145040" cy="322707"/>
-          </a:xfrm>
-          <a:prstGeom prst="rect">
-            <a:avLst/>
-          </a:prstGeom>
-          <a:noFill/>
-          <a:ln>
-            <a:noFill/>
-          </a:ln>
-        </p:spPr>
-        <p:txBody>
-          <a:bodyPr wrap="none" lIns="0" tIns="0" rIns="0" bIns="0" anchor="t" anchorCtr="0">
-            <a:spAutoFit/>
-          </a:bodyPr>
-          <a:lstStyle/>
-          <a:p>
-            <a:pPr algn="l"/>
-            <a:r>
-              <a:rPr lang="en-US" sz="1650" b="1" dirty="0">
+            <a:off x="314706" y="1593850"/>
+            <a:ext cx="1203819" cy="352044"/>
+          </a:xfrm>
+          <a:prstGeom prst="rect">
+            <a:avLst/>
+          </a:prstGeom>
+          <a:noFill/>
+          <a:ln>
+            <a:noFill/>
+          </a:ln>
+        </p:spPr>
+        <p:txBody>
+          <a:bodyPr wrap="none" lIns="0" tIns="0" rIns="0" bIns="0" anchor="t" anchorCtr="0">
+            <a:spAutoFit/>
+          </a:bodyPr>
+          <a:lstStyle/>
+          <a:p>
+            <a:pPr algn="l"/>
+            <a:r>
+              <a:rPr lang="zh-TW" sz="1800" b="1" dirty="0">
                 <a:solidFill>
                   <a:schemeClr val="accent1"/>
                 </a:solidFill>
@@ -1766,54 +1766,14 @@
                 <a:ea typeface="Microsoft JhengHei"/>
                 <a:cs typeface="Microsoft JhengHei"/>
               </a:rPr>
-              <a:t>a</a:t>
-            </a:r>
-          </a:p>
-        </p:txBody>
-      </p:sp>
-      <p:sp>
-        <p:nvSpPr>
-          <p:cNvPr id="6" name="TextBox 6"/>
-          <p:cNvSpPr txBox="1"/>
-          <p:nvPr/>
-        </p:nvSpPr>
-        <p:spPr>
-          <a:xfrm>
-            <a:off x="638937" y="1729867"/>
-            <a:ext cx="943712" cy="337376"/>
-          </a:xfrm>
-          <a:prstGeom prst="rect">
-            <a:avLst/>
-          </a:prstGeom>
-          <a:noFill/>
-          <a:ln>
-            <a:noFill/>
-          </a:ln>
-        </p:spPr>
-        <p:txBody>
-          <a:bodyPr wrap="none" lIns="0" tIns="0" rIns="0" bIns="0" anchor="t" anchorCtr="0">
-            <a:spAutoFit/>
-          </a:bodyPr>
-          <a:lstStyle/>
-          <a:p>
-            <a:pPr algn="l"/>
-            <a:r>
-              <a:rPr lang="zh-TW" sz="1720" b="1" dirty="0">
-                <a:solidFill>
-                  <a:schemeClr val="dk1"/>
-                </a:solidFill>
-                <a:latin typeface="Microsoft JhengHei"/>
-                <a:ea typeface="Microsoft JhengHei"/>
-                <a:cs typeface="Microsoft JhengHei"/>
-              </a:rPr>
-              <a:t>流量表徵</a:t>
+              <a:t>a 流量表徵</a:t>
             </a:r>
           </a:p>
         </p:txBody>
       </p:sp>
       <p:pic>
         <p:nvPicPr>
-          <p:cNvPr id="7" name="Image 7"/>
+          <p:cNvPr id="6" name="Image 6"/>
           <p:cNvPicPr>
             <a:picLocks noChangeAspect="1"/>
           </p:cNvPicPr>
@@ -1827,8 +1787,8 @@
         </p:blipFill>
         <p:spPr>
           <a:xfrm>
-            <a:off x="1135380" y="2064639"/>
-            <a:ext cx="891540" cy="891540"/>
+            <a:off x="1809750" y="1543050"/>
+            <a:ext cx="323850" cy="323850"/>
           </a:xfrm>
           <a:prstGeom prst="rect">
             <a:avLst/>
@@ -1837,14 +1797,94 @@
       </p:pic>
       <p:sp>
         <p:nvSpPr>
+          <p:cNvPr id="7" name="TextBox 7"/>
+          <p:cNvSpPr txBox="1"/>
+          <p:nvPr/>
+        </p:nvSpPr>
+        <p:spPr>
+          <a:xfrm>
+            <a:off x="315849" y="2085975"/>
+            <a:ext cx="1504899" cy="308991"/>
+          </a:xfrm>
+          <a:prstGeom prst="rect">
+            <a:avLst/>
+          </a:prstGeom>
+          <a:noFill/>
+          <a:ln>
+            <a:noFill/>
+          </a:ln>
+        </p:spPr>
+        <p:txBody>
+          <a:bodyPr wrap="none" lIns="0" tIns="0" rIns="0" bIns="0" anchor="t" anchorCtr="0">
+            <a:spAutoFit/>
+          </a:bodyPr>
+          <a:lstStyle/>
+          <a:p>
+            <a:pPr algn="l"/>
+            <a:r>
+              <a:rPr lang="zh-TW" sz="1580" dirty="0">
+                <a:solidFill>
+                  <a:schemeClr val="dk1"/>
+                </a:solidFill>
+                <a:latin typeface="Microsoft JhengHei"/>
+                <a:ea typeface="Microsoft JhengHei"/>
+                <a:cs typeface="Microsoft JhengHei"/>
+              </a:rPr>
+              <a:t>真實前處理張量</a:t>
+            </a:r>
+          </a:p>
+        </p:txBody>
+      </p:sp>
+      <p:sp>
+        <p:nvSpPr>
           <p:cNvPr id="8" name="TextBox 8"/>
           <p:cNvSpPr txBox="1"/>
           <p:nvPr/>
         </p:nvSpPr>
         <p:spPr>
           <a:xfrm>
-            <a:off x="334518" y="3094736"/>
-            <a:ext cx="2460117" cy="322707"/>
+            <a:off x="315468" y="2501900"/>
+            <a:ext cx="905256" cy="322707"/>
+          </a:xfrm>
+          <a:prstGeom prst="rect">
+            <a:avLst/>
+          </a:prstGeom>
+          <a:noFill/>
+          <a:ln>
+            <a:noFill/>
+          </a:ln>
+        </p:spPr>
+        <p:txBody>
+          <a:bodyPr wrap="none" lIns="0" tIns="0" rIns="0" bIns="0" anchor="t" anchorCtr="0">
+            <a:spAutoFit/>
+          </a:bodyPr>
+          <a:lstStyle/>
+          <a:p>
+            <a:pPr algn="l"/>
+            <a:r>
+              <a:rPr lang="zh-TW" sz="1650" dirty="0">
+                <a:solidFill>
+                  <a:schemeClr val="dk1"/>
+                </a:solidFill>
+                <a:latin typeface="Microsoft JhengHei"/>
+                <a:ea typeface="Microsoft JhengHei"/>
+                <a:cs typeface="Microsoft JhengHei"/>
+              </a:rPr>
+              <a:t>封包內容</a:t>
+            </a:r>
+          </a:p>
+        </p:txBody>
+      </p:sp>
+      <p:sp>
+        <p:nvSpPr>
+          <p:cNvPr id="9" name="TextBox 9"/>
+          <p:cNvSpPr txBox="1"/>
+          <p:nvPr/>
+        </p:nvSpPr>
+        <p:spPr>
+          <a:xfrm>
+            <a:off x="315468" y="2806700"/>
+            <a:ext cx="1349502" cy="322707"/>
           </a:xfrm>
           <a:prstGeom prst="rect">
             <a:avLst/>
@@ -1870,214 +1910,65 @@
                 <a:ea typeface="Microsoft JhengHei"/>
                 <a:cs typeface="Microsoft JhengHei"/>
               </a:rPr>
-              <a:t>封包內容・時間差・方向</a:t>
-            </a:r>
-          </a:p>
-        </p:txBody>
-      </p:sp>
-      <p:sp>
-        <p:nvSpPr>
-          <p:cNvPr id="9" name="TextBox 9"/>
-          <p:cNvSpPr txBox="1"/>
-          <p:nvPr/>
-        </p:nvSpPr>
-        <p:spPr>
-          <a:xfrm>
-            <a:off x="334518" y="3391916"/>
-            <a:ext cx="2460117" cy="322707"/>
-          </a:xfrm>
-          <a:prstGeom prst="rect">
-            <a:avLst/>
-          </a:prstGeom>
-          <a:noFill/>
-          <a:ln>
-            <a:noFill/>
-          </a:ln>
-        </p:spPr>
-        <p:txBody>
-          <a:bodyPr wrap="none" lIns="0" tIns="0" rIns="0" bIns="0" anchor="t" anchorCtr="0">
-            <a:spAutoFit/>
-          </a:bodyPr>
-          <a:lstStyle/>
-          <a:p>
-            <a:pPr algn="l"/>
-            <a:r>
-              <a:rPr lang="ja-JP" sz="1650" dirty="0">
-                <a:solidFill>
-                  <a:schemeClr val="dk1"/>
-                </a:solidFill>
-                <a:latin typeface="Microsoft JhengHei"/>
-                <a:ea typeface="Microsoft JhengHei"/>
-                <a:cs typeface="Microsoft JhengHei"/>
-              </a:rPr>
-              <a:t>遮罩識別欄位・流量切窗</a:t>
-            </a:r>
-          </a:p>
-        </p:txBody>
-      </p:sp>
-      <p:sp>
-        <p:nvSpPr>
-          <p:cNvPr id="10" name="Rectangle 10"/>
+              <a:t>時間差・方向</a:t>
+            </a:r>
+          </a:p>
+        </p:txBody>
+      </p:sp>
+      <p:sp>
+        <p:nvSpPr>
+          <p:cNvPr id="10" name="TextBox 10"/>
+          <p:cNvSpPr txBox="1"/>
+          <p:nvPr/>
+        </p:nvSpPr>
+        <p:spPr>
+          <a:xfrm>
+            <a:off x="316230" y="3105150"/>
+            <a:ext cx="1832610" cy="293370"/>
+          </a:xfrm>
+          <a:prstGeom prst="rect">
+            <a:avLst/>
+          </a:prstGeom>
+          <a:noFill/>
+          <a:ln>
+            <a:noFill/>
+          </a:ln>
+        </p:spPr>
+        <p:txBody>
+          <a:bodyPr wrap="none" lIns="0" tIns="0" rIns="0" bIns="0" anchor="t" anchorCtr="0">
+            <a:spAutoFit/>
+          </a:bodyPr>
+          <a:lstStyle/>
+          <a:p>
+            <a:pPr algn="l"/>
+            <a:r>
+              <a:rPr lang="ja-JP" sz="1500" dirty="0">
+                <a:solidFill>
+                  <a:schemeClr val="accent5"/>
+                </a:solidFill>
+                <a:latin typeface="Microsoft JhengHei"/>
+                <a:ea typeface="Microsoft JhengHei"/>
+                <a:cs typeface="Microsoft JhengHei"/>
+              </a:rPr>
+              <a:t>遮罩欄位・流量切窗</a:t>
+            </a:r>
+          </a:p>
+        </p:txBody>
+      </p:sp>
+      <p:sp>
+        <p:nvSpPr>
+          <p:cNvPr id="11" name="Rectangle 11"/>
           <p:cNvSpPr/>
           <p:nvPr/>
         </p:nvSpPr>
         <p:spPr>
           <a:xfrm>
-            <a:off x="323850" y="3862578"/>
-            <a:ext cx="2543175" cy="1188720"/>
+            <a:off x="2533650" y="1504950"/>
+            <a:ext cx="9505950" cy="1952625"/>
           </a:xfrm>
           <a:prstGeom prst="roundRect">
             <a:avLst>
-              <a:gd name="adj" fmla="val 6410"/>
-            </a:avLst>
-          </a:prstGeom>
-          <a:solidFill>
-            <a:schemeClr val="lt1"/>
-          </a:solidFill>
-          <a:ln>
-            <a:noFill/>
-          </a:ln>
-        </p:spPr>
-      </p:sp>
-      <p:sp>
-        <p:nvSpPr>
-          <p:cNvPr id="11" name="TextBox 11"/>
-          <p:cNvSpPr txBox="1"/>
-          <p:nvPr/>
-        </p:nvSpPr>
-        <p:spPr>
-          <a:xfrm>
-            <a:off x="421005" y="3998976"/>
-            <a:ext cx="2034540" cy="293370"/>
-          </a:xfrm>
-          <a:prstGeom prst="rect">
-            <a:avLst/>
-          </a:prstGeom>
-          <a:noFill/>
-          <a:ln>
-            <a:noFill/>
-          </a:ln>
-        </p:spPr>
-        <p:txBody>
-          <a:bodyPr wrap="none" lIns="0" tIns="0" rIns="0" bIns="0" anchor="t" anchorCtr="0">
-            <a:spAutoFit/>
-          </a:bodyPr>
-          <a:lstStyle/>
-          <a:p>
-            <a:pPr algn="l"/>
-            <a:r>
-              <a:rPr lang="zh-TW" sz="1500" dirty="0">
-                <a:solidFill>
-                  <a:schemeClr val="dk1"/>
-                </a:solidFill>
-                <a:latin typeface="Microsoft JhengHei"/>
-                <a:ea typeface="Microsoft JhengHei"/>
-                <a:cs typeface="Microsoft JhengHei"/>
-              </a:rPr>
-              <a:t>輸入：真實前處理張量</a:t>
-            </a:r>
-          </a:p>
-        </p:txBody>
-      </p:sp>
-      <p:sp>
-        <p:nvSpPr>
-          <p:cNvPr id="12" name="TextBox 12"/>
-          <p:cNvSpPr txBox="1"/>
-          <p:nvPr/>
-        </p:nvSpPr>
-        <p:spPr>
-          <a:xfrm>
-            <a:off x="421005" y="4355592"/>
-            <a:ext cx="1832610" cy="293370"/>
-          </a:xfrm>
-          <a:prstGeom prst="rect">
-            <a:avLst/>
-          </a:prstGeom>
-          <a:noFill/>
-          <a:ln>
-            <a:noFill/>
-          </a:ln>
-        </p:spPr>
-        <p:txBody>
-          <a:bodyPr wrap="none" lIns="0" tIns="0" rIns="0" bIns="0" anchor="t" anchorCtr="0">
-            <a:spAutoFit/>
-          </a:bodyPr>
-          <a:lstStyle/>
-          <a:p>
-            <a:pPr algn="l"/>
-            <a:r>
-              <a:rPr lang="zh-TW" sz="1500" dirty="0">
-                <a:solidFill>
-                  <a:schemeClr val="dk1"/>
-                </a:solidFill>
-                <a:latin typeface="Microsoft JhengHei"/>
-                <a:ea typeface="Microsoft JhengHei"/>
-                <a:cs typeface="Microsoft JhengHei"/>
-              </a:rPr>
-              <a:t>輸出：統一事件表徵</a:t>
-            </a:r>
-          </a:p>
-        </p:txBody>
-      </p:sp>
-      <p:sp>
-        <p:nvSpPr>
-          <p:cNvPr id="13" name="Freeform 13"/>
-          <p:cNvSpPr/>
-          <p:nvPr/>
-        </p:nvSpPr>
-        <p:spPr>
-          <a:xfrm>
-            <a:off x="3019425" y="3671697"/>
-            <a:ext cx="133350" cy="114300"/>
-          </a:xfrm>
-          <a:custGeom>
-            <a:avLst/>
-            <a:gdLst/>
-            <a:ahLst/>
-            <a:cxnLst/>
-            <a:rect l="l" t="t" r="r" b="b"/>
-            <a:pathLst>
-              <a:path w="133350" h="114300">
-                <a:moveTo>
-                  <a:pt x="0" y="57150"/>
-                </a:moveTo>
-                <a:lnTo>
-                  <a:pt x="133350" y="57150"/>
-                </a:lnTo>
-                <a:moveTo>
-                  <a:pt x="76200" y="0"/>
-                </a:moveTo>
-                <a:lnTo>
-                  <a:pt x="133350" y="57150"/>
-                </a:lnTo>
-                <a:lnTo>
-                  <a:pt x="76200" y="114300"/>
-                </a:lnTo>
-              </a:path>
-            </a:pathLst>
-          </a:custGeom>
-          <a:noFill/>
-          <a:ln w="28575">
-            <a:solidFill>
-              <a:schemeClr val="accent1"/>
-            </a:solidFill>
-          </a:ln>
-        </p:spPr>
-      </p:sp>
-      <p:sp>
-        <p:nvSpPr>
-          <p:cNvPr id="14" name="Rectangle 14"/>
-          <p:cNvSpPr/>
-          <p:nvPr/>
-        </p:nvSpPr>
-        <p:spPr>
-          <a:xfrm>
-            <a:off x="3190875" y="1663446"/>
-            <a:ext cx="2809875" cy="3655314"/>
-          </a:xfrm>
-          <a:prstGeom prst="roundRect">
-            <a:avLst>
-              <a:gd name="adj" fmla="val 2712"/>
+              <a:gd name="adj" fmla="val 3902"/>
             </a:avLst>
           </a:prstGeom>
           <a:solidFill>
@@ -2090,89 +1981,9 @@
           </a:ln>
         </p:spPr>
       </p:sp>
-      <p:sp>
-        <p:nvSpPr>
-          <p:cNvPr id="15" name="TextBox 15"/>
-          <p:cNvSpPr txBox="1"/>
-          <p:nvPr/>
-        </p:nvSpPr>
-        <p:spPr>
-          <a:xfrm>
-            <a:off x="3353943" y="1742567"/>
-            <a:ext cx="145040" cy="322707"/>
-          </a:xfrm>
-          <a:prstGeom prst="rect">
-            <a:avLst/>
-          </a:prstGeom>
-          <a:noFill/>
-          <a:ln>
-            <a:noFill/>
-          </a:ln>
-        </p:spPr>
-        <p:txBody>
-          <a:bodyPr wrap="none" lIns="0" tIns="0" rIns="0" bIns="0" anchor="t" anchorCtr="0">
-            <a:spAutoFit/>
-          </a:bodyPr>
-          <a:lstStyle/>
-          <a:p>
-            <a:pPr algn="l"/>
-            <a:r>
-              <a:rPr lang="en-US" sz="1650" b="1" dirty="0">
-                <a:solidFill>
-                  <a:schemeClr val="accent1"/>
-                </a:solidFill>
-                <a:latin typeface="Microsoft JhengHei"/>
-                <a:ea typeface="Microsoft JhengHei"/>
-                <a:cs typeface="Microsoft JhengHei"/>
-              </a:rPr>
-              <a:t>b</a:t>
-            </a:r>
-          </a:p>
-        </p:txBody>
-      </p:sp>
-      <p:sp>
-        <p:nvSpPr>
-          <p:cNvPr id="16" name="TextBox 16"/>
-          <p:cNvSpPr txBox="1"/>
-          <p:nvPr/>
-        </p:nvSpPr>
-        <p:spPr>
-          <a:xfrm>
-            <a:off x="3639312" y="1729867"/>
-            <a:ext cx="1052538" cy="337376"/>
-          </a:xfrm>
-          <a:prstGeom prst="rect">
-            <a:avLst/>
-          </a:prstGeom>
-          <a:noFill/>
-          <a:ln>
-            <a:noFill/>
-          </a:ln>
-        </p:spPr>
-        <p:txBody>
-          <a:bodyPr wrap="none" lIns="0" tIns="0" rIns="0" bIns="0" anchor="t" anchorCtr="0">
-            <a:spAutoFit/>
-          </a:bodyPr>
-          <a:lstStyle/>
-          <a:p>
-            <a:pPr algn="l"/>
-            <a:r>
-              <a:rPr lang="zh-TW" sz="1720" b="1" dirty="0">
-                <a:solidFill>
-                  <a:schemeClr val="dk1"/>
-                </a:solidFill>
-                <a:latin typeface="Microsoft JhengHei"/>
-                <a:ea typeface="Microsoft JhengHei"/>
-                <a:cs typeface="Microsoft JhengHei"/>
-              </a:rPr>
-              <a:t>17 類判定</a:t>
-            </a:r>
-          </a:p>
-        </p:txBody>
-      </p:sp>
       <p:pic>
         <p:nvPicPr>
-          <p:cNvPr id="17" name="Image 17"/>
+          <p:cNvPr id="12" name="Image 12"/>
           <p:cNvPicPr>
             <a:picLocks noChangeAspect="1"/>
           </p:cNvPicPr>
@@ -2186,8 +1997,8 @@
         </p:blipFill>
         <p:spPr>
           <a:xfrm>
-            <a:off x="4135755" y="2064639"/>
-            <a:ext cx="891540" cy="891540"/>
+            <a:off x="2686050" y="1562100"/>
+            <a:ext cx="342900" cy="342900"/>
           </a:xfrm>
           <a:prstGeom prst="rect">
             <a:avLst/>
@@ -2196,105 +2007,279 @@
       </p:pic>
       <p:sp>
         <p:nvSpPr>
-          <p:cNvPr id="18" name="TextBox 18"/>
-          <p:cNvSpPr txBox="1"/>
-          <p:nvPr/>
-        </p:nvSpPr>
-        <p:spPr>
-          <a:xfrm>
-            <a:off x="3334893" y="3094736"/>
-            <a:ext cx="1447571" cy="322707"/>
-          </a:xfrm>
-          <a:prstGeom prst="rect">
-            <a:avLst/>
-          </a:prstGeom>
-          <a:noFill/>
-          <a:ln>
-            <a:noFill/>
-          </a:ln>
-        </p:spPr>
-        <p:txBody>
-          <a:bodyPr wrap="none" lIns="0" tIns="0" rIns="0" bIns="0" anchor="t" anchorCtr="0">
-            <a:spAutoFit/>
-          </a:bodyPr>
-          <a:lstStyle/>
-          <a:p>
-            <a:pPr algn="l"/>
-            <a:r>
-              <a:rPr lang="zh-TW" sz="1650" dirty="0">
-                <a:solidFill>
-                  <a:schemeClr val="dk1"/>
-                </a:solidFill>
-                <a:latin typeface="Microsoft JhengHei"/>
-                <a:ea typeface="Microsoft JhengHei"/>
-                <a:cs typeface="Microsoft JhengHei"/>
-              </a:rPr>
-              <a:t>CTBM＋PBCNN</a:t>
-            </a:r>
-          </a:p>
-        </p:txBody>
-      </p:sp>
-      <p:sp>
-        <p:nvSpPr>
-          <p:cNvPr id="19" name="TextBox 19"/>
-          <p:cNvSpPr txBox="1"/>
-          <p:nvPr/>
-        </p:nvSpPr>
-        <p:spPr>
-          <a:xfrm>
-            <a:off x="3334893" y="3391916"/>
-            <a:ext cx="2170728" cy="322707"/>
-          </a:xfrm>
-          <a:prstGeom prst="rect">
-            <a:avLst/>
-          </a:prstGeom>
-          <a:noFill/>
-          <a:ln>
-            <a:noFill/>
-          </a:ln>
-        </p:spPr>
-        <p:txBody>
-          <a:bodyPr wrap="none" lIns="0" tIns="0" rIns="0" bIns="0" anchor="t" anchorCtr="0">
-            <a:spAutoFit/>
-          </a:bodyPr>
-          <a:lstStyle/>
-          <a:p>
-            <a:pPr algn="l"/>
-            <a:r>
-              <a:rPr lang="ja-JP" sz="1650" dirty="0">
-                <a:solidFill>
-                  <a:schemeClr val="dk1"/>
-                </a:solidFill>
-                <a:latin typeface="Microsoft JhengHei"/>
-                <a:ea typeface="Microsoft JhengHei"/>
-                <a:cs typeface="Microsoft JhengHei"/>
-              </a:rPr>
-              <a:t>校準信心・OOF Gate</a:t>
-            </a:r>
-          </a:p>
-        </p:txBody>
-      </p:sp>
-      <p:sp>
-        <p:nvSpPr>
-          <p:cNvPr id="20" name="Rectangle 20"/>
+          <p:cNvPr id="13" name="TextBox 13"/>
+          <p:cNvSpPr txBox="1"/>
+          <p:nvPr/>
+        </p:nvSpPr>
+        <p:spPr>
+          <a:xfrm>
+            <a:off x="3115056" y="1593850"/>
+            <a:ext cx="2605617" cy="352044"/>
+          </a:xfrm>
+          <a:prstGeom prst="rect">
+            <a:avLst/>
+          </a:prstGeom>
+          <a:noFill/>
+          <a:ln>
+            <a:noFill/>
+          </a:ln>
+        </p:spPr>
+        <p:txBody>
+          <a:bodyPr wrap="none" lIns="0" tIns="0" rIns="0" bIns="0" anchor="t" anchorCtr="0">
+            <a:spAutoFit/>
+          </a:bodyPr>
+          <a:lstStyle/>
+          <a:p>
+            <a:pPr algn="l"/>
+            <a:r>
+              <a:rPr lang="zh-TW" sz="1800" b="1" dirty="0">
+                <a:solidFill>
+                  <a:schemeClr val="accent1"/>
+                </a:solidFill>
+                <a:latin typeface="Microsoft JhengHei"/>
+                <a:ea typeface="Microsoft JhengHei"/>
+                <a:cs typeface="Microsoft JhengHei"/>
+              </a:rPr>
+              <a:t>b 互補模型與 17 類判定</a:t>
+            </a:r>
+          </a:p>
+        </p:txBody>
+      </p:sp>
+      <p:sp>
+        <p:nvSpPr>
+          <p:cNvPr id="14" name="Rectangle 14"/>
           <p:cNvSpPr/>
           <p:nvPr/>
         </p:nvSpPr>
         <p:spPr>
           <a:xfrm>
-            <a:off x="3324225" y="3862578"/>
-            <a:ext cx="2543175" cy="1188720"/>
+            <a:off x="2781300" y="2019300"/>
+            <a:ext cx="2857500" cy="571500"/>
           </a:xfrm>
           <a:prstGeom prst="roundRect">
             <a:avLst>
-              <a:gd name="adj" fmla="val 6410"/>
+              <a:gd name="adj" fmla="val 13333"/>
             </a:avLst>
           </a:prstGeom>
           <a:solidFill>
             <a:schemeClr val="lt1"/>
           </a:solidFill>
-          <a:ln>
-            <a:noFill/>
+          <a:ln w="9525">
+            <a:solidFill>
+              <a:schemeClr val="accent6"/>
+            </a:solidFill>
+          </a:ln>
+        </p:spPr>
+      </p:sp>
+      <p:sp>
+        <p:nvSpPr>
+          <p:cNvPr id="15" name="TextBox 15"/>
+          <p:cNvSpPr txBox="1"/>
+          <p:nvPr/>
+        </p:nvSpPr>
+        <p:spPr>
+          <a:xfrm>
+            <a:off x="2943606" y="2051050"/>
+            <a:ext cx="663489" cy="352044"/>
+          </a:xfrm>
+          <a:prstGeom prst="rect">
+            <a:avLst/>
+          </a:prstGeom>
+          <a:noFill/>
+          <a:ln>
+            <a:noFill/>
+          </a:ln>
+        </p:spPr>
+        <p:txBody>
+          <a:bodyPr wrap="none" lIns="0" tIns="0" rIns="0" bIns="0" anchor="t" anchorCtr="0">
+            <a:spAutoFit/>
+          </a:bodyPr>
+          <a:lstStyle/>
+          <a:p>
+            <a:pPr algn="l"/>
+            <a:r>
+              <a:rPr lang="en-US" sz="1800" b="1" dirty="0">
+                <a:solidFill>
+                  <a:schemeClr val="dk1"/>
+                </a:solidFill>
+                <a:latin typeface="Microsoft JhengHei"/>
+                <a:ea typeface="Microsoft JhengHei"/>
+                <a:cs typeface="Microsoft JhengHei"/>
+              </a:rPr>
+              <a:t>CTBM</a:t>
+            </a:r>
+          </a:p>
+        </p:txBody>
+      </p:sp>
+      <p:sp>
+        <p:nvSpPr>
+          <p:cNvPr id="16" name="TextBox 16"/>
+          <p:cNvSpPr txBox="1"/>
+          <p:nvPr/>
+        </p:nvSpPr>
+        <p:spPr>
+          <a:xfrm>
+            <a:off x="2945130" y="2305050"/>
+            <a:ext cx="1832610" cy="293370"/>
+          </a:xfrm>
+          <a:prstGeom prst="rect">
+            <a:avLst/>
+          </a:prstGeom>
+          <a:noFill/>
+          <a:ln>
+            <a:noFill/>
+          </a:ln>
+        </p:spPr>
+        <p:txBody>
+          <a:bodyPr wrap="none" lIns="0" tIns="0" rIns="0" bIns="0" anchor="t" anchorCtr="0">
+            <a:spAutoFit/>
+          </a:bodyPr>
+          <a:lstStyle/>
+          <a:p>
+            <a:pPr algn="l"/>
+            <a:r>
+              <a:rPr lang="ja-JP" sz="1500" dirty="0">
+                <a:solidFill>
+                  <a:schemeClr val="dk1"/>
+                </a:solidFill>
+                <a:latin typeface="Microsoft JhengHei"/>
+                <a:ea typeface="Microsoft JhengHei"/>
+                <a:cs typeface="Microsoft JhengHei"/>
+              </a:rPr>
+              <a:t>內容・時間差・方向</a:t>
+            </a:r>
+          </a:p>
+        </p:txBody>
+      </p:sp>
+      <p:sp>
+        <p:nvSpPr>
+          <p:cNvPr id="17" name="Rectangle 17"/>
+          <p:cNvSpPr/>
+          <p:nvPr/>
+        </p:nvSpPr>
+        <p:spPr>
+          <a:xfrm>
+            <a:off x="2781300" y="2762250"/>
+            <a:ext cx="2857500" cy="571500"/>
+          </a:xfrm>
+          <a:prstGeom prst="roundRect">
+            <a:avLst>
+              <a:gd name="adj" fmla="val 13333"/>
+            </a:avLst>
+          </a:prstGeom>
+          <a:solidFill>
+            <a:schemeClr val="lt1"/>
+          </a:solidFill>
+          <a:ln w="9525">
+            <a:solidFill>
+              <a:schemeClr val="accent6"/>
+            </a:solidFill>
+          </a:ln>
+        </p:spPr>
+      </p:sp>
+      <p:sp>
+        <p:nvSpPr>
+          <p:cNvPr id="18" name="TextBox 18"/>
+          <p:cNvSpPr txBox="1"/>
+          <p:nvPr/>
+        </p:nvSpPr>
+        <p:spPr>
+          <a:xfrm>
+            <a:off x="2943606" y="2794000"/>
+            <a:ext cx="757580" cy="352044"/>
+          </a:xfrm>
+          <a:prstGeom prst="rect">
+            <a:avLst/>
+          </a:prstGeom>
+          <a:noFill/>
+          <a:ln>
+            <a:noFill/>
+          </a:ln>
+        </p:spPr>
+        <p:txBody>
+          <a:bodyPr wrap="none" lIns="0" tIns="0" rIns="0" bIns="0" anchor="t" anchorCtr="0">
+            <a:spAutoFit/>
+          </a:bodyPr>
+          <a:lstStyle/>
+          <a:p>
+            <a:pPr algn="l"/>
+            <a:r>
+              <a:rPr lang="en-US" sz="1800" b="1" dirty="0">
+                <a:solidFill>
+                  <a:schemeClr val="dk1"/>
+                </a:solidFill>
+                <a:latin typeface="Microsoft JhengHei"/>
+                <a:ea typeface="Microsoft JhengHei"/>
+                <a:cs typeface="Microsoft JhengHei"/>
+              </a:rPr>
+              <a:t>PBCNN</a:t>
+            </a:r>
+          </a:p>
+        </p:txBody>
+      </p:sp>
+      <p:sp>
+        <p:nvSpPr>
+          <p:cNvPr id="19" name="TextBox 19"/>
+          <p:cNvSpPr txBox="1"/>
+          <p:nvPr/>
+        </p:nvSpPr>
+        <p:spPr>
+          <a:xfrm>
+            <a:off x="2945130" y="3048000"/>
+            <a:ext cx="1428750" cy="293370"/>
+          </a:xfrm>
+          <a:prstGeom prst="rect">
+            <a:avLst/>
+          </a:prstGeom>
+          <a:noFill/>
+          <a:ln>
+            <a:noFill/>
+          </a:ln>
+        </p:spPr>
+        <p:txBody>
+          <a:bodyPr wrap="none" lIns="0" tIns="0" rIns="0" bIns="0" anchor="t" anchorCtr="0">
+            <a:spAutoFit/>
+          </a:bodyPr>
+          <a:lstStyle/>
+          <a:p>
+            <a:pPr algn="l"/>
+            <a:r>
+              <a:rPr lang="zh-TW" sz="1500" dirty="0">
+                <a:solidFill>
+                  <a:schemeClr val="dk1"/>
+                </a:solidFill>
+                <a:latin typeface="Microsoft JhengHei"/>
+                <a:ea typeface="Microsoft JhengHei"/>
+                <a:cs typeface="Microsoft JhengHei"/>
+              </a:rPr>
+              <a:t>短窗位元組模式</a:t>
+            </a:r>
+          </a:p>
+        </p:txBody>
+      </p:sp>
+      <p:sp>
+        <p:nvSpPr>
+          <p:cNvPr id="20" name="Rectangle 20"/>
+          <p:cNvSpPr/>
+          <p:nvPr/>
+        </p:nvSpPr>
+        <p:spPr>
+          <a:xfrm>
+            <a:off x="6286500" y="2209800"/>
+            <a:ext cx="2647950" cy="857250"/>
+          </a:xfrm>
+          <a:prstGeom prst="roundRect">
+            <a:avLst>
+              <a:gd name="adj" fmla="val 8889"/>
+            </a:avLst>
+          </a:prstGeom>
+          <a:solidFill>
+            <a:schemeClr val="lt1"/>
+          </a:solidFill>
+          <a:ln w="9525">
+            <a:solidFill>
+              <a:schemeClr val="accent6"/>
+            </a:solidFill>
           </a:ln>
         </p:spPr>
       </p:sp>
@@ -2306,8 +2291,154 @@
         </p:nvSpPr>
         <p:spPr>
           <a:xfrm>
-            <a:off x="3421380" y="3998976"/>
-            <a:ext cx="1428750" cy="293370"/>
+            <a:off x="6486906" y="2308225"/>
+            <a:ext cx="1940345" cy="352044"/>
+          </a:xfrm>
+          <a:prstGeom prst="rect">
+            <a:avLst/>
+          </a:prstGeom>
+          <a:noFill/>
+          <a:ln>
+            <a:noFill/>
+          </a:ln>
+        </p:spPr>
+        <p:txBody>
+          <a:bodyPr wrap="none" lIns="0" tIns="0" rIns="0" bIns="0" anchor="t" anchorCtr="0">
+            <a:spAutoFit/>
+          </a:bodyPr>
+          <a:lstStyle/>
+          <a:p>
+            <a:pPr algn="l"/>
+            <a:r>
+              <a:rPr lang="zh-TW" sz="1800" b="1" dirty="0">
+                <a:solidFill>
+                  <a:schemeClr val="dk1"/>
+                </a:solidFill>
+                <a:latin typeface="Microsoft JhengHei"/>
+                <a:ea typeface="Microsoft JhengHei"/>
+                <a:cs typeface="Microsoft JhengHei"/>
+              </a:rPr>
+              <a:t>校準＋OOF Gate</a:t>
+            </a:r>
+          </a:p>
+        </p:txBody>
+      </p:sp>
+      <p:sp>
+        <p:nvSpPr>
+          <p:cNvPr id="22" name="TextBox 22"/>
+          <p:cNvSpPr txBox="1"/>
+          <p:nvPr/>
+        </p:nvSpPr>
+        <p:spPr>
+          <a:xfrm>
+            <a:off x="6487668" y="2673350"/>
+            <a:ext cx="1571625" cy="322707"/>
+          </a:xfrm>
+          <a:prstGeom prst="rect">
+            <a:avLst/>
+          </a:prstGeom>
+          <a:noFill/>
+          <a:ln>
+            <a:noFill/>
+          </a:ln>
+        </p:spPr>
+        <p:txBody>
+          <a:bodyPr wrap="none" lIns="0" tIns="0" rIns="0" bIns="0" anchor="t" anchorCtr="0">
+            <a:spAutoFit/>
+          </a:bodyPr>
+          <a:lstStyle/>
+          <a:p>
+            <a:pPr algn="l"/>
+            <a:r>
+              <a:rPr lang="zh-TW" sz="1650" dirty="0">
+                <a:solidFill>
+                  <a:schemeClr val="dk1"/>
+                </a:solidFill>
+                <a:latin typeface="Microsoft JhengHei"/>
+                <a:ea typeface="Microsoft JhengHei"/>
+                <a:cs typeface="Microsoft JhengHei"/>
+              </a:rPr>
+              <a:t>依事件證據融合</a:t>
+            </a:r>
+          </a:p>
+        </p:txBody>
+      </p:sp>
+      <p:sp>
+        <p:nvSpPr>
+          <p:cNvPr id="23" name="Rectangle 23"/>
+          <p:cNvSpPr/>
+          <p:nvPr/>
+        </p:nvSpPr>
+        <p:spPr>
+          <a:xfrm>
+            <a:off x="9201150" y="2209800"/>
+            <a:ext cx="2628900" cy="857250"/>
+          </a:xfrm>
+          <a:prstGeom prst="roundRect">
+            <a:avLst>
+              <a:gd name="adj" fmla="val 8889"/>
+            </a:avLst>
+          </a:prstGeom>
+          <a:solidFill>
+            <a:schemeClr val="lt1"/>
+          </a:solidFill>
+          <a:ln w="9525">
+            <a:solidFill>
+              <a:schemeClr val="accent6"/>
+            </a:solidFill>
+          </a:ln>
+        </p:spPr>
+      </p:sp>
+      <p:sp>
+        <p:nvSpPr>
+          <p:cNvPr id="24" name="TextBox 24"/>
+          <p:cNvSpPr txBox="1"/>
+          <p:nvPr/>
+        </p:nvSpPr>
+        <p:spPr>
+          <a:xfrm>
+            <a:off x="9382506" y="2308225"/>
+            <a:ext cx="1586073" cy="352044"/>
+          </a:xfrm>
+          <a:prstGeom prst="rect">
+            <a:avLst/>
+          </a:prstGeom>
+          <a:noFill/>
+          <a:ln>
+            <a:noFill/>
+          </a:ln>
+        </p:spPr>
+        <p:txBody>
+          <a:bodyPr wrap="none" lIns="0" tIns="0" rIns="0" bIns="0" anchor="t" anchorCtr="0">
+            <a:spAutoFit/>
+          </a:bodyPr>
+          <a:lstStyle/>
+          <a:p>
+            <a:pPr algn="l"/>
+            <a:r>
+              <a:rPr lang="zh-TW" sz="1800" b="1" dirty="0">
+                <a:solidFill>
+                  <a:schemeClr val="dk1"/>
+                </a:solidFill>
+                <a:latin typeface="Microsoft JhengHei"/>
+                <a:ea typeface="Microsoft JhengHei"/>
+                <a:cs typeface="Microsoft JhengHei"/>
+              </a:rPr>
+              <a:t>17 類正式判定</a:t>
+            </a:r>
+          </a:p>
+        </p:txBody>
+      </p:sp>
+      <p:sp>
+        <p:nvSpPr>
+          <p:cNvPr id="25" name="TextBox 25"/>
+          <p:cNvSpPr txBox="1"/>
+          <p:nvPr/>
+        </p:nvSpPr>
+        <p:spPr>
+          <a:xfrm>
+            <a:off x="9384030" y="2686050"/>
+            <a:ext cx="2105216" cy="293370"/>
           </a:xfrm>
           <a:prstGeom prst="rect">
             <a:avLst/>
@@ -2333,46 +2464,6 @@
                 <a:ea typeface="Microsoft JhengHei"/>
                 <a:cs typeface="Microsoft JhengHei"/>
               </a:rPr>
-              <a:t>輸出：正式類別</a:t>
-            </a:r>
-          </a:p>
-        </p:txBody>
-      </p:sp>
-      <p:sp>
-        <p:nvSpPr>
-          <p:cNvPr id="22" name="TextBox 22"/>
-          <p:cNvSpPr txBox="1"/>
-          <p:nvPr/>
-        </p:nvSpPr>
-        <p:spPr>
-          <a:xfrm>
-            <a:off x="3421380" y="4355592"/>
-            <a:ext cx="2105216" cy="293370"/>
-          </a:xfrm>
-          <a:prstGeom prst="rect">
-            <a:avLst/>
-          </a:prstGeom>
-          <a:noFill/>
-          <a:ln>
-            <a:noFill/>
-          </a:ln>
-        </p:spPr>
-        <p:txBody>
-          <a:bodyPr wrap="none" lIns="0" tIns="0" rIns="0" bIns="0" anchor="t" anchorCtr="0">
-            <a:spAutoFit/>
-          </a:bodyPr>
-          <a:lstStyle/>
-          <a:p>
-            <a:pPr algn="l"/>
-            <a:r>
-              <a:rPr lang="zh-TW" sz="1500" dirty="0">
-                <a:solidFill>
-                  <a:schemeClr val="dk1"/>
-                </a:solidFill>
-                <a:latin typeface="Microsoft JhengHei"/>
-                <a:ea typeface="Microsoft JhengHei"/>
-                <a:cs typeface="Microsoft JhengHei"/>
-              </a:rPr>
               <a:t>512 維表徵＋17 維機率</a:t>
             </a:r>
           </a:p>
@@ -2380,14 +2471,14 @@
       </p:sp>
       <p:sp>
         <p:nvSpPr>
-          <p:cNvPr id="23" name="Freeform 23"/>
+          <p:cNvPr id="26" name="Freeform 26"/>
           <p:cNvSpPr/>
           <p:nvPr/>
         </p:nvSpPr>
         <p:spPr>
           <a:xfrm>
-            <a:off x="6019800" y="3671697"/>
-            <a:ext cx="133350" cy="114300"/>
+            <a:off x="2305050" y="2305050"/>
+            <a:ext cx="476250" cy="171450"/>
           </a:xfrm>
           <a:custGeom>
             <a:avLst/>
@@ -2396,27 +2487,24 @@
             <a:cxnLst/>
             <a:rect l="l" t="t" r="r" b="b"/>
             <a:pathLst>
-              <a:path w="133350" h="114300">
+              <a:path w="476250" h="171450">
                 <a:moveTo>
-                  <a:pt x="0" y="57150"/>
+                  <a:pt x="0" y="171450"/>
                 </a:moveTo>
                 <a:lnTo>
-                  <a:pt x="133350" y="57150"/>
-                </a:lnTo>
-                <a:moveTo>
-                  <a:pt x="76200" y="0"/>
-                </a:moveTo>
-                <a:lnTo>
-                  <a:pt x="133350" y="57150"/>
+                  <a:pt x="361950" y="171450"/>
                 </a:lnTo>
                 <a:lnTo>
-                  <a:pt x="76200" y="114300"/>
+                  <a:pt x="361950" y="0"/>
+                </a:lnTo>
+                <a:lnTo>
+                  <a:pt x="476250" y="0"/>
                 </a:lnTo>
               </a:path>
             </a:pathLst>
           </a:custGeom>
           <a:noFill/>
-          <a:ln w="28575">
+          <a:ln w="19050">
             <a:solidFill>
               <a:schemeClr val="accent1"/>
             </a:solidFill>
@@ -2425,18 +2513,372 @@
       </p:sp>
       <p:sp>
         <p:nvSpPr>
-          <p:cNvPr id="24" name="Rectangle 24"/>
+          <p:cNvPr id="27" name="Freeform 27"/>
           <p:cNvSpPr/>
           <p:nvPr/>
         </p:nvSpPr>
         <p:spPr>
           <a:xfrm>
-            <a:off x="6191250" y="1663446"/>
-            <a:ext cx="2809875" cy="3655314"/>
+            <a:off x="2714625" y="2257425"/>
+            <a:ext cx="66675" cy="95250"/>
+          </a:xfrm>
+          <a:custGeom>
+            <a:avLst/>
+            <a:gdLst/>
+            <a:ahLst/>
+            <a:cxnLst/>
+            <a:rect l="l" t="t" r="r" b="b"/>
+            <a:pathLst>
+              <a:path w="66675" h="95250">
+                <a:moveTo>
+                  <a:pt x="0" y="0"/>
+                </a:moveTo>
+                <a:lnTo>
+                  <a:pt x="66675" y="47625"/>
+                </a:lnTo>
+                <a:lnTo>
+                  <a:pt x="0" y="95250"/>
+                </a:lnTo>
+              </a:path>
+            </a:pathLst>
+          </a:custGeom>
+          <a:noFill/>
+          <a:ln w="19050">
+            <a:solidFill>
+              <a:schemeClr val="accent1"/>
+            </a:solidFill>
+          </a:ln>
+        </p:spPr>
+      </p:sp>
+      <p:sp>
+        <p:nvSpPr>
+          <p:cNvPr id="28" name="Freeform 28"/>
+          <p:cNvSpPr/>
+          <p:nvPr/>
+        </p:nvSpPr>
+        <p:spPr>
+          <a:xfrm>
+            <a:off x="2667000" y="2476500"/>
+            <a:ext cx="114300" cy="571500"/>
+          </a:xfrm>
+          <a:custGeom>
+            <a:avLst/>
+            <a:gdLst/>
+            <a:ahLst/>
+            <a:cxnLst/>
+            <a:rect l="l" t="t" r="r" b="b"/>
+            <a:pathLst>
+              <a:path w="114300" h="571500">
+                <a:moveTo>
+                  <a:pt x="0" y="0"/>
+                </a:moveTo>
+                <a:lnTo>
+                  <a:pt x="0" y="571500"/>
+                </a:lnTo>
+                <a:lnTo>
+                  <a:pt x="114300" y="571500"/>
+                </a:lnTo>
+              </a:path>
+            </a:pathLst>
+          </a:custGeom>
+          <a:noFill/>
+          <a:ln w="19050">
+            <a:solidFill>
+              <a:schemeClr val="accent1"/>
+            </a:solidFill>
+          </a:ln>
+        </p:spPr>
+      </p:sp>
+      <p:sp>
+        <p:nvSpPr>
+          <p:cNvPr id="29" name="Freeform 29"/>
+          <p:cNvSpPr/>
+          <p:nvPr/>
+        </p:nvSpPr>
+        <p:spPr>
+          <a:xfrm>
+            <a:off x="2714625" y="3000375"/>
+            <a:ext cx="66675" cy="95250"/>
+          </a:xfrm>
+          <a:custGeom>
+            <a:avLst/>
+            <a:gdLst/>
+            <a:ahLst/>
+            <a:cxnLst/>
+            <a:rect l="l" t="t" r="r" b="b"/>
+            <a:pathLst>
+              <a:path w="66675" h="95250">
+                <a:moveTo>
+                  <a:pt x="0" y="0"/>
+                </a:moveTo>
+                <a:lnTo>
+                  <a:pt x="66675" y="47625"/>
+                </a:lnTo>
+                <a:lnTo>
+                  <a:pt x="0" y="95250"/>
+                </a:lnTo>
+              </a:path>
+            </a:pathLst>
+          </a:custGeom>
+          <a:noFill/>
+          <a:ln w="19050">
+            <a:solidFill>
+              <a:schemeClr val="accent1"/>
+            </a:solidFill>
+          </a:ln>
+        </p:spPr>
+      </p:sp>
+      <p:sp>
+        <p:nvSpPr>
+          <p:cNvPr id="30" name="Freeform 30"/>
+          <p:cNvSpPr/>
+          <p:nvPr/>
+        </p:nvSpPr>
+        <p:spPr>
+          <a:xfrm>
+            <a:off x="5638800" y="2305050"/>
+            <a:ext cx="647700" cy="333375"/>
+          </a:xfrm>
+          <a:custGeom>
+            <a:avLst/>
+            <a:gdLst/>
+            <a:ahLst/>
+            <a:cxnLst/>
+            <a:rect l="l" t="t" r="r" b="b"/>
+            <a:pathLst>
+              <a:path w="647700" h="333375">
+                <a:moveTo>
+                  <a:pt x="0" y="0"/>
+                </a:moveTo>
+                <a:lnTo>
+                  <a:pt x="314325" y="0"/>
+                </a:lnTo>
+                <a:lnTo>
+                  <a:pt x="314325" y="333375"/>
+                </a:lnTo>
+                <a:lnTo>
+                  <a:pt x="647700" y="333375"/>
+                </a:lnTo>
+              </a:path>
+            </a:pathLst>
+          </a:custGeom>
+          <a:noFill/>
+          <a:ln w="19050">
+            <a:solidFill>
+              <a:schemeClr val="accent1"/>
+            </a:solidFill>
+          </a:ln>
+        </p:spPr>
+      </p:sp>
+      <p:sp>
+        <p:nvSpPr>
+          <p:cNvPr id="31" name="Freeform 31"/>
+          <p:cNvSpPr/>
+          <p:nvPr/>
+        </p:nvSpPr>
+        <p:spPr>
+          <a:xfrm>
+            <a:off x="6219825" y="2590800"/>
+            <a:ext cx="66675" cy="95250"/>
+          </a:xfrm>
+          <a:custGeom>
+            <a:avLst/>
+            <a:gdLst/>
+            <a:ahLst/>
+            <a:cxnLst/>
+            <a:rect l="l" t="t" r="r" b="b"/>
+            <a:pathLst>
+              <a:path w="66675" h="95250">
+                <a:moveTo>
+                  <a:pt x="0" y="0"/>
+                </a:moveTo>
+                <a:lnTo>
+                  <a:pt x="66675" y="47625"/>
+                </a:lnTo>
+                <a:lnTo>
+                  <a:pt x="0" y="95250"/>
+                </a:lnTo>
+              </a:path>
+            </a:pathLst>
+          </a:custGeom>
+          <a:noFill/>
+          <a:ln w="19050">
+            <a:solidFill>
+              <a:schemeClr val="accent1"/>
+            </a:solidFill>
+          </a:ln>
+        </p:spPr>
+      </p:sp>
+      <p:sp>
+        <p:nvSpPr>
+          <p:cNvPr id="32" name="Freeform 32"/>
+          <p:cNvSpPr/>
+          <p:nvPr/>
+        </p:nvSpPr>
+        <p:spPr>
+          <a:xfrm>
+            <a:off x="5638800" y="2638425"/>
+            <a:ext cx="647700" cy="409575"/>
+          </a:xfrm>
+          <a:custGeom>
+            <a:avLst/>
+            <a:gdLst/>
+            <a:ahLst/>
+            <a:cxnLst/>
+            <a:rect l="l" t="t" r="r" b="b"/>
+            <a:pathLst>
+              <a:path w="647700" h="409575">
+                <a:moveTo>
+                  <a:pt x="0" y="409575"/>
+                </a:moveTo>
+                <a:lnTo>
+                  <a:pt x="314325" y="409575"/>
+                </a:lnTo>
+                <a:lnTo>
+                  <a:pt x="314325" y="0"/>
+                </a:lnTo>
+                <a:lnTo>
+                  <a:pt x="647700" y="0"/>
+                </a:lnTo>
+              </a:path>
+            </a:pathLst>
+          </a:custGeom>
+          <a:noFill/>
+          <a:ln w="19050">
+            <a:solidFill>
+              <a:schemeClr val="accent1"/>
+            </a:solidFill>
+          </a:ln>
+        </p:spPr>
+      </p:sp>
+      <p:sp>
+        <p:nvSpPr>
+          <p:cNvPr id="33" name="Freeform 33"/>
+          <p:cNvSpPr/>
+          <p:nvPr/>
+        </p:nvSpPr>
+        <p:spPr>
+          <a:xfrm>
+            <a:off x="6219825" y="2590800"/>
+            <a:ext cx="66675" cy="95250"/>
+          </a:xfrm>
+          <a:custGeom>
+            <a:avLst/>
+            <a:gdLst/>
+            <a:ahLst/>
+            <a:cxnLst/>
+            <a:rect l="l" t="t" r="r" b="b"/>
+            <a:pathLst>
+              <a:path w="66675" h="95250">
+                <a:moveTo>
+                  <a:pt x="0" y="0"/>
+                </a:moveTo>
+                <a:lnTo>
+                  <a:pt x="66675" y="47625"/>
+                </a:lnTo>
+                <a:lnTo>
+                  <a:pt x="0" y="95250"/>
+                </a:lnTo>
+              </a:path>
+            </a:pathLst>
+          </a:custGeom>
+          <a:noFill/>
+          <a:ln w="19050">
+            <a:solidFill>
+              <a:schemeClr val="accent1"/>
+            </a:solidFill>
+          </a:ln>
+        </p:spPr>
+      </p:sp>
+      <p:sp>
+        <p:nvSpPr>
+          <p:cNvPr id="34" name="Freeform 34"/>
+          <p:cNvSpPr/>
+          <p:nvPr/>
+        </p:nvSpPr>
+        <p:spPr>
+          <a:xfrm>
+            <a:off x="8934450" y="2638425"/>
+            <a:ext cx="266700" cy="9525"/>
+          </a:xfrm>
+          <a:custGeom>
+            <a:avLst/>
+            <a:gdLst/>
+            <a:ahLst/>
+            <a:cxnLst/>
+            <a:rect l="l" t="t" r="r" b="b"/>
+            <a:pathLst>
+              <a:path w="266700" h="9525">
+                <a:moveTo>
+                  <a:pt x="0" y="0"/>
+                </a:moveTo>
+                <a:lnTo>
+                  <a:pt x="266700" y="0"/>
+                </a:lnTo>
+              </a:path>
+            </a:pathLst>
+          </a:custGeom>
+          <a:noFill/>
+          <a:ln w="19050">
+            <a:solidFill>
+              <a:schemeClr val="accent1"/>
+            </a:solidFill>
+          </a:ln>
+        </p:spPr>
+      </p:sp>
+      <p:sp>
+        <p:nvSpPr>
+          <p:cNvPr id="35" name="Freeform 35"/>
+          <p:cNvSpPr/>
+          <p:nvPr/>
+        </p:nvSpPr>
+        <p:spPr>
+          <a:xfrm>
+            <a:off x="9134475" y="2590800"/>
+            <a:ext cx="66675" cy="95250"/>
+          </a:xfrm>
+          <a:custGeom>
+            <a:avLst/>
+            <a:gdLst/>
+            <a:ahLst/>
+            <a:cxnLst/>
+            <a:rect l="l" t="t" r="r" b="b"/>
+            <a:pathLst>
+              <a:path w="66675" h="95250">
+                <a:moveTo>
+                  <a:pt x="0" y="0"/>
+                </a:moveTo>
+                <a:lnTo>
+                  <a:pt x="66675" y="47625"/>
+                </a:lnTo>
+                <a:lnTo>
+                  <a:pt x="0" y="95250"/>
+                </a:lnTo>
+              </a:path>
+            </a:pathLst>
+          </a:custGeom>
+          <a:noFill/>
+          <a:ln w="19050">
+            <a:solidFill>
+              <a:schemeClr val="accent1"/>
+            </a:solidFill>
+          </a:ln>
+        </p:spPr>
+      </p:sp>
+      <p:sp>
+        <p:nvSpPr>
+          <p:cNvPr id="36" name="Rectangle 36"/>
+          <p:cNvSpPr/>
+          <p:nvPr/>
+        </p:nvSpPr>
+        <p:spPr>
+          <a:xfrm>
+            <a:off x="152400" y="4038600"/>
+            <a:ext cx="8001000" cy="1771650"/>
           </a:xfrm>
           <a:prstGeom prst="roundRect">
             <a:avLst>
-              <a:gd name="adj" fmla="val 2712"/>
+              <a:gd name="adj" fmla="val 4301"/>
             </a:avLst>
           </a:prstGeom>
           <a:solidFill>
@@ -2449,89 +2891,9 @@
           </a:ln>
         </p:spPr>
       </p:sp>
-      <p:sp>
-        <p:nvSpPr>
-          <p:cNvPr id="25" name="TextBox 25"/>
-          <p:cNvSpPr txBox="1"/>
-          <p:nvPr/>
-        </p:nvSpPr>
-        <p:spPr>
-          <a:xfrm>
-            <a:off x="6354318" y="1742567"/>
-            <a:ext cx="145040" cy="322707"/>
-          </a:xfrm>
-          <a:prstGeom prst="rect">
-            <a:avLst/>
-          </a:prstGeom>
-          <a:noFill/>
-          <a:ln>
-            <a:noFill/>
-          </a:ln>
-        </p:spPr>
-        <p:txBody>
-          <a:bodyPr wrap="none" lIns="0" tIns="0" rIns="0" bIns="0" anchor="t" anchorCtr="0">
-            <a:spAutoFit/>
-          </a:bodyPr>
-          <a:lstStyle/>
-          <a:p>
-            <a:pPr algn="l"/>
-            <a:r>
-              <a:rPr lang="en-US" sz="1650" b="1" dirty="0">
-                <a:solidFill>
-                  <a:schemeClr val="accent1"/>
-                </a:solidFill>
-                <a:latin typeface="Microsoft JhengHei"/>
-                <a:ea typeface="Microsoft JhengHei"/>
-                <a:cs typeface="Microsoft JhengHei"/>
-              </a:rPr>
-              <a:t>c</a:t>
-            </a:r>
-          </a:p>
-        </p:txBody>
-      </p:sp>
-      <p:sp>
-        <p:nvSpPr>
-          <p:cNvPr id="26" name="TextBox 26"/>
-          <p:cNvSpPr txBox="1"/>
-          <p:nvPr/>
-        </p:nvSpPr>
-        <p:spPr>
-          <a:xfrm>
-            <a:off x="6639687" y="1729867"/>
-            <a:ext cx="1638351" cy="337376"/>
-          </a:xfrm>
-          <a:prstGeom prst="rect">
-            <a:avLst/>
-          </a:prstGeom>
-          <a:noFill/>
-          <a:ln>
-            <a:noFill/>
-          </a:ln>
-        </p:spPr>
-        <p:txBody>
-          <a:bodyPr wrap="none" lIns="0" tIns="0" rIns="0" bIns="0" anchor="t" anchorCtr="0">
-            <a:spAutoFit/>
-          </a:bodyPr>
-          <a:lstStyle/>
-          <a:p>
-            <a:pPr algn="l"/>
-            <a:r>
-              <a:rPr lang="zh-TW" sz="1720" b="1" dirty="0">
-                <a:solidFill>
-                  <a:schemeClr val="dk1"/>
-                </a:solidFill>
-                <a:latin typeface="Microsoft JhengHei"/>
-                <a:ea typeface="Microsoft JhengHei"/>
-                <a:cs typeface="Microsoft JhengHei"/>
-              </a:rPr>
-              <a:t>證據檢索與稽核</a:t>
-            </a:r>
-          </a:p>
-        </p:txBody>
-      </p:sp>
       <p:pic>
         <p:nvPicPr>
-          <p:cNvPr id="27" name="Image 27"/>
+          <p:cNvPr id="37" name="Image 37"/>
           <p:cNvPicPr>
             <a:picLocks noChangeAspect="1"/>
           </p:cNvPicPr>
@@ -2545,8 +2907,8 @@
         </p:blipFill>
         <p:spPr>
           <a:xfrm>
-            <a:off x="7136130" y="2064639"/>
-            <a:ext cx="891540" cy="891540"/>
+            <a:off x="323850" y="4095750"/>
+            <a:ext cx="342900" cy="342900"/>
           </a:xfrm>
           <a:prstGeom prst="rect">
             <a:avLst/>
@@ -2555,117 +2917,331 @@
       </p:pic>
       <p:sp>
         <p:nvSpPr>
-          <p:cNvPr id="28" name="TextBox 28"/>
-          <p:cNvSpPr txBox="1"/>
-          <p:nvPr/>
-        </p:nvSpPr>
-        <p:spPr>
-          <a:xfrm>
-            <a:off x="6335268" y="3094736"/>
-            <a:ext cx="2443143" cy="322707"/>
-          </a:xfrm>
-          <a:prstGeom prst="rect">
-            <a:avLst/>
-          </a:prstGeom>
-          <a:noFill/>
-          <a:ln>
-            <a:noFill/>
-          </a:ln>
-        </p:spPr>
-        <p:txBody>
-          <a:bodyPr wrap="none" lIns="0" tIns="0" rIns="0" bIns="0" anchor="t" anchorCtr="0">
-            <a:spAutoFit/>
-          </a:bodyPr>
-          <a:lstStyle/>
-          <a:p>
-            <a:pPr algn="l"/>
-            <a:r>
-              <a:rPr lang="zh-TW" sz="1650" dirty="0">
-                <a:solidFill>
-                  <a:schemeClr val="dk1"/>
-                </a:solidFill>
-                <a:latin typeface="Microsoft JhengHei"/>
-                <a:ea typeface="Microsoft JhengHei"/>
-                <a:cs typeface="Microsoft JhengHei"/>
-              </a:rPr>
-              <a:t>529 維任務向量 → Top-5</a:t>
-            </a:r>
-          </a:p>
-        </p:txBody>
-      </p:sp>
-      <p:sp>
-        <p:nvSpPr>
-          <p:cNvPr id="29" name="TextBox 29"/>
-          <p:cNvSpPr txBox="1"/>
-          <p:nvPr/>
-        </p:nvSpPr>
-        <p:spPr>
-          <a:xfrm>
-            <a:off x="6335268" y="3391916"/>
-            <a:ext cx="2134057" cy="322707"/>
-          </a:xfrm>
-          <a:prstGeom prst="rect">
-            <a:avLst/>
-          </a:prstGeom>
-          <a:noFill/>
-          <a:ln>
-            <a:noFill/>
-          </a:ln>
-        </p:spPr>
-        <p:txBody>
-          <a:bodyPr wrap="none" lIns="0" tIns="0" rIns="0" bIns="0" anchor="t" anchorCtr="0">
-            <a:spAutoFit/>
-          </a:bodyPr>
-          <a:lstStyle/>
-          <a:p>
-            <a:pPr algn="l"/>
-            <a:r>
-              <a:rPr lang="zh-TW" sz="1650" dirty="0">
-                <a:solidFill>
-                  <a:schemeClr val="dk1"/>
-                </a:solidFill>
-                <a:latin typeface="Microsoft JhengHei"/>
-                <a:ea typeface="Microsoft JhengHei"/>
-                <a:cs typeface="Microsoft JhengHei"/>
-              </a:rPr>
-              <a:t>本機 AI 核對訓練案例</a:t>
-            </a:r>
-          </a:p>
-        </p:txBody>
-      </p:sp>
-      <p:sp>
-        <p:nvSpPr>
-          <p:cNvPr id="30" name="Rectangle 30"/>
+          <p:cNvPr id="38" name="TextBox 38"/>
+          <p:cNvSpPr txBox="1"/>
+          <p:nvPr/>
+        </p:nvSpPr>
+        <p:spPr>
+          <a:xfrm>
+            <a:off x="752856" y="4127500"/>
+            <a:ext cx="2805208" cy="352044"/>
+          </a:xfrm>
+          <a:prstGeom prst="rect">
+            <a:avLst/>
+          </a:prstGeom>
+          <a:noFill/>
+          <a:ln>
+            <a:noFill/>
+          </a:ln>
+        </p:spPr>
+        <p:txBody>
+          <a:bodyPr wrap="none" lIns="0" tIns="0" rIns="0" bIns="0" anchor="t" anchorCtr="0">
+            <a:spAutoFit/>
+          </a:bodyPr>
+          <a:lstStyle/>
+          <a:p>
+            <a:pPr algn="l"/>
+            <a:r>
+              <a:rPr lang="zh-TW" sz="1800" b="1" dirty="0">
+                <a:solidFill>
+                  <a:schemeClr val="accent1"/>
+                </a:solidFill>
+                <a:latin typeface="Microsoft JhengHei"/>
+                <a:ea typeface="Microsoft JhengHei"/>
+                <a:cs typeface="Microsoft JhengHei"/>
+              </a:rPr>
+              <a:t>c 任務導向檢索與 AI 稽核</a:t>
+            </a:r>
+          </a:p>
+        </p:txBody>
+      </p:sp>
+      <p:sp>
+        <p:nvSpPr>
+          <p:cNvPr id="39" name="Rectangle 39"/>
           <p:cNvSpPr/>
           <p:nvPr/>
         </p:nvSpPr>
         <p:spPr>
           <a:xfrm>
-            <a:off x="6324600" y="3862578"/>
-            <a:ext cx="2543175" cy="1188720"/>
+            <a:off x="381000" y="4591050"/>
+            <a:ext cx="1809750" cy="781050"/>
           </a:xfrm>
           <a:prstGeom prst="roundRect">
             <a:avLst>
-              <a:gd name="adj" fmla="val 6410"/>
+              <a:gd name="adj" fmla="val 9756"/>
             </a:avLst>
           </a:prstGeom>
           <a:solidFill>
             <a:schemeClr val="lt1"/>
           </a:solidFill>
-          <a:ln>
-            <a:noFill/>
-          </a:ln>
-        </p:spPr>
-      </p:sp>
-      <p:sp>
-        <p:nvSpPr>
-          <p:cNvPr id="31" name="TextBox 31"/>
-          <p:cNvSpPr txBox="1"/>
-          <p:nvPr/>
-        </p:nvSpPr>
-        <p:spPr>
-          <a:xfrm>
-            <a:off x="6421755" y="3998976"/>
+          <a:ln w="9525">
+            <a:solidFill>
+              <a:schemeClr val="accent6"/>
+            </a:solidFill>
+          </a:ln>
+        </p:spPr>
+      </p:sp>
+      <p:sp>
+        <p:nvSpPr>
+          <p:cNvPr id="40" name="TextBox 40"/>
+          <p:cNvSpPr txBox="1"/>
+          <p:nvPr/>
+        </p:nvSpPr>
+        <p:spPr>
+          <a:xfrm>
+            <a:off x="505968" y="4711700"/>
+            <a:ext cx="1582176" cy="322707"/>
+          </a:xfrm>
+          <a:prstGeom prst="rect">
+            <a:avLst/>
+          </a:prstGeom>
+          <a:noFill/>
+          <a:ln>
+            <a:noFill/>
+          </a:ln>
+        </p:spPr>
+        <p:txBody>
+          <a:bodyPr wrap="none" lIns="0" tIns="0" rIns="0" bIns="0" anchor="t" anchorCtr="0">
+            <a:spAutoFit/>
+          </a:bodyPr>
+          <a:lstStyle/>
+          <a:p>
+            <a:pPr algn="l"/>
+            <a:r>
+              <a:rPr lang="zh-TW" sz="1650" b="1" dirty="0">
+                <a:solidFill>
+                  <a:schemeClr val="dk1"/>
+                </a:solidFill>
+                <a:latin typeface="Microsoft JhengHei"/>
+                <a:ea typeface="Microsoft JhengHei"/>
+                <a:cs typeface="Microsoft JhengHei"/>
+              </a:rPr>
+              <a:t>529 維任務向量</a:t>
+            </a:r>
+          </a:p>
+        </p:txBody>
+      </p:sp>
+      <p:sp>
+        <p:nvSpPr>
+          <p:cNvPr id="41" name="TextBox 41"/>
+          <p:cNvSpPr txBox="1"/>
+          <p:nvPr/>
+        </p:nvSpPr>
+        <p:spPr>
+          <a:xfrm>
+            <a:off x="506730" y="5019675"/>
+            <a:ext cx="919734" cy="293370"/>
+          </a:xfrm>
+          <a:prstGeom prst="rect">
+            <a:avLst/>
+          </a:prstGeom>
+          <a:noFill/>
+          <a:ln>
+            <a:noFill/>
+          </a:ln>
+        </p:spPr>
+        <p:txBody>
+          <a:bodyPr wrap="none" lIns="0" tIns="0" rIns="0" bIns="0" anchor="t" anchorCtr="0">
+            <a:spAutoFit/>
+          </a:bodyPr>
+          <a:lstStyle/>
+          <a:p>
+            <a:pPr algn="l"/>
+            <a:r>
+              <a:rPr lang="zh-TW" sz="1500" dirty="0">
+                <a:solidFill>
+                  <a:schemeClr val="dk1"/>
+                </a:solidFill>
+                <a:latin typeface="Microsoft JhengHei"/>
+                <a:ea typeface="Microsoft JhengHei"/>
+                <a:cs typeface="Microsoft JhengHei"/>
+              </a:rPr>
+              <a:t>L2 正規化</a:t>
+            </a:r>
+          </a:p>
+        </p:txBody>
+      </p:sp>
+      <p:sp>
+        <p:nvSpPr>
+          <p:cNvPr id="42" name="Rectangle 42"/>
+          <p:cNvSpPr/>
+          <p:nvPr/>
+        </p:nvSpPr>
+        <p:spPr>
+          <a:xfrm>
+            <a:off x="2476500" y="4591050"/>
+            <a:ext cx="2324100" cy="781050"/>
+          </a:xfrm>
+          <a:prstGeom prst="roundRect">
+            <a:avLst>
+              <a:gd name="adj" fmla="val 9756"/>
+            </a:avLst>
+          </a:prstGeom>
+          <a:solidFill>
+            <a:schemeClr val="lt1"/>
+          </a:solidFill>
+          <a:ln w="9525">
+            <a:solidFill>
+              <a:schemeClr val="accent6"/>
+            </a:solidFill>
+          </a:ln>
+        </p:spPr>
+      </p:sp>
+      <p:sp>
+        <p:nvSpPr>
+          <p:cNvPr id="43" name="TextBox 43"/>
+          <p:cNvSpPr txBox="1"/>
+          <p:nvPr/>
+        </p:nvSpPr>
+        <p:spPr>
+          <a:xfrm>
+            <a:off x="2601468" y="4711700"/>
+            <a:ext cx="1630027" cy="322707"/>
+          </a:xfrm>
+          <a:prstGeom prst="rect">
+            <a:avLst/>
+          </a:prstGeom>
+          <a:noFill/>
+          <a:ln>
+            <a:noFill/>
+          </a:ln>
+        </p:spPr>
+        <p:txBody>
+          <a:bodyPr wrap="none" lIns="0" tIns="0" rIns="0" bIns="0" anchor="t" anchorCtr="0">
+            <a:spAutoFit/>
+          </a:bodyPr>
+          <a:lstStyle/>
+          <a:p>
+            <a:pPr algn="l"/>
+            <a:r>
+              <a:rPr lang="zh-TW" sz="1650" b="1" dirty="0">
+                <a:solidFill>
+                  <a:schemeClr val="dk1"/>
+                </a:solidFill>
+                <a:latin typeface="Microsoft JhengHei"/>
+                <a:ea typeface="Microsoft JhengHei"/>
+                <a:cs typeface="Microsoft JhengHei"/>
+              </a:rPr>
+              <a:t>Top-5 相似案例</a:t>
+            </a:r>
+          </a:p>
+        </p:txBody>
+      </p:sp>
+      <p:sp>
+        <p:nvSpPr>
+          <p:cNvPr id="44" name="TextBox 44"/>
+          <p:cNvSpPr txBox="1"/>
+          <p:nvPr/>
+        </p:nvSpPr>
+        <p:spPr>
+          <a:xfrm>
+            <a:off x="2602230" y="5019675"/>
+            <a:ext cx="1630680" cy="293370"/>
+          </a:xfrm>
+          <a:prstGeom prst="rect">
+            <a:avLst/>
+          </a:prstGeom>
+          <a:noFill/>
+          <a:ln>
+            <a:noFill/>
+          </a:ln>
+        </p:spPr>
+        <p:txBody>
+          <a:bodyPr wrap="none" lIns="0" tIns="0" rIns="0" bIns="0" anchor="t" anchorCtr="0">
+            <a:spAutoFit/>
+          </a:bodyPr>
+          <a:lstStyle/>
+          <a:p>
+            <a:pPr algn="l"/>
+            <a:r>
+              <a:rPr lang="zh-TW" sz="1500" dirty="0">
+                <a:solidFill>
+                  <a:schemeClr val="dk1"/>
+                </a:solidFill>
+                <a:latin typeface="Microsoft JhengHei"/>
+                <a:ea typeface="Microsoft JhengHei"/>
+                <a:cs typeface="Microsoft JhengHei"/>
+              </a:rPr>
+              <a:t>僅訓練資料案例庫</a:t>
+            </a:r>
+          </a:p>
+        </p:txBody>
+      </p:sp>
+      <p:sp>
+        <p:nvSpPr>
+          <p:cNvPr id="45" name="Rectangle 45"/>
+          <p:cNvSpPr/>
+          <p:nvPr/>
+        </p:nvSpPr>
+        <p:spPr>
+          <a:xfrm>
+            <a:off x="5143500" y="4591050"/>
+            <a:ext cx="2781300" cy="781050"/>
+          </a:xfrm>
+          <a:prstGeom prst="roundRect">
+            <a:avLst>
+              <a:gd name="adj" fmla="val 9756"/>
+            </a:avLst>
+          </a:prstGeom>
+          <a:solidFill>
+            <a:schemeClr val="lt1"/>
+          </a:solidFill>
+          <a:ln w="9525">
+            <a:solidFill>
+              <a:schemeClr val="accent6"/>
+            </a:solidFill>
+          </a:ln>
+        </p:spPr>
+      </p:sp>
+      <p:sp>
+        <p:nvSpPr>
+          <p:cNvPr id="46" name="TextBox 46"/>
+          <p:cNvSpPr txBox="1"/>
+          <p:nvPr/>
+        </p:nvSpPr>
+        <p:spPr>
+          <a:xfrm>
+            <a:off x="5268468" y="4711700"/>
+            <a:ext cx="1262581" cy="322707"/>
+          </a:xfrm>
+          <a:prstGeom prst="rect">
+            <a:avLst/>
+          </a:prstGeom>
+          <a:noFill/>
+          <a:ln>
+            <a:noFill/>
+          </a:ln>
+        </p:spPr>
+        <p:txBody>
+          <a:bodyPr wrap="none" lIns="0" tIns="0" rIns="0" bIns="0" anchor="t" anchorCtr="0">
+            <a:spAutoFit/>
+          </a:bodyPr>
+          <a:lstStyle/>
+          <a:p>
+            <a:pPr algn="l"/>
+            <a:r>
+              <a:rPr lang="zh-TW" sz="1650" b="1" dirty="0">
+                <a:solidFill>
+                  <a:schemeClr val="dk1"/>
+                </a:solidFill>
+                <a:latin typeface="Microsoft JhengHei"/>
+                <a:ea typeface="Microsoft JhengHei"/>
+                <a:cs typeface="Microsoft JhengHei"/>
+              </a:rPr>
+              <a:t>本機 AI 稽核</a:t>
+            </a:r>
+          </a:p>
+        </p:txBody>
+      </p:sp>
+      <p:sp>
+        <p:nvSpPr>
+          <p:cNvPr id="47" name="TextBox 47"/>
+          <p:cNvSpPr txBox="1"/>
+          <p:nvPr/>
+        </p:nvSpPr>
+        <p:spPr>
+          <a:xfrm>
+            <a:off x="5269230" y="5019675"/>
             <a:ext cx="1832610" cy="293370"/>
           </a:xfrm>
           <a:prstGeom prst="rect">
@@ -2699,54 +3275,14 @@
       </p:sp>
       <p:sp>
         <p:nvSpPr>
-          <p:cNvPr id="32" name="TextBox 32"/>
-          <p:cNvSpPr txBox="1"/>
-          <p:nvPr/>
-        </p:nvSpPr>
-        <p:spPr>
-          <a:xfrm>
-            <a:off x="6421755" y="4355592"/>
-            <a:ext cx="1832610" cy="293370"/>
-          </a:xfrm>
-          <a:prstGeom prst="rect">
-            <a:avLst/>
-          </a:prstGeom>
-          <a:noFill/>
-          <a:ln>
-            <a:noFill/>
-          </a:ln>
-        </p:spPr>
-        <p:txBody>
-          <a:bodyPr wrap="none" lIns="0" tIns="0" rIns="0" bIns="0" anchor="t" anchorCtr="0">
-            <a:spAutoFit/>
-          </a:bodyPr>
-          <a:lstStyle/>
-          <a:p>
-            <a:pPr algn="l"/>
-            <a:r>
-              <a:rPr lang="zh-TW" sz="1500" dirty="0">
-                <a:solidFill>
-                  <a:schemeClr val="dk1"/>
-                </a:solidFill>
-                <a:latin typeface="Microsoft JhengHei"/>
-                <a:ea typeface="Microsoft JhengHei"/>
-                <a:cs typeface="Microsoft JhengHei"/>
-              </a:rPr>
-              <a:t>稽核不改寫正式分類</a:t>
-            </a:r>
-          </a:p>
-        </p:txBody>
-      </p:sp>
-      <p:sp>
-        <p:nvSpPr>
-          <p:cNvPr id="33" name="Freeform 33"/>
+          <p:cNvPr id="48" name="Freeform 48"/>
           <p:cNvSpPr/>
           <p:nvPr/>
         </p:nvSpPr>
         <p:spPr>
           <a:xfrm>
-            <a:off x="9020175" y="3671697"/>
-            <a:ext cx="133350" cy="114300"/>
+            <a:off x="47625" y="3067050"/>
+            <a:ext cx="10467975" cy="1914525"/>
           </a:xfrm>
           <a:custGeom>
             <a:avLst/>
@@ -2755,27 +3291,27 @@
             <a:cxnLst/>
             <a:rect l="l" t="t" r="r" b="b"/>
             <a:pathLst>
-              <a:path w="133350" h="114300">
+              <a:path w="10467975" h="1914525">
                 <a:moveTo>
-                  <a:pt x="0" y="57150"/>
+                  <a:pt x="10467975" y="0"/>
                 </a:moveTo>
                 <a:lnTo>
-                  <a:pt x="133350" y="57150"/>
-                </a:lnTo>
-                <a:moveTo>
-                  <a:pt x="76200" y="0"/>
-                </a:moveTo>
-                <a:lnTo>
-                  <a:pt x="133350" y="57150"/>
+                  <a:pt x="10467975" y="657225"/>
                 </a:lnTo>
                 <a:lnTo>
-                  <a:pt x="76200" y="114300"/>
+                  <a:pt x="0" y="657225"/>
+                </a:lnTo>
+                <a:lnTo>
+                  <a:pt x="0" y="1914525"/>
+                </a:lnTo>
+                <a:lnTo>
+                  <a:pt x="333375" y="1914525"/>
                 </a:lnTo>
               </a:path>
             </a:pathLst>
           </a:custGeom>
           <a:noFill/>
-          <a:ln w="28575">
+          <a:ln w="19050">
             <a:solidFill>
               <a:schemeClr val="accent1"/>
             </a:solidFill>
@@ -2784,18 +3320,405 @@
       </p:sp>
       <p:sp>
         <p:nvSpPr>
-          <p:cNvPr id="34" name="Rectangle 34"/>
+          <p:cNvPr id="49" name="Freeform 49"/>
           <p:cNvSpPr/>
           <p:nvPr/>
         </p:nvSpPr>
         <p:spPr>
           <a:xfrm>
-            <a:off x="9191625" y="1663446"/>
-            <a:ext cx="2809875" cy="3655314"/>
+            <a:off x="314325" y="4933950"/>
+            <a:ext cx="66675" cy="95250"/>
+          </a:xfrm>
+          <a:custGeom>
+            <a:avLst/>
+            <a:gdLst/>
+            <a:ahLst/>
+            <a:cxnLst/>
+            <a:rect l="l" t="t" r="r" b="b"/>
+            <a:pathLst>
+              <a:path w="66675" h="95250">
+                <a:moveTo>
+                  <a:pt x="0" y="0"/>
+                </a:moveTo>
+                <a:lnTo>
+                  <a:pt x="66675" y="47625"/>
+                </a:lnTo>
+                <a:lnTo>
+                  <a:pt x="0" y="95250"/>
+                </a:lnTo>
+              </a:path>
+            </a:pathLst>
+          </a:custGeom>
+          <a:noFill/>
+          <a:ln w="19050">
+            <a:solidFill>
+              <a:schemeClr val="accent1"/>
+            </a:solidFill>
+          </a:ln>
+        </p:spPr>
+      </p:sp>
+      <p:sp>
+        <p:nvSpPr>
+          <p:cNvPr id="50" name="TextBox 50"/>
+          <p:cNvSpPr txBox="1"/>
+          <p:nvPr/>
+        </p:nvSpPr>
+        <p:spPr>
+          <a:xfrm>
+            <a:off x="4564380" y="3435350"/>
+            <a:ext cx="2682240" cy="322707"/>
+          </a:xfrm>
+          <a:prstGeom prst="rect">
+            <a:avLst/>
+          </a:prstGeom>
+          <a:noFill/>
+          <a:ln>
+            <a:noFill/>
+          </a:ln>
+        </p:spPr>
+        <p:txBody>
+          <a:bodyPr wrap="none" lIns="0" tIns="0" rIns="0" bIns="0" anchor="t" anchorCtr="0">
+            <a:spAutoFit/>
+          </a:bodyPr>
+          <a:lstStyle/>
+          <a:p>
+            <a:pPr algn="ctr"/>
+            <a:r>
+              <a:rPr lang="ja-JP" sz="1650" dirty="0">
+                <a:solidFill>
+                  <a:schemeClr val="dk1"/>
+                </a:solidFill>
+                <a:latin typeface="Microsoft JhengHei"/>
+                <a:ea typeface="Microsoft JhengHei"/>
+                <a:cs typeface="Microsoft JhengHei"/>
+              </a:rPr>
+              <a:t>正式類別・信心・模型表徵</a:t>
+            </a:r>
+          </a:p>
+        </p:txBody>
+      </p:sp>
+      <p:sp>
+        <p:nvSpPr>
+          <p:cNvPr id="51" name="Freeform 51"/>
+          <p:cNvSpPr/>
+          <p:nvPr/>
+        </p:nvSpPr>
+        <p:spPr>
+          <a:xfrm>
+            <a:off x="2190750" y="4981575"/>
+            <a:ext cx="285750" cy="9525"/>
+          </a:xfrm>
+          <a:custGeom>
+            <a:avLst/>
+            <a:gdLst/>
+            <a:ahLst/>
+            <a:cxnLst/>
+            <a:rect l="l" t="t" r="r" b="b"/>
+            <a:pathLst>
+              <a:path w="285750" h="9525">
+                <a:moveTo>
+                  <a:pt x="0" y="0"/>
+                </a:moveTo>
+                <a:lnTo>
+                  <a:pt x="285750" y="0"/>
+                </a:lnTo>
+              </a:path>
+            </a:pathLst>
+          </a:custGeom>
+          <a:noFill/>
+          <a:ln w="19050">
+            <a:solidFill>
+              <a:schemeClr val="accent1"/>
+            </a:solidFill>
+          </a:ln>
+        </p:spPr>
+      </p:sp>
+      <p:sp>
+        <p:nvSpPr>
+          <p:cNvPr id="52" name="Freeform 52"/>
+          <p:cNvSpPr/>
+          <p:nvPr/>
+        </p:nvSpPr>
+        <p:spPr>
+          <a:xfrm>
+            <a:off x="2409825" y="4933950"/>
+            <a:ext cx="66675" cy="95250"/>
+          </a:xfrm>
+          <a:custGeom>
+            <a:avLst/>
+            <a:gdLst/>
+            <a:ahLst/>
+            <a:cxnLst/>
+            <a:rect l="l" t="t" r="r" b="b"/>
+            <a:pathLst>
+              <a:path w="66675" h="95250">
+                <a:moveTo>
+                  <a:pt x="0" y="0"/>
+                </a:moveTo>
+                <a:lnTo>
+                  <a:pt x="66675" y="47625"/>
+                </a:lnTo>
+                <a:lnTo>
+                  <a:pt x="0" y="95250"/>
+                </a:lnTo>
+              </a:path>
+            </a:pathLst>
+          </a:custGeom>
+          <a:noFill/>
+          <a:ln w="19050">
+            <a:solidFill>
+              <a:schemeClr val="accent1"/>
+            </a:solidFill>
+          </a:ln>
+        </p:spPr>
+      </p:sp>
+      <p:sp>
+        <p:nvSpPr>
+          <p:cNvPr id="53" name="Freeform 53"/>
+          <p:cNvSpPr/>
+          <p:nvPr/>
+        </p:nvSpPr>
+        <p:spPr>
+          <a:xfrm>
+            <a:off x="4800600" y="4981575"/>
+            <a:ext cx="342900" cy="9525"/>
+          </a:xfrm>
+          <a:custGeom>
+            <a:avLst/>
+            <a:gdLst/>
+            <a:ahLst/>
+            <a:cxnLst/>
+            <a:rect l="l" t="t" r="r" b="b"/>
+            <a:pathLst>
+              <a:path w="342900" h="9525">
+                <a:moveTo>
+                  <a:pt x="0" y="0"/>
+                </a:moveTo>
+                <a:lnTo>
+                  <a:pt x="342900" y="0"/>
+                </a:lnTo>
+              </a:path>
+            </a:pathLst>
+          </a:custGeom>
+          <a:noFill/>
+          <a:ln w="19050">
+            <a:solidFill>
+              <a:schemeClr val="accent1"/>
+            </a:solidFill>
+          </a:ln>
+        </p:spPr>
+      </p:sp>
+      <p:sp>
+        <p:nvSpPr>
+          <p:cNvPr id="54" name="Freeform 54"/>
+          <p:cNvSpPr/>
+          <p:nvPr/>
+        </p:nvSpPr>
+        <p:spPr>
+          <a:xfrm>
+            <a:off x="5076825" y="4933950"/>
+            <a:ext cx="66675" cy="95250"/>
+          </a:xfrm>
+          <a:custGeom>
+            <a:avLst/>
+            <a:gdLst/>
+            <a:ahLst/>
+            <a:cxnLst/>
+            <a:rect l="l" t="t" r="r" b="b"/>
+            <a:pathLst>
+              <a:path w="66675" h="95250">
+                <a:moveTo>
+                  <a:pt x="0" y="0"/>
+                </a:moveTo>
+                <a:lnTo>
+                  <a:pt x="66675" y="47625"/>
+                </a:lnTo>
+                <a:lnTo>
+                  <a:pt x="0" y="95250"/>
+                </a:lnTo>
+              </a:path>
+            </a:pathLst>
+          </a:custGeom>
+          <a:noFill/>
+          <a:ln w="19050">
+            <a:solidFill>
+              <a:schemeClr val="accent1"/>
+            </a:solidFill>
+          </a:ln>
+        </p:spPr>
+      </p:sp>
+      <p:sp>
+        <p:nvSpPr>
+          <p:cNvPr id="55" name="TextBox 55"/>
+          <p:cNvSpPr txBox="1"/>
+          <p:nvPr/>
+        </p:nvSpPr>
+        <p:spPr>
+          <a:xfrm>
+            <a:off x="3107055" y="5486400"/>
+            <a:ext cx="1024890" cy="293370"/>
+          </a:xfrm>
+          <a:prstGeom prst="rect">
+            <a:avLst/>
+          </a:prstGeom>
+          <a:noFill/>
+          <a:ln>
+            <a:noFill/>
+          </a:ln>
+        </p:spPr>
+        <p:txBody>
+          <a:bodyPr wrap="none" lIns="0" tIns="0" rIns="0" bIns="0" anchor="t" anchorCtr="0">
+            <a:spAutoFit/>
+          </a:bodyPr>
+          <a:lstStyle/>
+          <a:p>
+            <a:pPr algn="ctr"/>
+            <a:r>
+              <a:rPr lang="zh-TW" sz="1500" dirty="0">
+                <a:solidFill>
+                  <a:schemeClr val="accent5"/>
+                </a:solidFill>
+                <a:latin typeface="Microsoft JhengHei"/>
+                <a:ea typeface="Microsoft JhengHei"/>
+                <a:cs typeface="Microsoft JhengHei"/>
+              </a:rPr>
+              <a:t>訓練案例庫</a:t>
+            </a:r>
+          </a:p>
+        </p:txBody>
+      </p:sp>
+      <p:sp>
+        <p:nvSpPr>
+          <p:cNvPr id="56" name="Freeform 56"/>
+          <p:cNvSpPr/>
+          <p:nvPr/>
+        </p:nvSpPr>
+        <p:spPr>
+          <a:xfrm>
+            <a:off x="3619500" y="5372100"/>
+            <a:ext cx="9525" cy="114300"/>
+          </a:xfrm>
+          <a:custGeom>
+            <a:avLst/>
+            <a:gdLst/>
+            <a:ahLst/>
+            <a:cxnLst/>
+            <a:rect l="l" t="t" r="r" b="b"/>
+            <a:pathLst>
+              <a:path w="9525" h="114300">
+                <a:moveTo>
+                  <a:pt x="0" y="114300"/>
+                </a:moveTo>
+                <a:lnTo>
+                  <a:pt x="0" y="0"/>
+                </a:lnTo>
+              </a:path>
+            </a:pathLst>
+          </a:custGeom>
+          <a:noFill/>
+          <a:ln w="19050">
+            <a:solidFill>
+              <a:srgbClr val="6B6B6B"/>
+            </a:solidFill>
+            <a:custDash>
+              <a:ds d="250000" sp="200000"/>
+            </a:custDash>
+          </a:ln>
+        </p:spPr>
+      </p:sp>
+      <p:sp>
+        <p:nvSpPr>
+          <p:cNvPr id="57" name="Freeform 57"/>
+          <p:cNvSpPr/>
+          <p:nvPr/>
+        </p:nvSpPr>
+        <p:spPr>
+          <a:xfrm>
+            <a:off x="3571875" y="5372100"/>
+            <a:ext cx="95250" cy="66675"/>
+          </a:xfrm>
+          <a:custGeom>
+            <a:avLst/>
+            <a:gdLst/>
+            <a:ahLst/>
+            <a:cxnLst/>
+            <a:rect l="l" t="t" r="r" b="b"/>
+            <a:pathLst>
+              <a:path w="95250" h="66675">
+                <a:moveTo>
+                  <a:pt x="0" y="66675"/>
+                </a:moveTo>
+                <a:lnTo>
+                  <a:pt x="47625" y="0"/>
+                </a:lnTo>
+                <a:lnTo>
+                  <a:pt x="95250" y="66675"/>
+                </a:lnTo>
+              </a:path>
+            </a:pathLst>
+          </a:custGeom>
+          <a:noFill/>
+          <a:ln w="19050">
+            <a:solidFill>
+              <a:srgbClr val="6B6B6B"/>
+            </a:solidFill>
+          </a:ln>
+        </p:spPr>
+      </p:sp>
+      <p:sp>
+        <p:nvSpPr>
+          <p:cNvPr id="58" name="TextBox 58"/>
+          <p:cNvSpPr txBox="1"/>
+          <p:nvPr/>
+        </p:nvSpPr>
+        <p:spPr>
+          <a:xfrm>
+            <a:off x="5269230" y="5486400"/>
+            <a:ext cx="1630680" cy="293370"/>
+          </a:xfrm>
+          <a:prstGeom prst="rect">
+            <a:avLst/>
+          </a:prstGeom>
+          <a:noFill/>
+          <a:ln>
+            <a:noFill/>
+          </a:ln>
+        </p:spPr>
+        <p:txBody>
+          <a:bodyPr wrap="none" lIns="0" tIns="0" rIns="0" bIns="0" anchor="t" anchorCtr="0">
+            <a:spAutoFit/>
+          </a:bodyPr>
+          <a:lstStyle/>
+          <a:p>
+            <a:pPr algn="l"/>
+            <a:r>
+              <a:rPr lang="zh-TW" sz="1500" dirty="0">
+                <a:solidFill>
+                  <a:schemeClr val="accent5"/>
+                </a:solidFill>
+                <a:latin typeface="Microsoft JhengHei"/>
+                <a:ea typeface="Microsoft JhengHei"/>
+                <a:cs typeface="Microsoft JhengHei"/>
+              </a:rPr>
+              <a:t>稽核保留正式分類</a:t>
+            </a:r>
+          </a:p>
+        </p:txBody>
+      </p:sp>
+      <p:sp>
+        <p:nvSpPr>
+          <p:cNvPr id="59" name="Rectangle 59"/>
+          <p:cNvSpPr/>
+          <p:nvPr/>
+        </p:nvSpPr>
+        <p:spPr>
+          <a:xfrm>
+            <a:off x="8382000" y="4038600"/>
+            <a:ext cx="3657600" cy="1771650"/>
           </a:xfrm>
           <a:prstGeom prst="roundRect">
             <a:avLst>
-              <a:gd name="adj" fmla="val 2712"/>
+              <a:gd name="adj" fmla="val 4301"/>
             </a:avLst>
           </a:prstGeom>
           <a:solidFill>
@@ -2808,89 +3731,9 @@
           </a:ln>
         </p:spPr>
       </p:sp>
-      <p:sp>
-        <p:nvSpPr>
-          <p:cNvPr id="35" name="TextBox 35"/>
-          <p:cNvSpPr txBox="1"/>
-          <p:nvPr/>
-        </p:nvSpPr>
-        <p:spPr>
-          <a:xfrm>
-            <a:off x="9354693" y="1742567"/>
-            <a:ext cx="145040" cy="322707"/>
-          </a:xfrm>
-          <a:prstGeom prst="rect">
-            <a:avLst/>
-          </a:prstGeom>
-          <a:noFill/>
-          <a:ln>
-            <a:noFill/>
-          </a:ln>
-        </p:spPr>
-        <p:txBody>
-          <a:bodyPr wrap="none" lIns="0" tIns="0" rIns="0" bIns="0" anchor="t" anchorCtr="0">
-            <a:spAutoFit/>
-          </a:bodyPr>
-          <a:lstStyle/>
-          <a:p>
-            <a:pPr algn="l"/>
-            <a:r>
-              <a:rPr lang="en-US" sz="1650" b="1" dirty="0">
-                <a:solidFill>
-                  <a:schemeClr val="accent1"/>
-                </a:solidFill>
-                <a:latin typeface="Microsoft JhengHei"/>
-                <a:ea typeface="Microsoft JhengHei"/>
-                <a:cs typeface="Microsoft JhengHei"/>
-              </a:rPr>
-              <a:t>d</a:t>
-            </a:r>
-          </a:p>
-        </p:txBody>
-      </p:sp>
-      <p:sp>
-        <p:nvSpPr>
-          <p:cNvPr id="36" name="TextBox 36"/>
-          <p:cNvSpPr txBox="1"/>
-          <p:nvPr/>
-        </p:nvSpPr>
-        <p:spPr>
-          <a:xfrm>
-            <a:off x="9640062" y="1729867"/>
-            <a:ext cx="1638351" cy="337376"/>
-          </a:xfrm>
-          <a:prstGeom prst="rect">
-            <a:avLst/>
-          </a:prstGeom>
-          <a:noFill/>
-          <a:ln>
-            <a:noFill/>
-          </a:ln>
-        </p:spPr>
-        <p:txBody>
-          <a:bodyPr wrap="none" lIns="0" tIns="0" rIns="0" bIns="0" anchor="t" anchorCtr="0">
-            <a:spAutoFit/>
-          </a:bodyPr>
-          <a:lstStyle/>
-          <a:p>
-            <a:pPr algn="l"/>
-            <a:r>
-              <a:rPr lang="zh-TW" sz="1720" b="1" dirty="0">
-                <a:solidFill>
-                  <a:schemeClr val="dk1"/>
-                </a:solidFill>
-                <a:latin typeface="Microsoft JhengHei"/>
-                <a:ea typeface="Microsoft JhengHei"/>
-                <a:cs typeface="Microsoft JhengHei"/>
-              </a:rPr>
-              <a:t>受控處置與回復</a:t>
-            </a:r>
-          </a:p>
-        </p:txBody>
-      </p:sp>
       <p:pic>
         <p:nvPicPr>
-          <p:cNvPr id="37" name="Image 37"/>
+          <p:cNvPr id="60" name="Image 60"/>
           <p:cNvPicPr>
             <a:picLocks noChangeAspect="1"/>
           </p:cNvPicPr>
@@ -2904,8 +3747,8 @@
         </p:blipFill>
         <p:spPr>
           <a:xfrm>
-            <a:off x="10136505" y="2064639"/>
-            <a:ext cx="891540" cy="891540"/>
+            <a:off x="8553450" y="4086225"/>
+            <a:ext cx="342900" cy="342900"/>
           </a:xfrm>
           <a:prstGeom prst="rect">
             <a:avLst/>
@@ -2914,32 +3757,72 @@
       </p:pic>
       <p:sp>
         <p:nvSpPr>
-          <p:cNvPr id="38" name="TextBox 38"/>
-          <p:cNvSpPr txBox="1"/>
-          <p:nvPr/>
-        </p:nvSpPr>
-        <p:spPr>
-          <a:xfrm>
-            <a:off x="9335643" y="3094736"/>
-            <a:ext cx="2460117" cy="322707"/>
-          </a:xfrm>
-          <a:prstGeom prst="rect">
-            <a:avLst/>
-          </a:prstGeom>
-          <a:noFill/>
-          <a:ln>
-            <a:noFill/>
-          </a:ln>
-        </p:spPr>
-        <p:txBody>
-          <a:bodyPr wrap="none" lIns="0" tIns="0" rIns="0" bIns="0" anchor="t" anchorCtr="0">
-            <a:spAutoFit/>
-          </a:bodyPr>
-          <a:lstStyle/>
-          <a:p>
-            <a:pPr algn="l"/>
-            <a:r>
-              <a:rPr lang="zh-TW" sz="1650" dirty="0">
+          <p:cNvPr id="61" name="TextBox 61"/>
+          <p:cNvSpPr txBox="1"/>
+          <p:nvPr/>
+        </p:nvSpPr>
+        <p:spPr>
+          <a:xfrm>
+            <a:off x="8982456" y="4127500"/>
+            <a:ext cx="1930767" cy="352044"/>
+          </a:xfrm>
+          <a:prstGeom prst="rect">
+            <a:avLst/>
+          </a:prstGeom>
+          <a:noFill/>
+          <a:ln>
+            <a:noFill/>
+          </a:ln>
+        </p:spPr>
+        <p:txBody>
+          <a:bodyPr wrap="none" lIns="0" tIns="0" rIns="0" bIns="0" anchor="t" anchorCtr="0">
+            <a:spAutoFit/>
+          </a:bodyPr>
+          <a:lstStyle/>
+          <a:p>
+            <a:pPr algn="l"/>
+            <a:r>
+              <a:rPr lang="zh-TW" sz="1800" b="1" dirty="0">
+                <a:solidFill>
+                  <a:schemeClr val="accent1"/>
+                </a:solidFill>
+                <a:latin typeface="Microsoft JhengHei"/>
+                <a:ea typeface="Microsoft JhengHei"/>
+                <a:cs typeface="Microsoft JhengHei"/>
+              </a:rPr>
+              <a:t>d 受控處置與回復</a:t>
+            </a:r>
+          </a:p>
+        </p:txBody>
+      </p:sp>
+      <p:sp>
+        <p:nvSpPr>
+          <p:cNvPr id="62" name="TextBox 62"/>
+          <p:cNvSpPr txBox="1"/>
+          <p:nvPr/>
+        </p:nvSpPr>
+        <p:spPr>
+          <a:xfrm>
+            <a:off x="8601456" y="4603750"/>
+            <a:ext cx="1750847" cy="352044"/>
+          </a:xfrm>
+          <a:prstGeom prst="rect">
+            <a:avLst/>
+          </a:prstGeom>
+          <a:noFill/>
+          <a:ln>
+            <a:noFill/>
+          </a:ln>
+        </p:spPr>
+        <p:txBody>
+          <a:bodyPr wrap="none" lIns="0" tIns="0" rIns="0" bIns="0" anchor="t" anchorCtr="0">
+            <a:spAutoFit/>
+          </a:bodyPr>
+          <a:lstStyle/>
+          <a:p>
+            <a:pPr algn="l"/>
+            <a:r>
+              <a:rPr lang="zh-TW" sz="1800" dirty="0">
                 <a:solidFill>
                   <a:schemeClr val="dk1"/>
                 </a:solidFill>
@@ -2947,39 +3830,39 @@
                 <a:ea typeface="Microsoft JhengHei"/>
                 <a:cs typeface="Microsoft JhengHei"/>
               </a:rPr>
-              <a:t>策略閘門檢查範圍與期限</a:t>
-            </a:r>
-          </a:p>
-        </p:txBody>
-      </p:sp>
-      <p:sp>
-        <p:nvSpPr>
-          <p:cNvPr id="39" name="TextBox 39"/>
-          <p:cNvSpPr txBox="1"/>
-          <p:nvPr/>
-        </p:nvSpPr>
-        <p:spPr>
-          <a:xfrm>
-            <a:off x="9335643" y="3391916"/>
-            <a:ext cx="2304631" cy="322707"/>
-          </a:xfrm>
-          <a:prstGeom prst="rect">
-            <a:avLst/>
-          </a:prstGeom>
-          <a:noFill/>
-          <a:ln>
-            <a:noFill/>
-          </a:ln>
-        </p:spPr>
-        <p:txBody>
-          <a:bodyPr wrap="none" lIns="0" tIns="0" rIns="0" bIns="0" anchor="t" anchorCtr="0">
-            <a:spAutoFit/>
-          </a:bodyPr>
-          <a:lstStyle/>
-          <a:p>
-            <a:pPr algn="l"/>
-            <a:r>
-              <a:rPr lang="zh-TW" sz="1650" dirty="0">
+              <a:t>策略檢查 → 套用</a:t>
+            </a:r>
+          </a:p>
+        </p:txBody>
+      </p:sp>
+      <p:sp>
+        <p:nvSpPr>
+          <p:cNvPr id="63" name="TextBox 63"/>
+          <p:cNvSpPr txBox="1"/>
+          <p:nvPr/>
+        </p:nvSpPr>
+        <p:spPr>
+          <a:xfrm>
+            <a:off x="8601456" y="4956175"/>
+            <a:ext cx="1750847" cy="352044"/>
+          </a:xfrm>
+          <a:prstGeom prst="rect">
+            <a:avLst/>
+          </a:prstGeom>
+          <a:noFill/>
+          <a:ln>
+            <a:noFill/>
+          </a:ln>
+        </p:spPr>
+        <p:txBody>
+          <a:bodyPr wrap="none" lIns="0" tIns="0" rIns="0" bIns="0" anchor="t" anchorCtr="0">
+            <a:spAutoFit/>
+          </a:bodyPr>
+          <a:lstStyle/>
+          <a:p>
+            <a:pPr algn="l"/>
+            <a:r>
+              <a:rPr lang="zh-TW" sz="1800" dirty="0">
                 <a:solidFill>
                   <a:schemeClr val="dk1"/>
                 </a:solidFill>
@@ -2987,125 +3870,61 @@
                 <a:ea typeface="Microsoft JhengHei"/>
                 <a:cs typeface="Microsoft JhengHei"/>
               </a:rPr>
-              <a:t>套用 → 讀回 → 到期撤銷</a:t>
-            </a:r>
-          </a:p>
-        </p:txBody>
-      </p:sp>
-      <p:sp>
-        <p:nvSpPr>
-          <p:cNvPr id="40" name="Rectangle 40"/>
+              <a:t>讀回 → 到期撤銷</a:t>
+            </a:r>
+          </a:p>
+        </p:txBody>
+      </p:sp>
+      <p:sp>
+        <p:nvSpPr>
+          <p:cNvPr id="64" name="TextBox 64"/>
+          <p:cNvSpPr txBox="1"/>
+          <p:nvPr/>
+        </p:nvSpPr>
+        <p:spPr>
+          <a:xfrm>
+            <a:off x="8602980" y="5457825"/>
+            <a:ext cx="1862900" cy="293370"/>
+          </a:xfrm>
+          <a:prstGeom prst="rect">
+            <a:avLst/>
+          </a:prstGeom>
+          <a:noFill/>
+          <a:ln>
+            <a:noFill/>
+          </a:ln>
+        </p:spPr>
+        <p:txBody>
+          <a:bodyPr wrap="none" lIns="0" tIns="0" rIns="0" bIns="0" anchor="t" anchorCtr="0">
+            <a:spAutoFit/>
+          </a:bodyPr>
+          <a:lstStyle/>
+          <a:p>
+            <a:pPr algn="l"/>
+            <a:r>
+              <a:rPr lang="zh-TW" sz="1500" dirty="0">
+                <a:solidFill>
+                  <a:schemeClr val="accent5"/>
+                </a:solidFill>
+                <a:latin typeface="Microsoft JhengHei"/>
+                <a:ea typeface="Microsoft JhengHei"/>
+                <a:cs typeface="Microsoft JhengHei"/>
+              </a:rPr>
+              <a:t>複核／不確定 → 蒐證</a:t>
+            </a:r>
+          </a:p>
+        </p:txBody>
+      </p:sp>
+      <p:sp>
+        <p:nvSpPr>
+          <p:cNvPr id="65" name="Freeform 65"/>
           <p:cNvSpPr/>
           <p:nvPr/>
         </p:nvSpPr>
         <p:spPr>
           <a:xfrm>
-            <a:off x="9324975" y="3862578"/>
-            <a:ext cx="2543175" cy="1188720"/>
-          </a:xfrm>
-          <a:prstGeom prst="roundRect">
-            <a:avLst>
-              <a:gd name="adj" fmla="val 6410"/>
-            </a:avLst>
-          </a:prstGeom>
-          <a:solidFill>
-            <a:schemeClr val="lt1"/>
-          </a:solidFill>
-          <a:ln>
-            <a:noFill/>
-          </a:ln>
-        </p:spPr>
-      </p:sp>
-      <p:sp>
-        <p:nvSpPr>
-          <p:cNvPr id="41" name="TextBox 41"/>
-          <p:cNvSpPr txBox="1"/>
-          <p:nvPr/>
-        </p:nvSpPr>
-        <p:spPr>
-          <a:xfrm>
-            <a:off x="9422130" y="3998976"/>
-            <a:ext cx="2034540" cy="293370"/>
-          </a:xfrm>
-          <a:prstGeom prst="rect">
-            <a:avLst/>
-          </a:prstGeom>
-          <a:noFill/>
-          <a:ln>
-            <a:noFill/>
-          </a:ln>
-        </p:spPr>
-        <p:txBody>
-          <a:bodyPr wrap="none" lIns="0" tIns="0" rIns="0" bIns="0" anchor="t" anchorCtr="0">
-            <a:spAutoFit/>
-          </a:bodyPr>
-          <a:lstStyle/>
-          <a:p>
-            <a:pPr algn="l"/>
-            <a:r>
-              <a:rPr lang="zh-TW" sz="1500" dirty="0">
-                <a:solidFill>
-                  <a:schemeClr val="dk1"/>
-                </a:solidFill>
-                <a:latin typeface="Microsoft JhengHei"/>
-                <a:ea typeface="Microsoft JhengHei"/>
-                <a:cs typeface="Microsoft JhengHei"/>
-              </a:rPr>
-              <a:t>輸出：處置與回復回條</a:t>
-            </a:r>
-          </a:p>
-        </p:txBody>
-      </p:sp>
-      <p:sp>
-        <p:nvSpPr>
-          <p:cNvPr id="42" name="TextBox 42"/>
-          <p:cNvSpPr txBox="1"/>
-          <p:nvPr/>
-        </p:nvSpPr>
-        <p:spPr>
-          <a:xfrm>
-            <a:off x="9422130" y="4355592"/>
-            <a:ext cx="1630680" cy="293370"/>
-          </a:xfrm>
-          <a:prstGeom prst="rect">
-            <a:avLst/>
-          </a:prstGeom>
-          <a:noFill/>
-          <a:ln>
-            <a:noFill/>
-          </a:ln>
-        </p:spPr>
-        <p:txBody>
-          <a:bodyPr wrap="none" lIns="0" tIns="0" rIns="0" bIns="0" anchor="t" anchorCtr="0">
-            <a:spAutoFit/>
-          </a:bodyPr>
-          <a:lstStyle/>
-          <a:p>
-            <a:pPr algn="l"/>
-            <a:r>
-              <a:rPr lang="zh-TW" sz="1500" dirty="0">
-                <a:solidFill>
-                  <a:schemeClr val="dk1"/>
-                </a:solidFill>
-                <a:latin typeface="Microsoft JhengHei"/>
-                <a:ea typeface="Microsoft JhengHei"/>
-                <a:cs typeface="Microsoft JhengHei"/>
-              </a:rPr>
-              <a:t>複核事件保留蒐證</a:t>
-            </a:r>
-          </a:p>
-        </p:txBody>
-      </p:sp>
-      <p:sp>
-        <p:nvSpPr>
-          <p:cNvPr id="43" name="Freeform 43"/>
-          <p:cNvSpPr/>
-          <p:nvPr/>
-        </p:nvSpPr>
-        <p:spPr>
-          <a:xfrm>
-            <a:off x="1571625" y="5333619"/>
-            <a:ext cx="9001125" cy="289750"/>
+            <a:off x="7924800" y="4981575"/>
+            <a:ext cx="457200" cy="9525"/>
           </a:xfrm>
           <a:custGeom>
             <a:avLst/>
@@ -3114,18 +3933,12 @@
             <a:cxnLst/>
             <a:rect l="l" t="t" r="r" b="b"/>
             <a:pathLst>
-              <a:path w="9001125" h="289750">
+              <a:path w="457200" h="9525">
                 <a:moveTo>
-                  <a:pt x="9001125" y="0"/>
+                  <a:pt x="0" y="0"/>
                 </a:moveTo>
                 <a:lnTo>
-                  <a:pt x="9001125" y="289750"/>
-                </a:lnTo>
-                <a:lnTo>
-                  <a:pt x="0" y="289750"/>
-                </a:lnTo>
-                <a:lnTo>
-                  <a:pt x="0" y="0"/>
+                  <a:pt x="457200" y="0"/>
                 </a:lnTo>
               </a:path>
             </a:pathLst>
@@ -3133,24 +3946,86 @@
           <a:noFill/>
           <a:ln w="19050">
             <a:solidFill>
-              <a:srgbClr val="6B6B6B"/>
+              <a:schemeClr val="accent1"/>
             </a:solidFill>
-            <a:custDash>
-              <a:ds d="350000" sp="250000"/>
-            </a:custDash>
-          </a:ln>
-        </p:spPr>
-      </p:sp>
-      <p:sp>
-        <p:nvSpPr>
-          <p:cNvPr id="44" name="TextBox 44"/>
-          <p:cNvSpPr txBox="1"/>
-          <p:nvPr/>
-        </p:nvSpPr>
-        <p:spPr>
-          <a:xfrm>
-            <a:off x="3807295" y="5687632"/>
-            <a:ext cx="4577410" cy="322707"/>
+          </a:ln>
+        </p:spPr>
+      </p:sp>
+      <p:sp>
+        <p:nvSpPr>
+          <p:cNvPr id="66" name="Freeform 66"/>
+          <p:cNvSpPr/>
+          <p:nvPr/>
+        </p:nvSpPr>
+        <p:spPr>
+          <a:xfrm>
+            <a:off x="8315325" y="4933950"/>
+            <a:ext cx="66675" cy="95250"/>
+          </a:xfrm>
+          <a:custGeom>
+            <a:avLst/>
+            <a:gdLst/>
+            <a:ahLst/>
+            <a:cxnLst/>
+            <a:rect l="l" t="t" r="r" b="b"/>
+            <a:pathLst>
+              <a:path w="66675" h="95250">
+                <a:moveTo>
+                  <a:pt x="0" y="0"/>
+                </a:moveTo>
+                <a:lnTo>
+                  <a:pt x="66675" y="47625"/>
+                </a:lnTo>
+                <a:lnTo>
+                  <a:pt x="0" y="95250"/>
+                </a:lnTo>
+              </a:path>
+            </a:pathLst>
+          </a:custGeom>
+          <a:noFill/>
+          <a:ln w="19050">
+            <a:solidFill>
+              <a:schemeClr val="accent1"/>
+            </a:solidFill>
+          </a:ln>
+        </p:spPr>
+      </p:sp>
+      <p:sp>
+        <p:nvSpPr>
+          <p:cNvPr id="67" name="Rectangle 67"/>
+          <p:cNvSpPr/>
+          <p:nvPr/>
+        </p:nvSpPr>
+        <p:spPr>
+          <a:xfrm>
+            <a:off x="152400" y="5962650"/>
+            <a:ext cx="11887200" cy="361950"/>
+          </a:xfrm>
+          <a:prstGeom prst="roundRect">
+            <a:avLst>
+              <a:gd name="adj" fmla="val 21053"/>
+            </a:avLst>
+          </a:prstGeom>
+          <a:solidFill>
+            <a:srgbClr val="F5F7FA"/>
+          </a:solidFill>
+          <a:ln w="9525">
+            <a:solidFill>
+              <a:schemeClr val="accent6"/>
+            </a:solidFill>
+          </a:ln>
+        </p:spPr>
+      </p:sp>
+      <p:sp>
+        <p:nvSpPr>
+          <p:cNvPr id="68" name="TextBox 68"/>
+          <p:cNvSpPr txBox="1"/>
+          <p:nvPr/>
+        </p:nvSpPr>
+        <p:spPr>
+          <a:xfrm>
+            <a:off x="2918174" y="6007100"/>
+            <a:ext cx="6355652" cy="322707"/>
           </a:xfrm>
           <a:prstGeom prst="rect">
             <a:avLst/>
@@ -3176,14 +4051,14 @@
                 <a:ea typeface="Microsoft JhengHei"/>
                 <a:cs typeface="Microsoft JhengHei"/>
               </a:rPr>
-              <a:t>同一事件 ID 串接偵測、證據、稽核與處置回條</a:t>
-            </a:r>
-          </a:p>
-        </p:txBody>
-      </p:sp>
-      <p:sp>
-        <p:nvSpPr>
-          <p:cNvPr id="45" name="TextBox 45"/>
+              <a:t>共用事件 ID：正式判定｜Top-5 證據｜AI 稽核｜處置與回復回條</a:t>
+            </a:r>
+          </a:p>
+        </p:txBody>
+      </p:sp>
+      <p:sp>
+        <p:nvSpPr>
+          <p:cNvPr id="69" name="TextBox 69"/>
           <p:cNvSpPr txBox="1"/>
           <p:nvPr/>
         </p:nvSpPr>
@@ -3223,7 +4098,7 @@
       </p:sp>
       <p:sp>
         <p:nvSpPr>
-          <p:cNvPr id="46" name="TextBox 46"/>
+          <p:cNvPr id="70" name="TextBox 70"/>
           <p:cNvSpPr txBox="1"/>
           <p:nvPr/>
         </p:nvSpPr>
@@ -3326,7 +4201,7 @@
             <a:r>
               <a:rPr lang="en-US" sz="1200" b="1" dirty="0">
                 <a:solidFill>
-                  <a:schemeClr val="accent1"/>
+                  <a:schemeClr val="accent2"/>
                 </a:solidFill>
                 <a:latin typeface="Microsoft JhengHei"/>
                 <a:ea typeface="Microsoft JhengHei"/>
@@ -3377,9 +4252,33 @@
           </a:p>
         </p:txBody>
       </p:sp>
+      <p:sp>
+        <p:nvSpPr>
+          <p:cNvPr id="4" name="Rectangle 4"/>
+          <p:cNvSpPr/>
+          <p:nvPr/>
+        </p:nvSpPr>
+        <p:spPr>
+          <a:xfrm>
+            <a:off x="609600" y="2095500"/>
+            <a:ext cx="2000250" cy="2095500"/>
+          </a:xfrm>
+          <a:prstGeom prst="roundRect">
+            <a:avLst>
+              <a:gd name="adj" fmla="val 3810"/>
+            </a:avLst>
+          </a:prstGeom>
+          <a:solidFill>
+            <a:schemeClr val="accent3"/>
+          </a:solidFill>
+          <a:ln>
+            <a:noFill/>
+          </a:ln>
+        </p:spPr>
+      </p:sp>
       <p:pic>
         <p:nvPicPr>
-          <p:cNvPr id="4" name="Image 4"/>
+          <p:cNvPr id="5" name="Image 5"/>
           <p:cNvPicPr>
             <a:picLocks noChangeAspect="1"/>
           </p:cNvPicPr>
@@ -3393,8 +4292,8 @@
         </p:blipFill>
         <p:spPr>
           <a:xfrm>
-            <a:off x="1276350" y="1714500"/>
-            <a:ext cx="1905000" cy="1905000"/>
+            <a:off x="1085850" y="2257425"/>
+            <a:ext cx="1047750" cy="1047750"/>
           </a:xfrm>
           <a:prstGeom prst="rect">
             <a:avLst/>
@@ -3403,14 +4302,415 @@
       </p:pic>
       <p:sp>
         <p:nvSpPr>
-          <p:cNvPr id="5" name="TextBox 5"/>
-          <p:cNvSpPr txBox="1"/>
-          <p:nvPr/>
-        </p:nvSpPr>
-        <p:spPr>
-          <a:xfrm>
-            <a:off x="598170" y="3911600"/>
-            <a:ext cx="1537335" cy="440055"/>
+          <p:cNvPr id="6" name="TextBox 6"/>
+          <p:cNvSpPr txBox="1"/>
+          <p:nvPr/>
+        </p:nvSpPr>
+        <p:spPr>
+          <a:xfrm>
+            <a:off x="895731" y="3546475"/>
+            <a:ext cx="1472184" cy="352044"/>
+          </a:xfrm>
+          <a:prstGeom prst="rect">
+            <a:avLst/>
+          </a:prstGeom>
+          <a:noFill/>
+          <a:ln>
+            <a:noFill/>
+          </a:ln>
+        </p:spPr>
+        <p:txBody>
+          <a:bodyPr wrap="none" lIns="0" tIns="0" rIns="0" bIns="0" anchor="t" anchorCtr="0">
+            <a:spAutoFit/>
+          </a:bodyPr>
+          <a:lstStyle/>
+          <a:p>
+            <a:pPr algn="l"/>
+            <a:r>
+              <a:rPr lang="zh-TW" sz="1800" dirty="0">
+                <a:solidFill>
+                  <a:srgbClr val="FFFFFF"/>
+                </a:solidFill>
+                <a:latin typeface="Microsoft JhengHei"/>
+                <a:ea typeface="Microsoft JhengHei"/>
+                <a:cs typeface="Microsoft JhengHei"/>
+              </a:rPr>
+              <a:t>同一流量輸入</a:t>
+            </a:r>
+          </a:p>
+        </p:txBody>
+      </p:sp>
+      <p:sp>
+        <p:nvSpPr>
+          <p:cNvPr id="7" name="Rectangle 7"/>
+          <p:cNvSpPr/>
+          <p:nvPr/>
+        </p:nvSpPr>
+        <p:spPr>
+          <a:xfrm>
+            <a:off x="3524250" y="1809750"/>
+            <a:ext cx="3238500" cy="1238250"/>
+          </a:xfrm>
+          <a:prstGeom prst="roundRect">
+            <a:avLst>
+              <a:gd name="adj" fmla="val 6154"/>
+            </a:avLst>
+          </a:prstGeom>
+          <a:solidFill>
+            <a:schemeClr val="accent3"/>
+          </a:solidFill>
+          <a:ln>
+            <a:noFill/>
+          </a:ln>
+        </p:spPr>
+      </p:sp>
+      <p:sp>
+        <p:nvSpPr>
+          <p:cNvPr id="8" name="TextBox 8"/>
+          <p:cNvSpPr txBox="1"/>
+          <p:nvPr/>
+        </p:nvSpPr>
+        <p:spPr>
+          <a:xfrm>
+            <a:off x="3779520" y="1958975"/>
+            <a:ext cx="829361" cy="440055"/>
+          </a:xfrm>
+          <a:prstGeom prst="rect">
+            <a:avLst/>
+          </a:prstGeom>
+          <a:noFill/>
+          <a:ln>
+            <a:noFill/>
+          </a:ln>
+        </p:spPr>
+        <p:txBody>
+          <a:bodyPr wrap="none" lIns="0" tIns="0" rIns="0" bIns="0" anchor="t" anchorCtr="0">
+            <a:spAutoFit/>
+          </a:bodyPr>
+          <a:lstStyle/>
+          <a:p>
+            <a:pPr algn="l"/>
+            <a:r>
+              <a:rPr lang="en-US" sz="2250" b="1" dirty="0">
+                <a:solidFill>
+                  <a:srgbClr val="FFFFFF"/>
+                </a:solidFill>
+                <a:latin typeface="Microsoft JhengHei"/>
+                <a:ea typeface="Microsoft JhengHei"/>
+                <a:cs typeface="Microsoft JhengHei"/>
+              </a:rPr>
+              <a:t>CTBM</a:t>
+            </a:r>
+          </a:p>
+        </p:txBody>
+      </p:sp>
+      <p:sp>
+        <p:nvSpPr>
+          <p:cNvPr id="9" name="TextBox 9"/>
+          <p:cNvSpPr txBox="1"/>
+          <p:nvPr/>
+        </p:nvSpPr>
+        <p:spPr>
+          <a:xfrm>
+            <a:off x="3781806" y="2470150"/>
+            <a:ext cx="2199132" cy="352044"/>
+          </a:xfrm>
+          <a:prstGeom prst="rect">
+            <a:avLst/>
+          </a:prstGeom>
+          <a:noFill/>
+          <a:ln>
+            <a:noFill/>
+          </a:ln>
+        </p:spPr>
+        <p:txBody>
+          <a:bodyPr wrap="none" lIns="0" tIns="0" rIns="0" bIns="0" anchor="t" anchorCtr="0">
+            <a:spAutoFit/>
+          </a:bodyPr>
+          <a:lstStyle/>
+          <a:p>
+            <a:pPr algn="l"/>
+            <a:r>
+              <a:rPr lang="ja-JP" sz="1800" dirty="0">
+                <a:solidFill>
+                  <a:schemeClr val="accent6"/>
+                </a:solidFill>
+                <a:latin typeface="Microsoft JhengHei"/>
+                <a:ea typeface="Microsoft JhengHei"/>
+                <a:cs typeface="Microsoft JhengHei"/>
+              </a:rPr>
+              <a:t>內容・時間差・方向</a:t>
+            </a:r>
+          </a:p>
+        </p:txBody>
+      </p:sp>
+      <p:sp>
+        <p:nvSpPr>
+          <p:cNvPr id="10" name="Rectangle 10"/>
+          <p:cNvSpPr/>
+          <p:nvPr/>
+        </p:nvSpPr>
+        <p:spPr>
+          <a:xfrm>
+            <a:off x="3524250" y="3524250"/>
+            <a:ext cx="3238500" cy="1238250"/>
+          </a:xfrm>
+          <a:prstGeom prst="roundRect">
+            <a:avLst>
+              <a:gd name="adj" fmla="val 6154"/>
+            </a:avLst>
+          </a:prstGeom>
+          <a:solidFill>
+            <a:schemeClr val="accent3"/>
+          </a:solidFill>
+          <a:ln>
+            <a:noFill/>
+          </a:ln>
+        </p:spPr>
+      </p:sp>
+      <p:sp>
+        <p:nvSpPr>
+          <p:cNvPr id="11" name="TextBox 11"/>
+          <p:cNvSpPr txBox="1"/>
+          <p:nvPr/>
+        </p:nvSpPr>
+        <p:spPr>
+          <a:xfrm>
+            <a:off x="3779520" y="3673475"/>
+            <a:ext cx="946976" cy="440055"/>
+          </a:xfrm>
+          <a:prstGeom prst="rect">
+            <a:avLst/>
+          </a:prstGeom>
+          <a:noFill/>
+          <a:ln>
+            <a:noFill/>
+          </a:ln>
+        </p:spPr>
+        <p:txBody>
+          <a:bodyPr wrap="none" lIns="0" tIns="0" rIns="0" bIns="0" anchor="t" anchorCtr="0">
+            <a:spAutoFit/>
+          </a:bodyPr>
+          <a:lstStyle/>
+          <a:p>
+            <a:pPr algn="l"/>
+            <a:r>
+              <a:rPr lang="en-US" sz="2250" b="1" dirty="0">
+                <a:solidFill>
+                  <a:srgbClr val="FFFFFF"/>
+                </a:solidFill>
+                <a:latin typeface="Microsoft JhengHei"/>
+                <a:ea typeface="Microsoft JhengHei"/>
+                <a:cs typeface="Microsoft JhengHei"/>
+              </a:rPr>
+              <a:t>PBCNN</a:t>
+            </a:r>
+          </a:p>
+        </p:txBody>
+      </p:sp>
+      <p:sp>
+        <p:nvSpPr>
+          <p:cNvPr id="12" name="TextBox 12"/>
+          <p:cNvSpPr txBox="1"/>
+          <p:nvPr/>
+        </p:nvSpPr>
+        <p:spPr>
+          <a:xfrm>
+            <a:off x="3781806" y="4184650"/>
+            <a:ext cx="1714500" cy="352044"/>
+          </a:xfrm>
+          <a:prstGeom prst="rect">
+            <a:avLst/>
+          </a:prstGeom>
+          <a:noFill/>
+          <a:ln>
+            <a:noFill/>
+          </a:ln>
+        </p:spPr>
+        <p:txBody>
+          <a:bodyPr wrap="none" lIns="0" tIns="0" rIns="0" bIns="0" anchor="t" anchorCtr="0">
+            <a:spAutoFit/>
+          </a:bodyPr>
+          <a:lstStyle/>
+          <a:p>
+            <a:pPr algn="l"/>
+            <a:r>
+              <a:rPr lang="zh-TW" sz="1800" dirty="0">
+                <a:solidFill>
+                  <a:schemeClr val="accent6"/>
+                </a:solidFill>
+                <a:latin typeface="Microsoft JhengHei"/>
+                <a:ea typeface="Microsoft JhengHei"/>
+                <a:cs typeface="Microsoft JhengHei"/>
+              </a:rPr>
+              <a:t>短窗位元組模式</a:t>
+            </a:r>
+          </a:p>
+        </p:txBody>
+      </p:sp>
+      <p:sp>
+        <p:nvSpPr>
+          <p:cNvPr id="13" name="Freeform 13"/>
+          <p:cNvSpPr/>
+          <p:nvPr/>
+        </p:nvSpPr>
+        <p:spPr>
+          <a:xfrm>
+            <a:off x="2609850" y="2428875"/>
+            <a:ext cx="5676900" cy="1714500"/>
+          </a:xfrm>
+          <a:custGeom>
+            <a:avLst/>
+            <a:gdLst/>
+            <a:ahLst/>
+            <a:cxnLst/>
+            <a:rect l="l" t="t" r="r" b="b"/>
+            <a:pathLst>
+              <a:path w="5676900" h="1714500">
+                <a:moveTo>
+                  <a:pt x="0" y="714375"/>
+                </a:moveTo>
+                <a:lnTo>
+                  <a:pt x="457200" y="714375"/>
+                </a:lnTo>
+                <a:lnTo>
+                  <a:pt x="457200" y="0"/>
+                </a:lnTo>
+                <a:lnTo>
+                  <a:pt x="914400" y="0"/>
+                </a:lnTo>
+                <a:moveTo>
+                  <a:pt x="457200" y="714375"/>
+                </a:moveTo>
+                <a:lnTo>
+                  <a:pt x="457200" y="1714500"/>
+                </a:lnTo>
+                <a:lnTo>
+                  <a:pt x="914400" y="1714500"/>
+                </a:lnTo>
+                <a:moveTo>
+                  <a:pt x="4152900" y="0"/>
+                </a:moveTo>
+                <a:lnTo>
+                  <a:pt x="4819650" y="0"/>
+                </a:lnTo>
+                <a:lnTo>
+                  <a:pt x="4819650" y="857250"/>
+                </a:lnTo>
+                <a:lnTo>
+                  <a:pt x="5676900" y="857250"/>
+                </a:lnTo>
+                <a:moveTo>
+                  <a:pt x="4152900" y="1714500"/>
+                </a:moveTo>
+                <a:lnTo>
+                  <a:pt x="4819650" y="1714500"/>
+                </a:lnTo>
+                <a:lnTo>
+                  <a:pt x="4819650" y="857250"/>
+                </a:lnTo>
+              </a:path>
+            </a:pathLst>
+          </a:custGeom>
+          <a:noFill/>
+          <a:ln w="28575">
+            <a:solidFill>
+              <a:schemeClr val="accent2"/>
+            </a:solidFill>
+          </a:ln>
+        </p:spPr>
+      </p:sp>
+      <p:sp>
+        <p:nvSpPr>
+          <p:cNvPr id="14" name="Freeform 14"/>
+          <p:cNvSpPr/>
+          <p:nvPr/>
+        </p:nvSpPr>
+        <p:spPr>
+          <a:xfrm>
+            <a:off x="3467100" y="2371725"/>
+            <a:ext cx="4819650" cy="1828800"/>
+          </a:xfrm>
+          <a:custGeom>
+            <a:avLst/>
+            <a:gdLst/>
+            <a:ahLst/>
+            <a:cxnLst/>
+            <a:rect l="l" t="t" r="r" b="b"/>
+            <a:pathLst>
+              <a:path w="4819650" h="1828800">
+                <a:moveTo>
+                  <a:pt x="0" y="0"/>
+                </a:moveTo>
+                <a:lnTo>
+                  <a:pt x="57150" y="57150"/>
+                </a:lnTo>
+                <a:lnTo>
+                  <a:pt x="0" y="114300"/>
+                </a:lnTo>
+                <a:moveTo>
+                  <a:pt x="0" y="1714500"/>
+                </a:moveTo>
+                <a:lnTo>
+                  <a:pt x="57150" y="1771650"/>
+                </a:lnTo>
+                <a:lnTo>
+                  <a:pt x="0" y="1828800"/>
+                </a:lnTo>
+                <a:moveTo>
+                  <a:pt x="4762500" y="857250"/>
+                </a:moveTo>
+                <a:lnTo>
+                  <a:pt x="4819650" y="914400"/>
+                </a:lnTo>
+                <a:lnTo>
+                  <a:pt x="4762500" y="971550"/>
+                </a:lnTo>
+              </a:path>
+            </a:pathLst>
+          </a:custGeom>
+          <a:noFill/>
+          <a:ln w="28575">
+            <a:solidFill>
+              <a:schemeClr val="accent2"/>
+            </a:solidFill>
+          </a:ln>
+        </p:spPr>
+      </p:sp>
+      <p:sp>
+        <p:nvSpPr>
+          <p:cNvPr id="15" name="Rectangle 15"/>
+          <p:cNvSpPr/>
+          <p:nvPr/>
+        </p:nvSpPr>
+        <p:spPr>
+          <a:xfrm>
+            <a:off x="8286750" y="2571750"/>
+            <a:ext cx="3295650" cy="1428750"/>
+          </a:xfrm>
+          <a:prstGeom prst="roundRect">
+            <a:avLst>
+              <a:gd name="adj" fmla="val 5333"/>
+            </a:avLst>
+          </a:prstGeom>
+          <a:solidFill>
+            <a:schemeClr val="accent3"/>
+          </a:solidFill>
+          <a:ln>
+            <a:noFill/>
+          </a:ln>
+        </p:spPr>
+      </p:sp>
+      <p:sp>
+        <p:nvSpPr>
+          <p:cNvPr id="16" name="TextBox 16"/>
+          <p:cNvSpPr txBox="1"/>
+          <p:nvPr/>
+        </p:nvSpPr>
+        <p:spPr>
+          <a:xfrm>
+            <a:off x="8522970" y="2787650"/>
+            <a:ext cx="2354294" cy="440055"/>
           </a:xfrm>
           <a:prstGeom prst="rect">
             <a:avLst/>
@@ -3436,39 +4736,39 @@
                 <a:ea typeface="Microsoft JhengHei"/>
                 <a:cs typeface="Microsoft JhengHei"/>
               </a:rPr>
-              <a:t>內容與時序</a:t>
-            </a:r>
-          </a:p>
-        </p:txBody>
-      </p:sp>
-      <p:sp>
-        <p:nvSpPr>
-          <p:cNvPr id="6" name="TextBox 6"/>
-          <p:cNvSpPr txBox="1"/>
-          <p:nvPr/>
-        </p:nvSpPr>
-        <p:spPr>
-          <a:xfrm>
-            <a:off x="601980" y="4438650"/>
-            <a:ext cx="2610612" cy="293370"/>
-          </a:xfrm>
-          <a:prstGeom prst="rect">
-            <a:avLst/>
-          </a:prstGeom>
-          <a:noFill/>
-          <a:ln>
-            <a:noFill/>
-          </a:ln>
-        </p:spPr>
-        <p:txBody>
-          <a:bodyPr wrap="none" lIns="0" tIns="0" rIns="0" bIns="0" anchor="t" anchorCtr="0">
-            <a:spAutoFit/>
-          </a:bodyPr>
-          <a:lstStyle/>
-          <a:p>
-            <a:pPr algn="l"/>
-            <a:r>
-              <a:rPr lang="zh-TW" sz="1500" dirty="0">
+              <a:t>校準＋OOF Gate</a:t>
+            </a:r>
+          </a:p>
+        </p:txBody>
+      </p:sp>
+      <p:sp>
+        <p:nvSpPr>
+          <p:cNvPr id="17" name="TextBox 17"/>
+          <p:cNvSpPr txBox="1"/>
+          <p:nvPr/>
+        </p:nvSpPr>
+        <p:spPr>
+          <a:xfrm>
+            <a:off x="8525256" y="3346450"/>
+            <a:ext cx="1714500" cy="352044"/>
+          </a:xfrm>
+          <a:prstGeom prst="rect">
+            <a:avLst/>
+          </a:prstGeom>
+          <a:noFill/>
+          <a:ln>
+            <a:noFill/>
+          </a:ln>
+        </p:spPr>
+        <p:txBody>
+          <a:bodyPr wrap="none" lIns="0" tIns="0" rIns="0" bIns="0" anchor="t" anchorCtr="0">
+            <a:spAutoFit/>
+          </a:bodyPr>
+          <a:lstStyle/>
+          <a:p>
+            <a:pPr algn="l"/>
+            <a:r>
+              <a:rPr lang="zh-TW" sz="1800" dirty="0">
                 <a:solidFill>
                   <a:schemeClr val="accent6"/>
                 </a:solidFill>
@@ -3476,302 +4776,14 @@
                 <a:ea typeface="Microsoft JhengHei"/>
                 <a:cs typeface="Microsoft JhengHei"/>
               </a:rPr>
-              <a:t>CTBM 讀取內容、時間與方向</a:t>
-            </a:r>
-          </a:p>
-        </p:txBody>
-      </p:sp>
-      <p:sp>
-        <p:nvSpPr>
-          <p:cNvPr id="7" name="TextBox 7"/>
-          <p:cNvSpPr txBox="1"/>
-          <p:nvPr/>
-        </p:nvSpPr>
-        <p:spPr>
-          <a:xfrm>
-            <a:off x="3834384" y="2546350"/>
-            <a:ext cx="227343" cy="528066"/>
-          </a:xfrm>
-          <a:prstGeom prst="rect">
-            <a:avLst/>
-          </a:prstGeom>
-          <a:noFill/>
-          <a:ln>
-            <a:noFill/>
-          </a:ln>
-        </p:spPr>
-        <p:txBody>
-          <a:bodyPr wrap="none" lIns="0" tIns="0" rIns="0" bIns="0" anchor="t" anchorCtr="0">
-            <a:spAutoFit/>
-          </a:bodyPr>
-          <a:lstStyle/>
-          <a:p>
-            <a:pPr algn="l"/>
-            <a:r>
-              <a:rPr lang="zh-TW" sz="2700" dirty="0">
-                <a:solidFill>
-                  <a:schemeClr val="accent2"/>
-                </a:solidFill>
-                <a:latin typeface="Microsoft JhengHei"/>
-                <a:ea typeface="Microsoft JhengHei"/>
-                <a:cs typeface="Microsoft JhengHei"/>
-              </a:rPr>
-              <a:t>→</a:t>
-            </a:r>
-          </a:p>
-        </p:txBody>
-      </p:sp>
-      <p:pic>
-        <p:nvPicPr>
-          <p:cNvPr id="8" name="Image 8"/>
-          <p:cNvPicPr>
-            <a:picLocks noChangeAspect="1"/>
-          </p:cNvPicPr>
-          <p:nvPr/>
-        </p:nvPicPr>
-        <p:blipFill>
-          <a:blip r:embed="rId3"/>
-          <a:stretch>
-            <a:fillRect/>
-          </a:stretch>
-        </p:blipFill>
-        <p:spPr>
-          <a:xfrm>
-            <a:off x="5038725" y="1714500"/>
-            <a:ext cx="1905000" cy="1905000"/>
-          </a:xfrm>
-          <a:prstGeom prst="rect">
-            <a:avLst/>
-          </a:prstGeom>
-        </p:spPr>
-      </p:pic>
-      <p:sp>
-        <p:nvSpPr>
-          <p:cNvPr id="9" name="TextBox 9"/>
-          <p:cNvSpPr txBox="1"/>
-          <p:nvPr/>
-        </p:nvSpPr>
-        <p:spPr>
-          <a:xfrm>
-            <a:off x="4360545" y="3911600"/>
-            <a:ext cx="1234440" cy="440055"/>
-          </a:xfrm>
-          <a:prstGeom prst="rect">
-            <a:avLst/>
-          </a:prstGeom>
-          <a:noFill/>
-          <a:ln>
-            <a:noFill/>
-          </a:ln>
-        </p:spPr>
-        <p:txBody>
-          <a:bodyPr wrap="none" lIns="0" tIns="0" rIns="0" bIns="0" anchor="t" anchorCtr="0">
-            <a:spAutoFit/>
-          </a:bodyPr>
-          <a:lstStyle/>
-          <a:p>
-            <a:pPr algn="l"/>
-            <a:r>
-              <a:rPr lang="zh-TW" sz="2250" dirty="0">
-                <a:solidFill>
-                  <a:srgbClr val="FFFFFF"/>
-                </a:solidFill>
-                <a:latin typeface="Microsoft JhengHei"/>
-                <a:ea typeface="Microsoft JhengHei"/>
-                <a:cs typeface="Microsoft JhengHei"/>
-              </a:rPr>
-              <a:t>短窗模式</a:t>
-            </a:r>
-          </a:p>
-        </p:txBody>
-      </p:sp>
-      <p:sp>
-        <p:nvSpPr>
-          <p:cNvPr id="10" name="TextBox 10"/>
-          <p:cNvSpPr txBox="1"/>
-          <p:nvPr/>
-        </p:nvSpPr>
-        <p:spPr>
-          <a:xfrm>
-            <a:off x="4364355" y="4438650"/>
-            <a:ext cx="2483358" cy="293370"/>
-          </a:xfrm>
-          <a:prstGeom prst="rect">
-            <a:avLst/>
-          </a:prstGeom>
-          <a:noFill/>
-          <a:ln>
-            <a:noFill/>
-          </a:ln>
-        </p:spPr>
-        <p:txBody>
-          <a:bodyPr wrap="none" lIns="0" tIns="0" rIns="0" bIns="0" anchor="t" anchorCtr="0">
-            <a:spAutoFit/>
-          </a:bodyPr>
-          <a:lstStyle/>
-          <a:p>
-            <a:pPr algn="l"/>
-            <a:r>
-              <a:rPr lang="zh-TW" sz="1500" dirty="0">
-                <a:solidFill>
-                  <a:schemeClr val="accent6"/>
-                </a:solidFill>
-                <a:latin typeface="Microsoft JhengHei"/>
-                <a:ea typeface="Microsoft JhengHei"/>
-                <a:cs typeface="Microsoft JhengHei"/>
-              </a:rPr>
-              <a:t>PBCNN 補充局部位元組特徵</a:t>
-            </a:r>
-          </a:p>
-        </p:txBody>
-      </p:sp>
-      <p:sp>
-        <p:nvSpPr>
-          <p:cNvPr id="11" name="TextBox 11"/>
-          <p:cNvSpPr txBox="1"/>
-          <p:nvPr/>
-        </p:nvSpPr>
-        <p:spPr>
-          <a:xfrm>
-            <a:off x="7596759" y="2546350"/>
-            <a:ext cx="227343" cy="528066"/>
-          </a:xfrm>
-          <a:prstGeom prst="rect">
-            <a:avLst/>
-          </a:prstGeom>
-          <a:noFill/>
-          <a:ln>
-            <a:noFill/>
-          </a:ln>
-        </p:spPr>
-        <p:txBody>
-          <a:bodyPr wrap="none" lIns="0" tIns="0" rIns="0" bIns="0" anchor="t" anchorCtr="0">
-            <a:spAutoFit/>
-          </a:bodyPr>
-          <a:lstStyle/>
-          <a:p>
-            <a:pPr algn="l"/>
-            <a:r>
-              <a:rPr lang="zh-TW" sz="2700" dirty="0">
-                <a:solidFill>
-                  <a:schemeClr val="accent2"/>
-                </a:solidFill>
-                <a:latin typeface="Microsoft JhengHei"/>
-                <a:ea typeface="Microsoft JhengHei"/>
-                <a:cs typeface="Microsoft JhengHei"/>
-              </a:rPr>
-              <a:t>→</a:t>
-            </a:r>
-          </a:p>
-        </p:txBody>
-      </p:sp>
-      <p:pic>
-        <p:nvPicPr>
-          <p:cNvPr id="12" name="Image 12"/>
-          <p:cNvPicPr>
-            <a:picLocks noChangeAspect="1"/>
-          </p:cNvPicPr>
-          <p:nvPr/>
-        </p:nvPicPr>
-        <p:blipFill>
-          <a:blip r:embed="rId4"/>
-          <a:stretch>
-            <a:fillRect/>
-          </a:stretch>
-        </p:blipFill>
-        <p:spPr>
-          <a:xfrm>
-            <a:off x="8801100" y="1714500"/>
-            <a:ext cx="1905000" cy="1905000"/>
-          </a:xfrm>
-          <a:prstGeom prst="rect">
-            <a:avLst/>
-          </a:prstGeom>
-        </p:spPr>
-      </p:pic>
-      <p:sp>
-        <p:nvSpPr>
-          <p:cNvPr id="13" name="TextBox 13"/>
-          <p:cNvSpPr txBox="1"/>
-          <p:nvPr/>
-        </p:nvSpPr>
-        <p:spPr>
-          <a:xfrm>
-            <a:off x="8122920" y="3911600"/>
-            <a:ext cx="1234440" cy="440055"/>
-          </a:xfrm>
-          <a:prstGeom prst="rect">
-            <a:avLst/>
-          </a:prstGeom>
-          <a:noFill/>
-          <a:ln>
-            <a:noFill/>
-          </a:ln>
-        </p:spPr>
-        <p:txBody>
-          <a:bodyPr wrap="none" lIns="0" tIns="0" rIns="0" bIns="0" anchor="t" anchorCtr="0">
-            <a:spAutoFit/>
-          </a:bodyPr>
-          <a:lstStyle/>
-          <a:p>
-            <a:pPr algn="l"/>
-            <a:r>
-              <a:rPr lang="zh-TW" sz="2250" dirty="0">
-                <a:solidFill>
-                  <a:srgbClr val="FFFFFF"/>
-                </a:solidFill>
-                <a:latin typeface="Microsoft JhengHei"/>
-                <a:ea typeface="Microsoft JhengHei"/>
-                <a:cs typeface="Microsoft JhengHei"/>
-              </a:rPr>
-              <a:t>融合判定</a:t>
-            </a:r>
-          </a:p>
-        </p:txBody>
-      </p:sp>
-      <p:sp>
-        <p:nvSpPr>
-          <p:cNvPr id="14" name="TextBox 14"/>
-          <p:cNvSpPr txBox="1"/>
-          <p:nvPr/>
-        </p:nvSpPr>
-        <p:spPr>
-          <a:xfrm>
-            <a:off x="8126730" y="4438650"/>
-            <a:ext cx="2438400" cy="293370"/>
-          </a:xfrm>
-          <a:prstGeom prst="rect">
-            <a:avLst/>
-          </a:prstGeom>
-          <a:noFill/>
-          <a:ln>
-            <a:noFill/>
-          </a:ln>
-        </p:spPr>
-        <p:txBody>
-          <a:bodyPr wrap="none" lIns="0" tIns="0" rIns="0" bIns="0" anchor="t" anchorCtr="0">
-            <a:spAutoFit/>
-          </a:bodyPr>
-          <a:lstStyle/>
-          <a:p>
-            <a:pPr algn="l"/>
-            <a:r>
-              <a:rPr lang="zh-TW" sz="1500" dirty="0">
-                <a:solidFill>
-                  <a:schemeClr val="accent6"/>
-                </a:solidFill>
-                <a:latin typeface="Microsoft JhengHei"/>
-                <a:ea typeface="Microsoft JhengHei"/>
-                <a:cs typeface="Microsoft JhengHei"/>
-              </a:rPr>
-              <a:t>校準後依事件證據動態調權</a:t>
-            </a:r>
-          </a:p>
-        </p:txBody>
-      </p:sp>
-      <p:sp>
-        <p:nvSpPr>
-          <p:cNvPr id="15" name="Rectangle 15"/>
+              <a:t>依事件證據融合</a:t>
+            </a:r>
+          </a:p>
+        </p:txBody>
+      </p:sp>
+      <p:sp>
+        <p:nvSpPr>
+          <p:cNvPr id="18" name="Rectangle 18"/>
           <p:cNvSpPr/>
           <p:nvPr/>
         </p:nvSpPr>
@@ -3795,7 +4807,7 @@
       </p:sp>
       <p:sp>
         <p:nvSpPr>
-          <p:cNvPr id="16" name="TextBox 16"/>
+          <p:cNvPr id="19" name="TextBox 19"/>
           <p:cNvSpPr txBox="1"/>
           <p:nvPr/>
         </p:nvSpPr>
@@ -3835,7 +4847,7 @@
       </p:sp>
       <p:sp>
         <p:nvSpPr>
-          <p:cNvPr id="17" name="TextBox 17"/>
+          <p:cNvPr id="20" name="TextBox 20"/>
           <p:cNvSpPr txBox="1"/>
           <p:nvPr/>
         </p:nvSpPr>
@@ -3875,7 +4887,7 @@
       </p:sp>
       <p:sp>
         <p:nvSpPr>
-          <p:cNvPr id="18" name="TextBox 18"/>
+          <p:cNvPr id="21" name="TextBox 21"/>
           <p:cNvSpPr txBox="1"/>
           <p:nvPr/>
         </p:nvSpPr>
@@ -4550,7 +5562,7 @@
             <a:r>
               <a:rPr lang="en-US" sz="1200" b="1" dirty="0">
                 <a:solidFill>
-                  <a:schemeClr val="accent1"/>
+                  <a:schemeClr val="accent2"/>
                 </a:solidFill>
                 <a:latin typeface="Microsoft JhengHei"/>
                 <a:ea typeface="Microsoft JhengHei"/>
@@ -5998,7 +7010,7 @@
             <a:r>
               <a:rPr lang="en-US" sz="1200" b="1" dirty="0">
                 <a:solidFill>
-                  <a:schemeClr val="accent1"/>
+                  <a:schemeClr val="accent2"/>
                 </a:solidFill>
                 <a:latin typeface="Microsoft JhengHei"/>
                 <a:ea typeface="Microsoft JhengHei"/>

</xml_diff>

<commit_message>
Deliver light-themed finals media and verify current local model chain
</commit_message>
<xml_diff>
--- a/deliverables/決賽簡報_AI資安框架.pptx
+++ b/deliverables/決賽簡報_AI資安框架.pptx
@@ -1282,7 +1282,7 @@
     <p:bg>
       <p:bgPr>
         <a:solidFill>
-          <a:schemeClr val="lt2"/>
+          <a:schemeClr val="lt1"/>
         </a:solidFill>
         <a:effectLst/>
       </p:bgPr>
@@ -1330,7 +1330,7 @@
             <a:r>
               <a:rPr lang="zh-TW" sz="1350" b="1" dirty="0">
                 <a:solidFill>
-                  <a:schemeClr val="accent2"/>
+                  <a:schemeClr val="accent1"/>
                 </a:solidFill>
                 <a:latin typeface="Microsoft JhengHei"/>
                 <a:ea typeface="Microsoft JhengHei"/>
@@ -1370,7 +1370,7 @@
             <a:r>
               <a:rPr lang="zh-TW" sz="3220" dirty="0">
                 <a:solidFill>
-                  <a:srgbClr val="FFFFFF"/>
+                  <a:srgbClr val="121314"/>
                 </a:solidFill>
                 <a:latin typeface="Microsoft JhengHei"/>
                 <a:ea typeface="Microsoft JhengHei"/>
@@ -1410,7 +1410,7 @@
             <a:r>
               <a:rPr lang="zh-TW" sz="3220" dirty="0">
                 <a:solidFill>
-                  <a:srgbClr val="FFFFFF"/>
+                  <a:srgbClr val="121314"/>
                 </a:solidFill>
                 <a:latin typeface="Microsoft JhengHei"/>
                 <a:ea typeface="Microsoft JhengHei"/>
@@ -1450,7 +1450,7 @@
             <a:r>
               <a:rPr lang="zh-TW" sz="3220" dirty="0">
                 <a:solidFill>
-                  <a:srgbClr val="FFFFFF"/>
+                  <a:srgbClr val="121314"/>
                 </a:solidFill>
                 <a:latin typeface="Microsoft JhengHei"/>
                 <a:ea typeface="Microsoft JhengHei"/>
@@ -1490,7 +1490,7 @@
             <a:r>
               <a:rPr lang="zh-TW" sz="2100" dirty="0">
                 <a:solidFill>
-                  <a:schemeClr val="accent6"/>
+                  <a:schemeClr val="accent5"/>
                 </a:solidFill>
                 <a:latin typeface="Microsoft JhengHei"/>
                 <a:ea typeface="Microsoft JhengHei"/>
@@ -1722,7 +1722,7 @@
             </a:avLst>
           </a:prstGeom>
           <a:solidFill>
-            <a:srgbClr val="F5F7FA"/>
+            <a:schemeClr val="accent3"/>
           </a:solidFill>
           <a:ln w="9525">
             <a:solidFill>
@@ -1972,7 +1972,7 @@
             </a:avLst>
           </a:prstGeom>
           <a:solidFill>
-            <a:srgbClr val="F5F7FA"/>
+            <a:schemeClr val="accent3"/>
           </a:solidFill>
           <a:ln w="9525">
             <a:solidFill>
@@ -2882,7 +2882,7 @@
             </a:avLst>
           </a:prstGeom>
           <a:solidFill>
-            <a:srgbClr val="F5F7FA"/>
+            <a:schemeClr val="accent3"/>
           </a:solidFill>
           <a:ln w="9525">
             <a:solidFill>
@@ -3722,7 +3722,7 @@
             </a:avLst>
           </a:prstGeom>
           <a:solidFill>
-            <a:srgbClr val="F5F7FA"/>
+            <a:schemeClr val="accent3"/>
           </a:solidFill>
           <a:ln w="9525">
             <a:solidFill>
@@ -4007,7 +4007,7 @@
             </a:avLst>
           </a:prstGeom>
           <a:solidFill>
-            <a:srgbClr val="F5F7FA"/>
+            <a:schemeClr val="accent3"/>
           </a:solidFill>
           <a:ln w="9525">
             <a:solidFill>
@@ -4153,7 +4153,7 @@
     <p:bg>
       <p:bgPr>
         <a:solidFill>
-          <a:schemeClr val="lt2"/>
+          <a:schemeClr val="lt1"/>
         </a:solidFill>
         <a:effectLst/>
       </p:bgPr>
@@ -4201,7 +4201,7 @@
             <a:r>
               <a:rPr lang="en-US" sz="1200" b="1" dirty="0">
                 <a:solidFill>
-                  <a:schemeClr val="accent2"/>
+                  <a:schemeClr val="accent1"/>
                 </a:solidFill>
                 <a:latin typeface="Microsoft JhengHei"/>
                 <a:ea typeface="Microsoft JhengHei"/>
@@ -4241,7 +4241,7 @@
             <a:r>
               <a:rPr lang="zh-TW" sz="3300" dirty="0">
                 <a:solidFill>
-                  <a:srgbClr val="FFFFFF"/>
+                  <a:srgbClr val="121314"/>
                 </a:solidFill>
                 <a:latin typeface="Microsoft JhengHei"/>
                 <a:ea typeface="Microsoft JhengHei"/>
@@ -4329,7 +4329,7 @@
             <a:r>
               <a:rPr lang="zh-TW" sz="1800" dirty="0">
                 <a:solidFill>
-                  <a:srgbClr val="FFFFFF"/>
+                  <a:srgbClr val="121314"/>
                 </a:solidFill>
                 <a:latin typeface="Microsoft JhengHei"/>
                 <a:ea typeface="Microsoft JhengHei"/>
@@ -4393,7 +4393,7 @@
             <a:r>
               <a:rPr lang="en-US" sz="2250" b="1" dirty="0">
                 <a:solidFill>
-                  <a:srgbClr val="FFFFFF"/>
+                  <a:srgbClr val="121314"/>
                 </a:solidFill>
                 <a:latin typeface="Microsoft JhengHei"/>
                 <a:ea typeface="Microsoft JhengHei"/>
@@ -4433,7 +4433,7 @@
             <a:r>
               <a:rPr lang="ja-JP" sz="1800" dirty="0">
                 <a:solidFill>
-                  <a:schemeClr val="accent6"/>
+                  <a:schemeClr val="accent5"/>
                 </a:solidFill>
                 <a:latin typeface="Microsoft JhengHei"/>
                 <a:ea typeface="Microsoft JhengHei"/>
@@ -4497,7 +4497,7 @@
             <a:r>
               <a:rPr lang="en-US" sz="2250" b="1" dirty="0">
                 <a:solidFill>
-                  <a:srgbClr val="FFFFFF"/>
+                  <a:srgbClr val="121314"/>
                 </a:solidFill>
                 <a:latin typeface="Microsoft JhengHei"/>
                 <a:ea typeface="Microsoft JhengHei"/>
@@ -4537,7 +4537,7 @@
             <a:r>
               <a:rPr lang="zh-TW" sz="1800" dirty="0">
                 <a:solidFill>
-                  <a:schemeClr val="accent6"/>
+                  <a:schemeClr val="accent5"/>
                 </a:solidFill>
                 <a:latin typeface="Microsoft JhengHei"/>
                 <a:ea typeface="Microsoft JhengHei"/>
@@ -4615,7 +4615,7 @@
           <a:noFill/>
           <a:ln w="28575">
             <a:solidFill>
-              <a:schemeClr val="accent2"/>
+              <a:schemeClr val="accent1"/>
             </a:solidFill>
           </a:ln>
         </p:spPr>
@@ -4672,7 +4672,7 @@
           <a:noFill/>
           <a:ln w="28575">
             <a:solidFill>
-              <a:schemeClr val="accent2"/>
+              <a:schemeClr val="accent1"/>
             </a:solidFill>
           </a:ln>
         </p:spPr>
@@ -4730,7 +4730,7 @@
             <a:r>
               <a:rPr lang="zh-TW" sz="2250" dirty="0">
                 <a:solidFill>
-                  <a:srgbClr val="FFFFFF"/>
+                  <a:srgbClr val="121314"/>
                 </a:solidFill>
                 <a:latin typeface="Microsoft JhengHei"/>
                 <a:ea typeface="Microsoft JhengHei"/>
@@ -4770,7 +4770,7 @@
             <a:r>
               <a:rPr lang="zh-TW" sz="1800" dirty="0">
                 <a:solidFill>
-                  <a:schemeClr val="accent6"/>
+                  <a:schemeClr val="accent5"/>
                 </a:solidFill>
                 <a:latin typeface="Microsoft JhengHei"/>
                 <a:ea typeface="Microsoft JhengHei"/>
@@ -4834,7 +4834,7 @@
             <a:r>
               <a:rPr lang="zh-TW" sz="1800" dirty="0">
                 <a:solidFill>
-                  <a:srgbClr val="FFFFFF"/>
+                  <a:srgbClr val="121314"/>
                 </a:solidFill>
                 <a:latin typeface="Microsoft JhengHei"/>
                 <a:ea typeface="Microsoft JhengHei"/>
@@ -4874,7 +4874,7 @@
             <a:r>
               <a:rPr lang="zh-TW" sz="1050" dirty="0">
                 <a:solidFill>
-                  <a:schemeClr val="accent6"/>
+                  <a:schemeClr val="accent5"/>
                 </a:solidFill>
                 <a:latin typeface="Microsoft JhengHei"/>
                 <a:ea typeface="Microsoft JhengHei"/>
@@ -4914,7 +4914,7 @@
             <a:r>
               <a:rPr lang="zh-TW" sz="1050" dirty="0">
                 <a:solidFill>
-                  <a:schemeClr val="accent6"/>
+                  <a:schemeClr val="accent5"/>
                 </a:solidFill>
                 <a:latin typeface="Microsoft JhengHei"/>
                 <a:ea typeface="Microsoft JhengHei"/>
@@ -5082,7 +5082,7 @@
             </a:avLst>
           </a:prstGeom>
           <a:solidFill>
-            <a:srgbClr val="F5F7FA"/>
+            <a:schemeClr val="accent3"/>
           </a:solidFill>
           <a:ln>
             <a:noFill/>
@@ -5186,7 +5186,7 @@
             </a:avLst>
           </a:prstGeom>
           <a:solidFill>
-            <a:srgbClr val="F5F7FA"/>
+            <a:schemeClr val="accent3"/>
           </a:solidFill>
           <a:ln>
             <a:noFill/>
@@ -5290,7 +5290,7 @@
             </a:avLst>
           </a:prstGeom>
           <a:solidFill>
-            <a:srgbClr val="F5F7FA"/>
+            <a:schemeClr val="accent3"/>
           </a:solidFill>
           <a:ln>
             <a:noFill/>
@@ -5514,7 +5514,7 @@
     <p:bg>
       <p:bgPr>
         <a:solidFill>
-          <a:schemeClr val="lt2"/>
+          <a:schemeClr val="lt1"/>
         </a:solidFill>
         <a:effectLst/>
       </p:bgPr>
@@ -5562,7 +5562,7 @@
             <a:r>
               <a:rPr lang="en-US" sz="1200" b="1" dirty="0">
                 <a:solidFill>
-                  <a:schemeClr val="accent2"/>
+                  <a:schemeClr val="accent1"/>
                 </a:solidFill>
                 <a:latin typeface="Microsoft JhengHei"/>
                 <a:ea typeface="Microsoft JhengHei"/>
@@ -5602,7 +5602,7 @@
             <a:r>
               <a:rPr lang="zh-TW" sz="3300" dirty="0">
                 <a:solidFill>
-                  <a:srgbClr val="FFFFFF"/>
+                  <a:srgbClr val="121314"/>
                 </a:solidFill>
                 <a:latin typeface="Microsoft JhengHei"/>
                 <a:ea typeface="Microsoft JhengHei"/>
@@ -5666,7 +5666,7 @@
             <a:r>
               <a:rPr lang="zh-TW" sz="1500" dirty="0">
                 <a:solidFill>
-                  <a:schemeClr val="accent2"/>
+                  <a:schemeClr val="accent1"/>
                 </a:solidFill>
                 <a:latin typeface="Microsoft JhengHei"/>
                 <a:ea typeface="Microsoft JhengHei"/>
@@ -5706,7 +5706,7 @@
             <a:r>
               <a:rPr lang="zh-TW" sz="2400" dirty="0">
                 <a:solidFill>
-                  <a:srgbClr val="FFFFFF"/>
+                  <a:srgbClr val="121314"/>
                 </a:solidFill>
                 <a:latin typeface="Microsoft JhengHei"/>
                 <a:ea typeface="Microsoft JhengHei"/>
@@ -5746,7 +5746,7 @@
             <a:r>
               <a:rPr lang="zh-TW" sz="1650" dirty="0">
                 <a:solidFill>
-                  <a:schemeClr val="accent6"/>
+                  <a:schemeClr val="accent5"/>
                 </a:solidFill>
                 <a:latin typeface="Microsoft JhengHei"/>
                 <a:ea typeface="Microsoft JhengHei"/>
@@ -5810,7 +5810,7 @@
             <a:r>
               <a:rPr lang="zh-TW" sz="1500" dirty="0">
                 <a:solidFill>
-                  <a:schemeClr val="accent2"/>
+                  <a:schemeClr val="accent1"/>
                 </a:solidFill>
                 <a:latin typeface="Microsoft JhengHei"/>
                 <a:ea typeface="Microsoft JhengHei"/>
@@ -5850,7 +5850,7 @@
             <a:r>
               <a:rPr lang="zh-TW" sz="2400" dirty="0">
                 <a:solidFill>
-                  <a:srgbClr val="FFFFFF"/>
+                  <a:srgbClr val="121314"/>
                 </a:solidFill>
                 <a:latin typeface="Microsoft JhengHei"/>
                 <a:ea typeface="Microsoft JhengHei"/>
@@ -5890,7 +5890,7 @@
             <a:r>
               <a:rPr lang="zh-TW" sz="1650" dirty="0">
                 <a:solidFill>
-                  <a:schemeClr val="accent6"/>
+                  <a:schemeClr val="accent5"/>
                 </a:solidFill>
                 <a:latin typeface="Microsoft JhengHei"/>
                 <a:ea typeface="Microsoft JhengHei"/>
@@ -5954,7 +5954,7 @@
             <a:r>
               <a:rPr lang="zh-TW" sz="1500" dirty="0">
                 <a:solidFill>
-                  <a:schemeClr val="accent2"/>
+                  <a:schemeClr val="accent1"/>
                 </a:solidFill>
                 <a:latin typeface="Microsoft JhengHei"/>
                 <a:ea typeface="Microsoft JhengHei"/>
@@ -5994,7 +5994,7 @@
             <a:r>
               <a:rPr lang="zh-TW" sz="2400" dirty="0">
                 <a:solidFill>
-                  <a:srgbClr val="FFFFFF"/>
+                  <a:srgbClr val="121314"/>
                 </a:solidFill>
                 <a:latin typeface="Microsoft JhengHei"/>
                 <a:ea typeface="Microsoft JhengHei"/>
@@ -6034,7 +6034,7 @@
             <a:r>
               <a:rPr lang="zh-TW" sz="1650" dirty="0">
                 <a:solidFill>
-                  <a:schemeClr val="accent6"/>
+                  <a:schemeClr val="accent5"/>
                 </a:solidFill>
                 <a:latin typeface="Microsoft JhengHei"/>
                 <a:ea typeface="Microsoft JhengHei"/>
@@ -6074,7 +6074,7 @@
             <a:r>
               <a:rPr lang="zh-TW" sz="2020" dirty="0">
                 <a:solidFill>
-                  <a:srgbClr val="FFFFFF"/>
+                  <a:srgbClr val="121314"/>
                 </a:solidFill>
                 <a:latin typeface="Microsoft JhengHei"/>
                 <a:ea typeface="Microsoft JhengHei"/>
@@ -6114,7 +6114,7 @@
             <a:r>
               <a:rPr lang="zh-TW" sz="1650" dirty="0">
                 <a:solidFill>
-                  <a:schemeClr val="accent6"/>
+                  <a:schemeClr val="accent5"/>
                 </a:solidFill>
                 <a:latin typeface="Microsoft JhengHei"/>
                 <a:ea typeface="Microsoft JhengHei"/>
@@ -6154,7 +6154,7 @@
             <a:r>
               <a:rPr lang="zh-TW" sz="1050" dirty="0">
                 <a:solidFill>
-                  <a:schemeClr val="accent6"/>
+                  <a:schemeClr val="accent5"/>
                 </a:solidFill>
                 <a:latin typeface="Microsoft JhengHei"/>
                 <a:ea typeface="Microsoft JhengHei"/>
@@ -6194,7 +6194,7 @@
             <a:r>
               <a:rPr lang="zh-TW" sz="1050" dirty="0">
                 <a:solidFill>
-                  <a:schemeClr val="accent6"/>
+                  <a:schemeClr val="accent5"/>
                 </a:solidFill>
                 <a:latin typeface="Microsoft JhengHei"/>
                 <a:ea typeface="Microsoft JhengHei"/>
@@ -6738,7 +6738,7 @@
             </a:avLst>
           </a:prstGeom>
           <a:solidFill>
-            <a:srgbClr val="F5F7FA"/>
+            <a:schemeClr val="accent3"/>
           </a:solidFill>
           <a:ln>
             <a:noFill/>
@@ -6957,6 +6957,706 @@
 </file>
 
 <file path=ppt/slides/slide7.xml><?xml version="1.0" encoding="utf-8"?>
+<p:sld xmlns:a="http://schemas.openxmlformats.org/drawingml/2006/main" xmlns:r="http://schemas.openxmlformats.org/officeDocument/2006/relationships" xmlns:p="http://schemas.openxmlformats.org/presentationml/2006/main">
+  <p:cSld>
+    <p:bg>
+      <p:bgPr>
+        <a:solidFill>
+          <a:schemeClr val="lt1"/>
+        </a:solidFill>
+        <a:effectLst/>
+      </p:bgPr>
+    </p:bg>
+    <p:spTree>
+      <p:nvGrpSpPr>
+        <p:cNvPr id="1" name=""/>
+        <p:cNvGrpSpPr/>
+        <p:nvPr/>
+      </p:nvGrpSpPr>
+      <p:grpSpPr>
+        <a:xfrm>
+          <a:off x="0" y="0"/>
+          <a:ext cx="0" cy="0"/>
+          <a:chOff x="0" y="0"/>
+          <a:chExt cx="0" cy="0"/>
+        </a:xfrm>
+      </p:grpSpPr>
+      <p:sp>
+        <p:nvSpPr>
+          <p:cNvPr id="2" name="TextBox 2"/>
+          <p:cNvSpPr txBox="1"/>
+          <p:nvPr/>
+        </p:nvSpPr>
+        <p:spPr>
+          <a:xfrm>
+            <a:off x="603504" y="390525"/>
+            <a:ext cx="1580388" cy="234696"/>
+          </a:xfrm>
+          <a:prstGeom prst="rect">
+            <a:avLst/>
+          </a:prstGeom>
+          <a:noFill/>
+          <a:ln>
+            <a:noFill/>
+          </a:ln>
+        </p:spPr>
+        <p:txBody>
+          <a:bodyPr wrap="none" lIns="0" tIns="0" rIns="0" bIns="0" anchor="t" anchorCtr="0">
+            <a:spAutoFit/>
+          </a:bodyPr>
+          <a:lstStyle/>
+          <a:p>
+            <a:pPr algn="l"/>
+            <a:r>
+              <a:rPr lang="en-US" sz="1200" b="1" dirty="0">
+                <a:solidFill>
+                  <a:schemeClr val="accent1"/>
+                </a:solidFill>
+                <a:latin typeface="Microsoft JhengHei"/>
+                <a:ea typeface="Microsoft JhengHei"/>
+                <a:cs typeface="Microsoft JhengHei"/>
+              </a:rPr>
+              <a:t>MEASURED RESULTS</a:t>
+            </a:r>
+          </a:p>
+        </p:txBody>
+      </p:sp>
+      <p:sp>
+        <p:nvSpPr>
+          <p:cNvPr id="3" name="TextBox 3"/>
+          <p:cNvSpPr txBox="1"/>
+          <p:nvPr/>
+        </p:nvSpPr>
+        <p:spPr>
+          <a:xfrm>
+            <a:off x="592836" y="736600"/>
+            <a:ext cx="6252972" cy="645414"/>
+          </a:xfrm>
+          <a:prstGeom prst="rect">
+            <a:avLst/>
+          </a:prstGeom>
+          <a:noFill/>
+          <a:ln>
+            <a:noFill/>
+          </a:ln>
+        </p:spPr>
+        <p:txBody>
+          <a:bodyPr wrap="none" lIns="0" tIns="0" rIns="0" bIns="0" anchor="t" anchorCtr="0">
+            <a:spAutoFit/>
+          </a:bodyPr>
+          <a:lstStyle/>
+          <a:p>
+            <a:pPr algn="l"/>
+            <a:r>
+              <a:rPr lang="zh-TW" sz="3300" dirty="0">
+                <a:solidFill>
+                  <a:srgbClr val="121314"/>
+                </a:solidFill>
+                <a:latin typeface="Microsoft JhengHei"/>
+                <a:ea typeface="Microsoft JhengHei"/>
+                <a:cs typeface="Microsoft JhengHei"/>
+              </a:rPr>
+              <a:t>從相似案例，走到可核對的結論</a:t>
+            </a:r>
+          </a:p>
+        </p:txBody>
+      </p:sp>
+      <p:sp>
+        <p:nvSpPr>
+          <p:cNvPr id="4" name="TextBox 4"/>
+          <p:cNvSpPr txBox="1"/>
+          <p:nvPr/>
+        </p:nvSpPr>
+        <p:spPr>
+          <a:xfrm>
+            <a:off x="590550" y="2038350"/>
+            <a:ext cx="1946338" cy="790575"/>
+          </a:xfrm>
+          <a:prstGeom prst="rect">
+            <a:avLst/>
+          </a:prstGeom>
+          <a:noFill/>
+          <a:ln>
+            <a:noFill/>
+          </a:ln>
+        </p:spPr>
+        <p:txBody>
+          <a:bodyPr wrap="none" lIns="0" tIns="0" rIns="0" bIns="0" anchor="t" anchorCtr="0">
+            <a:spAutoFit/>
+          </a:bodyPr>
+          <a:lstStyle/>
+          <a:p>
+            <a:pPr algn="l"/>
+            <a:r>
+              <a:rPr lang="zh-TW" sz="4050" dirty="0">
+                <a:solidFill>
+                  <a:srgbClr val="121314"/>
+                </a:solidFill>
+                <a:latin typeface="Microsoft JhengHei"/>
+                <a:ea typeface="Microsoft JhengHei"/>
+                <a:cs typeface="Microsoft JhengHei"/>
+              </a:rPr>
+              <a:t>97.62%</a:t>
+            </a:r>
+          </a:p>
+        </p:txBody>
+      </p:sp>
+      <p:sp>
+        <p:nvSpPr>
+          <p:cNvPr id="5" name="TextBox 5"/>
+          <p:cNvSpPr txBox="1"/>
+          <p:nvPr/>
+        </p:nvSpPr>
+        <p:spPr>
+          <a:xfrm>
+            <a:off x="598932" y="2870200"/>
+            <a:ext cx="1747952" cy="410718"/>
+          </a:xfrm>
+          <a:prstGeom prst="rect">
+            <a:avLst/>
+          </a:prstGeom>
+          <a:noFill/>
+          <a:ln>
+            <a:noFill/>
+          </a:ln>
+        </p:spPr>
+        <p:txBody>
+          <a:bodyPr wrap="none" lIns="0" tIns="0" rIns="0" bIns="0" anchor="t" anchorCtr="0">
+            <a:spAutoFit/>
+          </a:bodyPr>
+          <a:lstStyle/>
+          <a:p>
+            <a:pPr algn="l"/>
+            <a:r>
+              <a:rPr lang="zh-TW" sz="2100" dirty="0">
+                <a:solidFill>
+                  <a:srgbClr val="121314"/>
+                </a:solidFill>
+                <a:latin typeface="Microsoft JhengHei"/>
+                <a:ea typeface="Microsoft JhengHei"/>
+                <a:cs typeface="Microsoft JhengHei"/>
+              </a:rPr>
+              <a:t>Top-5 命中率</a:t>
+            </a:r>
+          </a:p>
+        </p:txBody>
+      </p:sp>
+      <p:sp>
+        <p:nvSpPr>
+          <p:cNvPr id="6" name="TextBox 6"/>
+          <p:cNvSpPr txBox="1"/>
+          <p:nvPr/>
+        </p:nvSpPr>
+        <p:spPr>
+          <a:xfrm>
+            <a:off x="602361" y="3479800"/>
+            <a:ext cx="2690724" cy="278702"/>
+          </a:xfrm>
+          <a:prstGeom prst="rect">
+            <a:avLst/>
+          </a:prstGeom>
+          <a:noFill/>
+          <a:ln>
+            <a:noFill/>
+          </a:ln>
+        </p:spPr>
+        <p:txBody>
+          <a:bodyPr wrap="none" lIns="0" tIns="0" rIns="0" bIns="0" anchor="t" anchorCtr="0">
+            <a:spAutoFit/>
+          </a:bodyPr>
+          <a:lstStyle/>
+          <a:p>
+            <a:pPr algn="l"/>
+            <a:r>
+              <a:rPr lang="zh-TW" sz="1420" dirty="0">
+                <a:solidFill>
+                  <a:schemeClr val="accent5"/>
+                </a:solidFill>
+                <a:latin typeface="Microsoft JhengHei"/>
+                <a:ea typeface="Microsoft JhengHei"/>
+                <a:cs typeface="Microsoft JhengHei"/>
+              </a:rPr>
+              <a:t>463 筆查詢／1,550 筆訓練案例</a:t>
+            </a:r>
+          </a:p>
+        </p:txBody>
+      </p:sp>
+      <p:sp>
+        <p:nvSpPr>
+          <p:cNvPr id="7" name="TextBox 7"/>
+          <p:cNvSpPr txBox="1"/>
+          <p:nvPr/>
+        </p:nvSpPr>
+        <p:spPr>
+          <a:xfrm>
+            <a:off x="4352925" y="2038350"/>
+            <a:ext cx="1946338" cy="790575"/>
+          </a:xfrm>
+          <a:prstGeom prst="rect">
+            <a:avLst/>
+          </a:prstGeom>
+          <a:noFill/>
+          <a:ln>
+            <a:noFill/>
+          </a:ln>
+        </p:spPr>
+        <p:txBody>
+          <a:bodyPr wrap="none" lIns="0" tIns="0" rIns="0" bIns="0" anchor="t" anchorCtr="0">
+            <a:spAutoFit/>
+          </a:bodyPr>
+          <a:lstStyle/>
+          <a:p>
+            <a:pPr algn="l"/>
+            <a:r>
+              <a:rPr lang="zh-TW" sz="4050" dirty="0">
+                <a:solidFill>
+                  <a:srgbClr val="121314"/>
+                </a:solidFill>
+                <a:latin typeface="Microsoft JhengHei"/>
+                <a:ea typeface="Microsoft JhengHei"/>
+                <a:cs typeface="Microsoft JhengHei"/>
+              </a:rPr>
+              <a:t>93.89%</a:t>
+            </a:r>
+          </a:p>
+        </p:txBody>
+      </p:sp>
+      <p:sp>
+        <p:nvSpPr>
+          <p:cNvPr id="8" name="TextBox 8"/>
+          <p:cNvSpPr txBox="1"/>
+          <p:nvPr/>
+        </p:nvSpPr>
+        <p:spPr>
+          <a:xfrm>
+            <a:off x="4361307" y="2870200"/>
+            <a:ext cx="902513" cy="410718"/>
+          </a:xfrm>
+          <a:prstGeom prst="rect">
+            <a:avLst/>
+          </a:prstGeom>
+          <a:noFill/>
+          <a:ln>
+            <a:noFill/>
+          </a:ln>
+        </p:spPr>
+        <p:txBody>
+          <a:bodyPr wrap="none" lIns="0" tIns="0" rIns="0" bIns="0" anchor="t" anchorCtr="0">
+            <a:spAutoFit/>
+          </a:bodyPr>
+          <a:lstStyle/>
+          <a:p>
+            <a:pPr algn="l"/>
+            <a:r>
+              <a:rPr lang="en-US" sz="2100" dirty="0">
+                <a:solidFill>
+                  <a:srgbClr val="121314"/>
+                </a:solidFill>
+                <a:latin typeface="Microsoft JhengHei"/>
+                <a:ea typeface="Microsoft JhengHei"/>
+                <a:cs typeface="Microsoft JhengHei"/>
+              </a:rPr>
+              <a:t>MRR@5</a:t>
+            </a:r>
+          </a:p>
+        </p:txBody>
+      </p:sp>
+      <p:sp>
+        <p:nvSpPr>
+          <p:cNvPr id="9" name="TextBox 9"/>
+          <p:cNvSpPr txBox="1"/>
+          <p:nvPr/>
+        </p:nvSpPr>
+        <p:spPr>
+          <a:xfrm>
+            <a:off x="4364736" y="3479800"/>
+            <a:ext cx="1926082" cy="278702"/>
+          </a:xfrm>
+          <a:prstGeom prst="rect">
+            <a:avLst/>
+          </a:prstGeom>
+          <a:noFill/>
+          <a:ln>
+            <a:noFill/>
+          </a:ln>
+        </p:spPr>
+        <p:txBody>
+          <a:bodyPr wrap="none" lIns="0" tIns="0" rIns="0" bIns="0" anchor="t" anchorCtr="0">
+            <a:spAutoFit/>
+          </a:bodyPr>
+          <a:lstStyle/>
+          <a:p>
+            <a:pPr algn="l"/>
+            <a:r>
+              <a:rPr lang="zh-TW" sz="1420" dirty="0">
+                <a:solidFill>
+                  <a:schemeClr val="accent5"/>
+                </a:solidFill>
+                <a:latin typeface="Microsoft JhengHei"/>
+                <a:ea typeface="Microsoft JhengHei"/>
+                <a:cs typeface="Microsoft JhengHei"/>
+              </a:rPr>
+              <a:t>前五筆結果的排序品質</a:t>
+            </a:r>
+          </a:p>
+        </p:txBody>
+      </p:sp>
+      <p:sp>
+        <p:nvSpPr>
+          <p:cNvPr id="10" name="TextBox 10"/>
+          <p:cNvSpPr txBox="1"/>
+          <p:nvPr/>
+        </p:nvSpPr>
+        <p:spPr>
+          <a:xfrm>
+            <a:off x="8115300" y="2038350"/>
+            <a:ext cx="1946338" cy="790575"/>
+          </a:xfrm>
+          <a:prstGeom prst="rect">
+            <a:avLst/>
+          </a:prstGeom>
+          <a:noFill/>
+          <a:ln>
+            <a:noFill/>
+          </a:ln>
+        </p:spPr>
+        <p:txBody>
+          <a:bodyPr wrap="none" lIns="0" tIns="0" rIns="0" bIns="0" anchor="t" anchorCtr="0">
+            <a:spAutoFit/>
+          </a:bodyPr>
+          <a:lstStyle/>
+          <a:p>
+            <a:pPr algn="l"/>
+            <a:r>
+              <a:rPr lang="zh-TW" sz="4050" dirty="0">
+                <a:solidFill>
+                  <a:srgbClr val="121314"/>
+                </a:solidFill>
+                <a:latin typeface="Microsoft JhengHei"/>
+                <a:ea typeface="Microsoft JhengHei"/>
+                <a:cs typeface="Microsoft JhengHei"/>
+              </a:rPr>
+              <a:t>97.11%</a:t>
+            </a:r>
+          </a:p>
+        </p:txBody>
+      </p:sp>
+      <p:sp>
+        <p:nvSpPr>
+          <p:cNvPr id="11" name="TextBox 11"/>
+          <p:cNvSpPr txBox="1"/>
+          <p:nvPr/>
+        </p:nvSpPr>
+        <p:spPr>
+          <a:xfrm>
+            <a:off x="8123682" y="2870200"/>
+            <a:ext cx="1434846" cy="410718"/>
+          </a:xfrm>
+          <a:prstGeom prst="rect">
+            <a:avLst/>
+          </a:prstGeom>
+          <a:noFill/>
+          <a:ln>
+            <a:noFill/>
+          </a:ln>
+        </p:spPr>
+        <p:txBody>
+          <a:bodyPr wrap="none" lIns="0" tIns="0" rIns="0" bIns="0" anchor="t" anchorCtr="0">
+            <a:spAutoFit/>
+          </a:bodyPr>
+          <a:lstStyle/>
+          <a:p>
+            <a:pPr algn="l"/>
+            <a:r>
+              <a:rPr lang="zh-TW" sz="2100" dirty="0">
+                <a:solidFill>
+                  <a:srgbClr val="121314"/>
+                </a:solidFill>
+                <a:latin typeface="Microsoft JhengHei"/>
+                <a:ea typeface="Microsoft JhengHei"/>
+                <a:cs typeface="Microsoft JhengHei"/>
+              </a:rPr>
+              <a:t>支持精確率</a:t>
+            </a:r>
+          </a:p>
+        </p:txBody>
+      </p:sp>
+      <p:sp>
+        <p:nvSpPr>
+          <p:cNvPr id="12" name="TextBox 12"/>
+          <p:cNvSpPr txBox="1"/>
+          <p:nvPr/>
+        </p:nvSpPr>
+        <p:spPr>
+          <a:xfrm>
+            <a:off x="8127111" y="3479800"/>
+            <a:ext cx="2642934" cy="278702"/>
+          </a:xfrm>
+          <a:prstGeom prst="rect">
+            <a:avLst/>
+          </a:prstGeom>
+          <a:noFill/>
+          <a:ln>
+            <a:noFill/>
+          </a:ln>
+        </p:spPr>
+        <p:txBody>
+          <a:bodyPr wrap="none" lIns="0" tIns="0" rIns="0" bIns="0" anchor="t" anchorCtr="0">
+            <a:spAutoFit/>
+          </a:bodyPr>
+          <a:lstStyle/>
+          <a:p>
+            <a:pPr algn="l"/>
+            <a:r>
+              <a:rPr lang="zh-TW" sz="1420" dirty="0">
+                <a:solidFill>
+                  <a:schemeClr val="accent5"/>
+                </a:solidFill>
+                <a:latin typeface="Microsoft JhengHei"/>
+                <a:ea typeface="Microsoft JhengHei"/>
+                <a:cs typeface="Microsoft JhengHei"/>
+              </a:rPr>
+              <a:t>415 支持／13 複核／35 不確定</a:t>
+            </a:r>
+          </a:p>
+        </p:txBody>
+      </p:sp>
+      <p:sp>
+        <p:nvSpPr>
+          <p:cNvPr id="13" name="Rectangle 13"/>
+          <p:cNvSpPr/>
+          <p:nvPr/>
+        </p:nvSpPr>
+        <p:spPr>
+          <a:xfrm>
+            <a:off x="609600" y="4533900"/>
+            <a:ext cx="10972800" cy="1238250"/>
+          </a:xfrm>
+          <a:prstGeom prst="roundRect">
+            <a:avLst>
+              <a:gd name="adj" fmla="val 6154"/>
+            </a:avLst>
+          </a:prstGeom>
+          <a:solidFill>
+            <a:schemeClr val="accent3"/>
+          </a:solidFill>
+          <a:ln>
+            <a:noFill/>
+          </a:ln>
+        </p:spPr>
+      </p:sp>
+      <p:sp>
+        <p:nvSpPr>
+          <p:cNvPr id="14" name="TextBox 14"/>
+          <p:cNvSpPr txBox="1"/>
+          <p:nvPr/>
+        </p:nvSpPr>
+        <p:spPr>
+          <a:xfrm>
+            <a:off x="821055" y="4581525"/>
+            <a:ext cx="1558592" cy="661035"/>
+          </a:xfrm>
+          <a:prstGeom prst="rect">
+            <a:avLst/>
+          </a:prstGeom>
+          <a:noFill/>
+          <a:ln>
+            <a:noFill/>
+          </a:ln>
+        </p:spPr>
+        <p:txBody>
+          <a:bodyPr wrap="none" lIns="0" tIns="0" rIns="0" bIns="0" anchor="t" anchorCtr="0">
+            <a:spAutoFit/>
+          </a:bodyPr>
+          <a:lstStyle/>
+          <a:p>
+            <a:pPr algn="l"/>
+            <a:r>
+              <a:rPr lang="zh-TW" sz="3380" dirty="0">
+                <a:solidFill>
+                  <a:schemeClr val="accent1"/>
+                </a:solidFill>
+                <a:latin typeface="Microsoft JhengHei"/>
+                <a:ea typeface="Microsoft JhengHei"/>
+                <a:cs typeface="Microsoft JhengHei"/>
+              </a:rPr>
+              <a:t>18 / 30</a:t>
+            </a:r>
+          </a:p>
+        </p:txBody>
+      </p:sp>
+      <p:sp>
+        <p:nvSpPr>
+          <p:cNvPr id="15" name="TextBox 15"/>
+          <p:cNvSpPr txBox="1"/>
+          <p:nvPr/>
+        </p:nvSpPr>
+        <p:spPr>
+          <a:xfrm>
+            <a:off x="3704844" y="4759325"/>
+            <a:ext cx="3432429" cy="381381"/>
+          </a:xfrm>
+          <a:prstGeom prst="rect">
+            <a:avLst/>
+          </a:prstGeom>
+          <a:noFill/>
+          <a:ln>
+            <a:noFill/>
+          </a:ln>
+        </p:spPr>
+        <p:txBody>
+          <a:bodyPr wrap="none" lIns="0" tIns="0" rIns="0" bIns="0" anchor="t" anchorCtr="0">
+            <a:spAutoFit/>
+          </a:bodyPr>
+          <a:lstStyle/>
+          <a:p>
+            <a:pPr algn="l"/>
+            <a:r>
+              <a:rPr lang="zh-TW" sz="1950" dirty="0">
+                <a:solidFill>
+                  <a:srgbClr val="121314"/>
+                </a:solidFill>
+                <a:latin typeface="Microsoft JhengHei"/>
+                <a:ea typeface="Microsoft JhengHei"/>
+                <a:cs typeface="Microsoft JhengHei"/>
+              </a:rPr>
+              <a:t>偵測誤判分流至複核或不確定</a:t>
+            </a:r>
+          </a:p>
+        </p:txBody>
+      </p:sp>
+      <p:sp>
+        <p:nvSpPr>
+          <p:cNvPr id="16" name="TextBox 16"/>
+          <p:cNvSpPr txBox="1"/>
+          <p:nvPr/>
+        </p:nvSpPr>
+        <p:spPr>
+          <a:xfrm>
+            <a:off x="829437" y="5213350"/>
+            <a:ext cx="5392898" cy="337376"/>
+          </a:xfrm>
+          <a:prstGeom prst="rect">
+            <a:avLst/>
+          </a:prstGeom>
+          <a:noFill/>
+          <a:ln>
+            <a:noFill/>
+          </a:ln>
+        </p:spPr>
+        <p:txBody>
+          <a:bodyPr wrap="none" lIns="0" tIns="0" rIns="0" bIns="0" anchor="t" anchorCtr="0">
+            <a:spAutoFit/>
+          </a:bodyPr>
+          <a:lstStyle/>
+          <a:p>
+            <a:pPr algn="l"/>
+            <a:r>
+              <a:rPr lang="zh-TW" sz="1720" dirty="0">
+                <a:solidFill>
+                  <a:schemeClr val="accent5"/>
+                </a:solidFill>
+                <a:latin typeface="Microsoft JhengHei"/>
+                <a:ea typeface="Microsoft JhengHei"/>
+                <a:cs typeface="Microsoft JhengHei"/>
+              </a:rPr>
+              <a:t>AI 依案例證據給出稽核結論；正式分類保持可追溯。</a:t>
+            </a:r>
+          </a:p>
+        </p:txBody>
+      </p:sp>
+      <p:sp>
+        <p:nvSpPr>
+          <p:cNvPr id="17" name="TextBox 17"/>
+          <p:cNvSpPr txBox="1"/>
+          <p:nvPr/>
+        </p:nvSpPr>
+        <p:spPr>
+          <a:xfrm>
+            <a:off x="604266" y="6416675"/>
+            <a:ext cx="1617135" cy="205359"/>
+          </a:xfrm>
+          <a:prstGeom prst="rect">
+            <a:avLst/>
+          </a:prstGeom>
+          <a:noFill/>
+          <a:ln>
+            <a:noFill/>
+          </a:ln>
+        </p:spPr>
+        <p:txBody>
+          <a:bodyPr wrap="none" lIns="0" tIns="0" rIns="0" bIns="0" anchor="t" anchorCtr="0">
+            <a:spAutoFit/>
+          </a:bodyPr>
+          <a:lstStyle/>
+          <a:p>
+            <a:pPr algn="l"/>
+            <a:r>
+              <a:rPr lang="zh-TW" sz="1050" dirty="0">
+                <a:solidFill>
+                  <a:schemeClr val="accent5"/>
+                </a:solidFill>
+                <a:latin typeface="Microsoft JhengHei"/>
+                <a:ea typeface="Microsoft JhengHei"/>
+                <a:cs typeface="Microsoft JhengHei"/>
+              </a:rPr>
+              <a:t>AI 資安框架 · 資安技術組</a:t>
+            </a:r>
+          </a:p>
+        </p:txBody>
+      </p:sp>
+      <p:sp>
+        <p:nvSpPr>
+          <p:cNvPr id="18" name="TextBox 18"/>
+          <p:cNvSpPr txBox="1"/>
+          <p:nvPr/>
+        </p:nvSpPr>
+        <p:spPr>
+          <a:xfrm>
+            <a:off x="11103540" y="6416675"/>
+            <a:ext cx="484194" cy="205359"/>
+          </a:xfrm>
+          <a:prstGeom prst="rect">
+            <a:avLst/>
+          </a:prstGeom>
+          <a:noFill/>
+          <a:ln>
+            <a:noFill/>
+          </a:ln>
+        </p:spPr>
+        <p:txBody>
+          <a:bodyPr wrap="none" lIns="0" tIns="0" rIns="0" bIns="0" anchor="t" anchorCtr="0">
+            <a:spAutoFit/>
+          </a:bodyPr>
+          <a:lstStyle/>
+          <a:p>
+            <a:pPr algn="r"/>
+            <a:r>
+              <a:rPr lang="zh-TW" sz="1050" dirty="0">
+                <a:solidFill>
+                  <a:schemeClr val="accent5"/>
+                </a:solidFill>
+                <a:latin typeface="Microsoft JhengHei"/>
+                <a:ea typeface="Microsoft JhengHei"/>
+                <a:cs typeface="Microsoft JhengHei"/>
+              </a:rPr>
+              <a:t>07 / 08</a:t>
+            </a:r>
+          </a:p>
+        </p:txBody>
+      </p:sp>
+    </p:spTree>
+  </p:cSld>
+  <p:clrMapOvr>
+    <a:masterClrMapping/>
+  </p:clrMapOvr>
+  <p:transition xmlns:p14="http://schemas.microsoft.com/office/powerpoint/2010/main" p14:dur="400">
+    <p:fade/>
+  </p:transition>
+</p:sld>
+</file>
+
+<file path=ppt/slides/slide8.xml><?xml version="1.0" encoding="utf-8"?>
 <p:sld xmlns:a="http://schemas.openxmlformats.org/drawingml/2006/main" xmlns:r="http://schemas.openxmlformats.org/officeDocument/2006/relationships" xmlns:p="http://schemas.openxmlformats.org/presentationml/2006/main">
   <p:cSld>
     <p:bg>
@@ -6989,706 +7689,6 @@
         </p:nvSpPr>
         <p:spPr>
           <a:xfrm>
-            <a:off x="603504" y="390525"/>
-            <a:ext cx="1580388" cy="234696"/>
-          </a:xfrm>
-          <a:prstGeom prst="rect">
-            <a:avLst/>
-          </a:prstGeom>
-          <a:noFill/>
-          <a:ln>
-            <a:noFill/>
-          </a:ln>
-        </p:spPr>
-        <p:txBody>
-          <a:bodyPr wrap="none" lIns="0" tIns="0" rIns="0" bIns="0" anchor="t" anchorCtr="0">
-            <a:spAutoFit/>
-          </a:bodyPr>
-          <a:lstStyle/>
-          <a:p>
-            <a:pPr algn="l"/>
-            <a:r>
-              <a:rPr lang="en-US" sz="1200" b="1" dirty="0">
-                <a:solidFill>
-                  <a:schemeClr val="accent2"/>
-                </a:solidFill>
-                <a:latin typeface="Microsoft JhengHei"/>
-                <a:ea typeface="Microsoft JhengHei"/>
-                <a:cs typeface="Microsoft JhengHei"/>
-              </a:rPr>
-              <a:t>MEASURED RESULTS</a:t>
-            </a:r>
-          </a:p>
-        </p:txBody>
-      </p:sp>
-      <p:sp>
-        <p:nvSpPr>
-          <p:cNvPr id="3" name="TextBox 3"/>
-          <p:cNvSpPr txBox="1"/>
-          <p:nvPr/>
-        </p:nvSpPr>
-        <p:spPr>
-          <a:xfrm>
-            <a:off x="592836" y="736600"/>
-            <a:ext cx="6252972" cy="645414"/>
-          </a:xfrm>
-          <a:prstGeom prst="rect">
-            <a:avLst/>
-          </a:prstGeom>
-          <a:noFill/>
-          <a:ln>
-            <a:noFill/>
-          </a:ln>
-        </p:spPr>
-        <p:txBody>
-          <a:bodyPr wrap="none" lIns="0" tIns="0" rIns="0" bIns="0" anchor="t" anchorCtr="0">
-            <a:spAutoFit/>
-          </a:bodyPr>
-          <a:lstStyle/>
-          <a:p>
-            <a:pPr algn="l"/>
-            <a:r>
-              <a:rPr lang="zh-TW" sz="3300" dirty="0">
-                <a:solidFill>
-                  <a:srgbClr val="FFFFFF"/>
-                </a:solidFill>
-                <a:latin typeface="Microsoft JhengHei"/>
-                <a:ea typeface="Microsoft JhengHei"/>
-                <a:cs typeface="Microsoft JhengHei"/>
-              </a:rPr>
-              <a:t>從相似案例，走到可核對的結論</a:t>
-            </a:r>
-          </a:p>
-        </p:txBody>
-      </p:sp>
-      <p:sp>
-        <p:nvSpPr>
-          <p:cNvPr id="4" name="TextBox 4"/>
-          <p:cNvSpPr txBox="1"/>
-          <p:nvPr/>
-        </p:nvSpPr>
-        <p:spPr>
-          <a:xfrm>
-            <a:off x="590550" y="2038350"/>
-            <a:ext cx="1946338" cy="790575"/>
-          </a:xfrm>
-          <a:prstGeom prst="rect">
-            <a:avLst/>
-          </a:prstGeom>
-          <a:noFill/>
-          <a:ln>
-            <a:noFill/>
-          </a:ln>
-        </p:spPr>
-        <p:txBody>
-          <a:bodyPr wrap="none" lIns="0" tIns="0" rIns="0" bIns="0" anchor="t" anchorCtr="0">
-            <a:spAutoFit/>
-          </a:bodyPr>
-          <a:lstStyle/>
-          <a:p>
-            <a:pPr algn="l"/>
-            <a:r>
-              <a:rPr lang="zh-TW" sz="4050" dirty="0">
-                <a:solidFill>
-                  <a:srgbClr val="FFFFFF"/>
-                </a:solidFill>
-                <a:latin typeface="Microsoft JhengHei"/>
-                <a:ea typeface="Microsoft JhengHei"/>
-                <a:cs typeface="Microsoft JhengHei"/>
-              </a:rPr>
-              <a:t>97.62%</a:t>
-            </a:r>
-          </a:p>
-        </p:txBody>
-      </p:sp>
-      <p:sp>
-        <p:nvSpPr>
-          <p:cNvPr id="5" name="TextBox 5"/>
-          <p:cNvSpPr txBox="1"/>
-          <p:nvPr/>
-        </p:nvSpPr>
-        <p:spPr>
-          <a:xfrm>
-            <a:off x="598932" y="2870200"/>
-            <a:ext cx="1747952" cy="410718"/>
-          </a:xfrm>
-          <a:prstGeom prst="rect">
-            <a:avLst/>
-          </a:prstGeom>
-          <a:noFill/>
-          <a:ln>
-            <a:noFill/>
-          </a:ln>
-        </p:spPr>
-        <p:txBody>
-          <a:bodyPr wrap="none" lIns="0" tIns="0" rIns="0" bIns="0" anchor="t" anchorCtr="0">
-            <a:spAutoFit/>
-          </a:bodyPr>
-          <a:lstStyle/>
-          <a:p>
-            <a:pPr algn="l"/>
-            <a:r>
-              <a:rPr lang="zh-TW" sz="2100" dirty="0">
-                <a:solidFill>
-                  <a:srgbClr val="FFFFFF"/>
-                </a:solidFill>
-                <a:latin typeface="Microsoft JhengHei"/>
-                <a:ea typeface="Microsoft JhengHei"/>
-                <a:cs typeface="Microsoft JhengHei"/>
-              </a:rPr>
-              <a:t>Top-5 命中率</a:t>
-            </a:r>
-          </a:p>
-        </p:txBody>
-      </p:sp>
-      <p:sp>
-        <p:nvSpPr>
-          <p:cNvPr id="6" name="TextBox 6"/>
-          <p:cNvSpPr txBox="1"/>
-          <p:nvPr/>
-        </p:nvSpPr>
-        <p:spPr>
-          <a:xfrm>
-            <a:off x="602361" y="3479800"/>
-            <a:ext cx="2690724" cy="278702"/>
-          </a:xfrm>
-          <a:prstGeom prst="rect">
-            <a:avLst/>
-          </a:prstGeom>
-          <a:noFill/>
-          <a:ln>
-            <a:noFill/>
-          </a:ln>
-        </p:spPr>
-        <p:txBody>
-          <a:bodyPr wrap="none" lIns="0" tIns="0" rIns="0" bIns="0" anchor="t" anchorCtr="0">
-            <a:spAutoFit/>
-          </a:bodyPr>
-          <a:lstStyle/>
-          <a:p>
-            <a:pPr algn="l"/>
-            <a:r>
-              <a:rPr lang="zh-TW" sz="1420" dirty="0">
-                <a:solidFill>
-                  <a:schemeClr val="accent6"/>
-                </a:solidFill>
-                <a:latin typeface="Microsoft JhengHei"/>
-                <a:ea typeface="Microsoft JhengHei"/>
-                <a:cs typeface="Microsoft JhengHei"/>
-              </a:rPr>
-              <a:t>463 筆查詢／1,550 筆訓練案例</a:t>
-            </a:r>
-          </a:p>
-        </p:txBody>
-      </p:sp>
-      <p:sp>
-        <p:nvSpPr>
-          <p:cNvPr id="7" name="TextBox 7"/>
-          <p:cNvSpPr txBox="1"/>
-          <p:nvPr/>
-        </p:nvSpPr>
-        <p:spPr>
-          <a:xfrm>
-            <a:off x="4352925" y="2038350"/>
-            <a:ext cx="1946338" cy="790575"/>
-          </a:xfrm>
-          <a:prstGeom prst="rect">
-            <a:avLst/>
-          </a:prstGeom>
-          <a:noFill/>
-          <a:ln>
-            <a:noFill/>
-          </a:ln>
-        </p:spPr>
-        <p:txBody>
-          <a:bodyPr wrap="none" lIns="0" tIns="0" rIns="0" bIns="0" anchor="t" anchorCtr="0">
-            <a:spAutoFit/>
-          </a:bodyPr>
-          <a:lstStyle/>
-          <a:p>
-            <a:pPr algn="l"/>
-            <a:r>
-              <a:rPr lang="zh-TW" sz="4050" dirty="0">
-                <a:solidFill>
-                  <a:srgbClr val="FFFFFF"/>
-                </a:solidFill>
-                <a:latin typeface="Microsoft JhengHei"/>
-                <a:ea typeface="Microsoft JhengHei"/>
-                <a:cs typeface="Microsoft JhengHei"/>
-              </a:rPr>
-              <a:t>93.89%</a:t>
-            </a:r>
-          </a:p>
-        </p:txBody>
-      </p:sp>
-      <p:sp>
-        <p:nvSpPr>
-          <p:cNvPr id="8" name="TextBox 8"/>
-          <p:cNvSpPr txBox="1"/>
-          <p:nvPr/>
-        </p:nvSpPr>
-        <p:spPr>
-          <a:xfrm>
-            <a:off x="4361307" y="2870200"/>
-            <a:ext cx="902513" cy="410718"/>
-          </a:xfrm>
-          <a:prstGeom prst="rect">
-            <a:avLst/>
-          </a:prstGeom>
-          <a:noFill/>
-          <a:ln>
-            <a:noFill/>
-          </a:ln>
-        </p:spPr>
-        <p:txBody>
-          <a:bodyPr wrap="none" lIns="0" tIns="0" rIns="0" bIns="0" anchor="t" anchorCtr="0">
-            <a:spAutoFit/>
-          </a:bodyPr>
-          <a:lstStyle/>
-          <a:p>
-            <a:pPr algn="l"/>
-            <a:r>
-              <a:rPr lang="en-US" sz="2100" dirty="0">
-                <a:solidFill>
-                  <a:srgbClr val="FFFFFF"/>
-                </a:solidFill>
-                <a:latin typeface="Microsoft JhengHei"/>
-                <a:ea typeface="Microsoft JhengHei"/>
-                <a:cs typeface="Microsoft JhengHei"/>
-              </a:rPr>
-              <a:t>MRR@5</a:t>
-            </a:r>
-          </a:p>
-        </p:txBody>
-      </p:sp>
-      <p:sp>
-        <p:nvSpPr>
-          <p:cNvPr id="9" name="TextBox 9"/>
-          <p:cNvSpPr txBox="1"/>
-          <p:nvPr/>
-        </p:nvSpPr>
-        <p:spPr>
-          <a:xfrm>
-            <a:off x="4364736" y="3479800"/>
-            <a:ext cx="1926082" cy="278702"/>
-          </a:xfrm>
-          <a:prstGeom prst="rect">
-            <a:avLst/>
-          </a:prstGeom>
-          <a:noFill/>
-          <a:ln>
-            <a:noFill/>
-          </a:ln>
-        </p:spPr>
-        <p:txBody>
-          <a:bodyPr wrap="none" lIns="0" tIns="0" rIns="0" bIns="0" anchor="t" anchorCtr="0">
-            <a:spAutoFit/>
-          </a:bodyPr>
-          <a:lstStyle/>
-          <a:p>
-            <a:pPr algn="l"/>
-            <a:r>
-              <a:rPr lang="zh-TW" sz="1420" dirty="0">
-                <a:solidFill>
-                  <a:schemeClr val="accent6"/>
-                </a:solidFill>
-                <a:latin typeface="Microsoft JhengHei"/>
-                <a:ea typeface="Microsoft JhengHei"/>
-                <a:cs typeface="Microsoft JhengHei"/>
-              </a:rPr>
-              <a:t>前五筆結果的排序品質</a:t>
-            </a:r>
-          </a:p>
-        </p:txBody>
-      </p:sp>
-      <p:sp>
-        <p:nvSpPr>
-          <p:cNvPr id="10" name="TextBox 10"/>
-          <p:cNvSpPr txBox="1"/>
-          <p:nvPr/>
-        </p:nvSpPr>
-        <p:spPr>
-          <a:xfrm>
-            <a:off x="8115300" y="2038350"/>
-            <a:ext cx="1946338" cy="790575"/>
-          </a:xfrm>
-          <a:prstGeom prst="rect">
-            <a:avLst/>
-          </a:prstGeom>
-          <a:noFill/>
-          <a:ln>
-            <a:noFill/>
-          </a:ln>
-        </p:spPr>
-        <p:txBody>
-          <a:bodyPr wrap="none" lIns="0" tIns="0" rIns="0" bIns="0" anchor="t" anchorCtr="0">
-            <a:spAutoFit/>
-          </a:bodyPr>
-          <a:lstStyle/>
-          <a:p>
-            <a:pPr algn="l"/>
-            <a:r>
-              <a:rPr lang="zh-TW" sz="4050" dirty="0">
-                <a:solidFill>
-                  <a:srgbClr val="FFFFFF"/>
-                </a:solidFill>
-                <a:latin typeface="Microsoft JhengHei"/>
-                <a:ea typeface="Microsoft JhengHei"/>
-                <a:cs typeface="Microsoft JhengHei"/>
-              </a:rPr>
-              <a:t>97.11%</a:t>
-            </a:r>
-          </a:p>
-        </p:txBody>
-      </p:sp>
-      <p:sp>
-        <p:nvSpPr>
-          <p:cNvPr id="11" name="TextBox 11"/>
-          <p:cNvSpPr txBox="1"/>
-          <p:nvPr/>
-        </p:nvSpPr>
-        <p:spPr>
-          <a:xfrm>
-            <a:off x="8123682" y="2870200"/>
-            <a:ext cx="1434846" cy="410718"/>
-          </a:xfrm>
-          <a:prstGeom prst="rect">
-            <a:avLst/>
-          </a:prstGeom>
-          <a:noFill/>
-          <a:ln>
-            <a:noFill/>
-          </a:ln>
-        </p:spPr>
-        <p:txBody>
-          <a:bodyPr wrap="none" lIns="0" tIns="0" rIns="0" bIns="0" anchor="t" anchorCtr="0">
-            <a:spAutoFit/>
-          </a:bodyPr>
-          <a:lstStyle/>
-          <a:p>
-            <a:pPr algn="l"/>
-            <a:r>
-              <a:rPr lang="zh-TW" sz="2100" dirty="0">
-                <a:solidFill>
-                  <a:srgbClr val="FFFFFF"/>
-                </a:solidFill>
-                <a:latin typeface="Microsoft JhengHei"/>
-                <a:ea typeface="Microsoft JhengHei"/>
-                <a:cs typeface="Microsoft JhengHei"/>
-              </a:rPr>
-              <a:t>支持精確率</a:t>
-            </a:r>
-          </a:p>
-        </p:txBody>
-      </p:sp>
-      <p:sp>
-        <p:nvSpPr>
-          <p:cNvPr id="12" name="TextBox 12"/>
-          <p:cNvSpPr txBox="1"/>
-          <p:nvPr/>
-        </p:nvSpPr>
-        <p:spPr>
-          <a:xfrm>
-            <a:off x="8127111" y="3479800"/>
-            <a:ext cx="2642934" cy="278702"/>
-          </a:xfrm>
-          <a:prstGeom prst="rect">
-            <a:avLst/>
-          </a:prstGeom>
-          <a:noFill/>
-          <a:ln>
-            <a:noFill/>
-          </a:ln>
-        </p:spPr>
-        <p:txBody>
-          <a:bodyPr wrap="none" lIns="0" tIns="0" rIns="0" bIns="0" anchor="t" anchorCtr="0">
-            <a:spAutoFit/>
-          </a:bodyPr>
-          <a:lstStyle/>
-          <a:p>
-            <a:pPr algn="l"/>
-            <a:r>
-              <a:rPr lang="zh-TW" sz="1420" dirty="0">
-                <a:solidFill>
-                  <a:schemeClr val="accent6"/>
-                </a:solidFill>
-                <a:latin typeface="Microsoft JhengHei"/>
-                <a:ea typeface="Microsoft JhengHei"/>
-                <a:cs typeface="Microsoft JhengHei"/>
-              </a:rPr>
-              <a:t>415 支持／13 複核／35 不確定</a:t>
-            </a:r>
-          </a:p>
-        </p:txBody>
-      </p:sp>
-      <p:sp>
-        <p:nvSpPr>
-          <p:cNvPr id="13" name="Rectangle 13"/>
-          <p:cNvSpPr/>
-          <p:nvPr/>
-        </p:nvSpPr>
-        <p:spPr>
-          <a:xfrm>
-            <a:off x="609600" y="4533900"/>
-            <a:ext cx="10972800" cy="1238250"/>
-          </a:xfrm>
-          <a:prstGeom prst="roundRect">
-            <a:avLst>
-              <a:gd name="adj" fmla="val 6154"/>
-            </a:avLst>
-          </a:prstGeom>
-          <a:solidFill>
-            <a:schemeClr val="accent3"/>
-          </a:solidFill>
-          <a:ln>
-            <a:noFill/>
-          </a:ln>
-        </p:spPr>
-      </p:sp>
-      <p:sp>
-        <p:nvSpPr>
-          <p:cNvPr id="14" name="TextBox 14"/>
-          <p:cNvSpPr txBox="1"/>
-          <p:nvPr/>
-        </p:nvSpPr>
-        <p:spPr>
-          <a:xfrm>
-            <a:off x="821055" y="4581525"/>
-            <a:ext cx="1558592" cy="661035"/>
-          </a:xfrm>
-          <a:prstGeom prst="rect">
-            <a:avLst/>
-          </a:prstGeom>
-          <a:noFill/>
-          <a:ln>
-            <a:noFill/>
-          </a:ln>
-        </p:spPr>
-        <p:txBody>
-          <a:bodyPr wrap="none" lIns="0" tIns="0" rIns="0" bIns="0" anchor="t" anchorCtr="0">
-            <a:spAutoFit/>
-          </a:bodyPr>
-          <a:lstStyle/>
-          <a:p>
-            <a:pPr algn="l"/>
-            <a:r>
-              <a:rPr lang="zh-TW" sz="3380" dirty="0">
-                <a:solidFill>
-                  <a:schemeClr val="accent2"/>
-                </a:solidFill>
-                <a:latin typeface="Microsoft JhengHei"/>
-                <a:ea typeface="Microsoft JhengHei"/>
-                <a:cs typeface="Microsoft JhengHei"/>
-              </a:rPr>
-              <a:t>18 / 30</a:t>
-            </a:r>
-          </a:p>
-        </p:txBody>
-      </p:sp>
-      <p:sp>
-        <p:nvSpPr>
-          <p:cNvPr id="15" name="TextBox 15"/>
-          <p:cNvSpPr txBox="1"/>
-          <p:nvPr/>
-        </p:nvSpPr>
-        <p:spPr>
-          <a:xfrm>
-            <a:off x="3704844" y="4759325"/>
-            <a:ext cx="3432429" cy="381381"/>
-          </a:xfrm>
-          <a:prstGeom prst="rect">
-            <a:avLst/>
-          </a:prstGeom>
-          <a:noFill/>
-          <a:ln>
-            <a:noFill/>
-          </a:ln>
-        </p:spPr>
-        <p:txBody>
-          <a:bodyPr wrap="none" lIns="0" tIns="0" rIns="0" bIns="0" anchor="t" anchorCtr="0">
-            <a:spAutoFit/>
-          </a:bodyPr>
-          <a:lstStyle/>
-          <a:p>
-            <a:pPr algn="l"/>
-            <a:r>
-              <a:rPr lang="zh-TW" sz="1950" dirty="0">
-                <a:solidFill>
-                  <a:srgbClr val="FFFFFF"/>
-                </a:solidFill>
-                <a:latin typeface="Microsoft JhengHei"/>
-                <a:ea typeface="Microsoft JhengHei"/>
-                <a:cs typeface="Microsoft JhengHei"/>
-              </a:rPr>
-              <a:t>偵測誤判分流至複核或不確定</a:t>
-            </a:r>
-          </a:p>
-        </p:txBody>
-      </p:sp>
-      <p:sp>
-        <p:nvSpPr>
-          <p:cNvPr id="16" name="TextBox 16"/>
-          <p:cNvSpPr txBox="1"/>
-          <p:nvPr/>
-        </p:nvSpPr>
-        <p:spPr>
-          <a:xfrm>
-            <a:off x="829437" y="5213350"/>
-            <a:ext cx="5392898" cy="337376"/>
-          </a:xfrm>
-          <a:prstGeom prst="rect">
-            <a:avLst/>
-          </a:prstGeom>
-          <a:noFill/>
-          <a:ln>
-            <a:noFill/>
-          </a:ln>
-        </p:spPr>
-        <p:txBody>
-          <a:bodyPr wrap="none" lIns="0" tIns="0" rIns="0" bIns="0" anchor="t" anchorCtr="0">
-            <a:spAutoFit/>
-          </a:bodyPr>
-          <a:lstStyle/>
-          <a:p>
-            <a:pPr algn="l"/>
-            <a:r>
-              <a:rPr lang="zh-TW" sz="1720" dirty="0">
-                <a:solidFill>
-                  <a:schemeClr val="accent6"/>
-                </a:solidFill>
-                <a:latin typeface="Microsoft JhengHei"/>
-                <a:ea typeface="Microsoft JhengHei"/>
-                <a:cs typeface="Microsoft JhengHei"/>
-              </a:rPr>
-              <a:t>AI 依案例證據給出稽核結論；正式分類保持可追溯。</a:t>
-            </a:r>
-          </a:p>
-        </p:txBody>
-      </p:sp>
-      <p:sp>
-        <p:nvSpPr>
-          <p:cNvPr id="17" name="TextBox 17"/>
-          <p:cNvSpPr txBox="1"/>
-          <p:nvPr/>
-        </p:nvSpPr>
-        <p:spPr>
-          <a:xfrm>
-            <a:off x="604266" y="6416675"/>
-            <a:ext cx="1617135" cy="205359"/>
-          </a:xfrm>
-          <a:prstGeom prst="rect">
-            <a:avLst/>
-          </a:prstGeom>
-          <a:noFill/>
-          <a:ln>
-            <a:noFill/>
-          </a:ln>
-        </p:spPr>
-        <p:txBody>
-          <a:bodyPr wrap="none" lIns="0" tIns="0" rIns="0" bIns="0" anchor="t" anchorCtr="0">
-            <a:spAutoFit/>
-          </a:bodyPr>
-          <a:lstStyle/>
-          <a:p>
-            <a:pPr algn="l"/>
-            <a:r>
-              <a:rPr lang="zh-TW" sz="1050" dirty="0">
-                <a:solidFill>
-                  <a:schemeClr val="accent6"/>
-                </a:solidFill>
-                <a:latin typeface="Microsoft JhengHei"/>
-                <a:ea typeface="Microsoft JhengHei"/>
-                <a:cs typeface="Microsoft JhengHei"/>
-              </a:rPr>
-              <a:t>AI 資安框架 · 資安技術組</a:t>
-            </a:r>
-          </a:p>
-        </p:txBody>
-      </p:sp>
-      <p:sp>
-        <p:nvSpPr>
-          <p:cNvPr id="18" name="TextBox 18"/>
-          <p:cNvSpPr txBox="1"/>
-          <p:nvPr/>
-        </p:nvSpPr>
-        <p:spPr>
-          <a:xfrm>
-            <a:off x="11103540" y="6416675"/>
-            <a:ext cx="484194" cy="205359"/>
-          </a:xfrm>
-          <a:prstGeom prst="rect">
-            <a:avLst/>
-          </a:prstGeom>
-          <a:noFill/>
-          <a:ln>
-            <a:noFill/>
-          </a:ln>
-        </p:spPr>
-        <p:txBody>
-          <a:bodyPr wrap="none" lIns="0" tIns="0" rIns="0" bIns="0" anchor="t" anchorCtr="0">
-            <a:spAutoFit/>
-          </a:bodyPr>
-          <a:lstStyle/>
-          <a:p>
-            <a:pPr algn="r"/>
-            <a:r>
-              <a:rPr lang="zh-TW" sz="1050" dirty="0">
-                <a:solidFill>
-                  <a:schemeClr val="accent6"/>
-                </a:solidFill>
-                <a:latin typeface="Microsoft JhengHei"/>
-                <a:ea typeface="Microsoft JhengHei"/>
-                <a:cs typeface="Microsoft JhengHei"/>
-              </a:rPr>
-              <a:t>07 / 08</a:t>
-            </a:r>
-          </a:p>
-        </p:txBody>
-      </p:sp>
-    </p:spTree>
-  </p:cSld>
-  <p:clrMapOvr>
-    <a:masterClrMapping/>
-  </p:clrMapOvr>
-  <p:transition xmlns:p14="http://schemas.microsoft.com/office/powerpoint/2010/main" p14:dur="400">
-    <p:fade/>
-  </p:transition>
-</p:sld>
-</file>
-
-<file path=ppt/slides/slide8.xml><?xml version="1.0" encoding="utf-8"?>
-<p:sld xmlns:a="http://schemas.openxmlformats.org/drawingml/2006/main" xmlns:r="http://schemas.openxmlformats.org/officeDocument/2006/relationships" xmlns:p="http://schemas.openxmlformats.org/presentationml/2006/main">
-  <p:cSld>
-    <p:bg>
-      <p:bgPr>
-        <a:solidFill>
-          <a:schemeClr val="accent1"/>
-        </a:solidFill>
-        <a:effectLst/>
-      </p:bgPr>
-    </p:bg>
-    <p:spTree>
-      <p:nvGrpSpPr>
-        <p:cNvPr id="1" name=""/>
-        <p:cNvGrpSpPr/>
-        <p:nvPr/>
-      </p:nvGrpSpPr>
-      <p:grpSpPr>
-        <a:xfrm>
-          <a:off x="0" y="0"/>
-          <a:ext cx="0" cy="0"/>
-          <a:chOff x="0" y="0"/>
-          <a:chExt cx="0" cy="0"/>
-        </a:xfrm>
-      </p:grpSpPr>
-      <p:sp>
-        <p:nvSpPr>
-          <p:cNvPr id="2" name="TextBox 2"/>
-          <p:cNvSpPr txBox="1"/>
-          <p:nvPr/>
-        </p:nvSpPr>
-        <p:spPr>
-          <a:xfrm>
             <a:off x="602742" y="711200"/>
             <a:ext cx="2261837" cy="264033"/>
           </a:xfrm>
@@ -7710,7 +7710,7 @@
             <a:r>
               <a:rPr lang="en-US" sz="1350" b="1" dirty="0">
                 <a:solidFill>
-                  <a:srgbClr val="FFFFFF"/>
+                  <a:srgbClr val="121314"/>
                 </a:solidFill>
                 <a:latin typeface="Microsoft JhengHei"/>
                 <a:ea typeface="Microsoft JhengHei"/>
@@ -7750,7 +7750,7 @@
             <a:r>
               <a:rPr lang="zh-TW" sz="4200" dirty="0">
                 <a:solidFill>
-                  <a:srgbClr val="FFFFFF"/>
+                  <a:srgbClr val="121314"/>
                 </a:solidFill>
                 <a:latin typeface="Microsoft JhengHei"/>
                 <a:ea typeface="Microsoft JhengHei"/>
@@ -7790,7 +7790,7 @@
             <a:r>
               <a:rPr lang="zh-TW" sz="4200" dirty="0">
                 <a:solidFill>
-                  <a:srgbClr val="FFFFFF"/>
+                  <a:srgbClr val="121314"/>
                 </a:solidFill>
                 <a:latin typeface="Microsoft JhengHei"/>
                 <a:ea typeface="Microsoft JhengHei"/>
@@ -7830,7 +7830,7 @@
             <a:r>
               <a:rPr lang="zh-TW" sz="4200" dirty="0">
                 <a:solidFill>
-                  <a:srgbClr val="FFFFFF"/>
+                  <a:srgbClr val="121314"/>
                 </a:solidFill>
                 <a:latin typeface="Microsoft JhengHei"/>
                 <a:ea typeface="Microsoft JhengHei"/>
@@ -7894,7 +7894,7 @@
             <a:r>
               <a:rPr lang="zh-TW" sz="2100" dirty="0">
                 <a:solidFill>
-                  <a:srgbClr val="FFFFFF"/>
+                  <a:srgbClr val="121314"/>
                 </a:solidFill>
                 <a:latin typeface="Microsoft JhengHei"/>
                 <a:ea typeface="Microsoft JhengHei"/>
@@ -7934,7 +7934,7 @@
             <a:r>
               <a:rPr lang="zh-TW" sz="1650" dirty="0">
                 <a:solidFill>
-                  <a:srgbClr val="FFFFFF"/>
+                  <a:srgbClr val="121314"/>
                 </a:solidFill>
                 <a:latin typeface="Microsoft JhengHei"/>
                 <a:ea typeface="Microsoft JhengHei"/>
@@ -7970,16 +7970,16 @@
         <a:srgbClr val="1F497D"/>
       </a:dk2>
       <a:lt2>
-        <a:srgbClr val="000000"/>
+        <a:srgbClr val="F2F7FC"/>
       </a:lt2>
       <a:accent1>
         <a:srgbClr val="0070D1"/>
       </a:accent1>
       <a:accent2>
-        <a:srgbClr val="53B1FF"/>
+        <a:srgbClr val="0070D1"/>
       </a:accent2>
       <a:accent3>
-        <a:srgbClr val="181818"/>
+        <a:srgbClr val="F5F7FA"/>
       </a:accent3>
       <a:accent4>
         <a:srgbClr val="0070D1"/>
@@ -7991,10 +7991,10 @@
         <a:srgbClr val="CCCCCC"/>
       </a:accent6>
       <a:hlink>
-        <a:srgbClr val="53B1FF"/>
+        <a:srgbClr val="0070D1"/>
       </a:hlink>
       <a:folHlink>
-        <a:srgbClr val="181818"/>
+        <a:srgbClr val="F5F7FA"/>
       </a:folHlink>
     </a:clrScheme>
     <a:fontScheme name="finals_editorial">
@@ -8290,16 +8290,16 @@
         <a:srgbClr val="1F497D"/>
       </a:dk2>
       <a:lt2>
-        <a:srgbClr val="000000"/>
+        <a:srgbClr val="F2F7FC"/>
       </a:lt2>
       <a:accent1>
         <a:srgbClr val="0070D1"/>
       </a:accent1>
       <a:accent2>
-        <a:srgbClr val="53B1FF"/>
+        <a:srgbClr val="0070D1"/>
       </a:accent2>
       <a:accent3>
-        <a:srgbClr val="181818"/>
+        <a:srgbClr val="F5F7FA"/>
       </a:accent3>
       <a:accent4>
         <a:srgbClr val="0070D1"/>
@@ -8311,10 +8311,10 @@
         <a:srgbClr val="CCCCCC"/>
       </a:accent6>
       <a:hlink>
-        <a:srgbClr val="53B1FF"/>
+        <a:srgbClr val="0070D1"/>
       </a:hlink>
       <a:folHlink>
-        <a:srgbClr val="181818"/>
+        <a:srgbClr val="F5F7FA"/>
       </a:folHlink>
     </a:clrScheme>
     <a:fontScheme name="finals_editorial">

</xml_diff>

<commit_message>
Deliver light-themed finals media and verify current local model chain (#6)
</commit_message>
<xml_diff>
--- a/deliverables/決賽簡報_AI資安框架.pptx
+++ b/deliverables/決賽簡報_AI資安框架.pptx
@@ -1282,7 +1282,7 @@
     <p:bg>
       <p:bgPr>
         <a:solidFill>
-          <a:schemeClr val="lt2"/>
+          <a:schemeClr val="lt1"/>
         </a:solidFill>
         <a:effectLst/>
       </p:bgPr>
@@ -1330,7 +1330,7 @@
             <a:r>
               <a:rPr lang="zh-TW" sz="1350" b="1" dirty="0">
                 <a:solidFill>
-                  <a:schemeClr val="accent2"/>
+                  <a:schemeClr val="accent1"/>
                 </a:solidFill>
                 <a:latin typeface="Microsoft JhengHei"/>
                 <a:ea typeface="Microsoft JhengHei"/>
@@ -1370,7 +1370,7 @@
             <a:r>
               <a:rPr lang="zh-TW" sz="3220" dirty="0">
                 <a:solidFill>
-                  <a:srgbClr val="FFFFFF"/>
+                  <a:srgbClr val="121314"/>
                 </a:solidFill>
                 <a:latin typeface="Microsoft JhengHei"/>
                 <a:ea typeface="Microsoft JhengHei"/>
@@ -1410,7 +1410,7 @@
             <a:r>
               <a:rPr lang="zh-TW" sz="3220" dirty="0">
                 <a:solidFill>
-                  <a:srgbClr val="FFFFFF"/>
+                  <a:srgbClr val="121314"/>
                 </a:solidFill>
                 <a:latin typeface="Microsoft JhengHei"/>
                 <a:ea typeface="Microsoft JhengHei"/>
@@ -1450,7 +1450,7 @@
             <a:r>
               <a:rPr lang="zh-TW" sz="3220" dirty="0">
                 <a:solidFill>
-                  <a:srgbClr val="FFFFFF"/>
+                  <a:srgbClr val="121314"/>
                 </a:solidFill>
                 <a:latin typeface="Microsoft JhengHei"/>
                 <a:ea typeface="Microsoft JhengHei"/>
@@ -1490,7 +1490,7 @@
             <a:r>
               <a:rPr lang="zh-TW" sz="2100" dirty="0">
                 <a:solidFill>
-                  <a:schemeClr val="accent6"/>
+                  <a:schemeClr val="accent5"/>
                 </a:solidFill>
                 <a:latin typeface="Microsoft JhengHei"/>
                 <a:ea typeface="Microsoft JhengHei"/>
@@ -1722,7 +1722,7 @@
             </a:avLst>
           </a:prstGeom>
           <a:solidFill>
-            <a:srgbClr val="F5F7FA"/>
+            <a:schemeClr val="accent3"/>
           </a:solidFill>
           <a:ln w="9525">
             <a:solidFill>
@@ -1972,7 +1972,7 @@
             </a:avLst>
           </a:prstGeom>
           <a:solidFill>
-            <a:srgbClr val="F5F7FA"/>
+            <a:schemeClr val="accent3"/>
           </a:solidFill>
           <a:ln w="9525">
             <a:solidFill>
@@ -2882,7 +2882,7 @@
             </a:avLst>
           </a:prstGeom>
           <a:solidFill>
-            <a:srgbClr val="F5F7FA"/>
+            <a:schemeClr val="accent3"/>
           </a:solidFill>
           <a:ln w="9525">
             <a:solidFill>
@@ -3722,7 +3722,7 @@
             </a:avLst>
           </a:prstGeom>
           <a:solidFill>
-            <a:srgbClr val="F5F7FA"/>
+            <a:schemeClr val="accent3"/>
           </a:solidFill>
           <a:ln w="9525">
             <a:solidFill>
@@ -4007,7 +4007,7 @@
             </a:avLst>
           </a:prstGeom>
           <a:solidFill>
-            <a:srgbClr val="F5F7FA"/>
+            <a:schemeClr val="accent3"/>
           </a:solidFill>
           <a:ln w="9525">
             <a:solidFill>
@@ -4153,7 +4153,7 @@
     <p:bg>
       <p:bgPr>
         <a:solidFill>
-          <a:schemeClr val="lt2"/>
+          <a:schemeClr val="lt1"/>
         </a:solidFill>
         <a:effectLst/>
       </p:bgPr>
@@ -4201,7 +4201,7 @@
             <a:r>
               <a:rPr lang="en-US" sz="1200" b="1" dirty="0">
                 <a:solidFill>
-                  <a:schemeClr val="accent2"/>
+                  <a:schemeClr val="accent1"/>
                 </a:solidFill>
                 <a:latin typeface="Microsoft JhengHei"/>
                 <a:ea typeface="Microsoft JhengHei"/>
@@ -4241,7 +4241,7 @@
             <a:r>
               <a:rPr lang="zh-TW" sz="3300" dirty="0">
                 <a:solidFill>
-                  <a:srgbClr val="FFFFFF"/>
+                  <a:srgbClr val="121314"/>
                 </a:solidFill>
                 <a:latin typeface="Microsoft JhengHei"/>
                 <a:ea typeface="Microsoft JhengHei"/>
@@ -4329,7 +4329,7 @@
             <a:r>
               <a:rPr lang="zh-TW" sz="1800" dirty="0">
                 <a:solidFill>
-                  <a:srgbClr val="FFFFFF"/>
+                  <a:srgbClr val="121314"/>
                 </a:solidFill>
                 <a:latin typeface="Microsoft JhengHei"/>
                 <a:ea typeface="Microsoft JhengHei"/>
@@ -4393,7 +4393,7 @@
             <a:r>
               <a:rPr lang="en-US" sz="2250" b="1" dirty="0">
                 <a:solidFill>
-                  <a:srgbClr val="FFFFFF"/>
+                  <a:srgbClr val="121314"/>
                 </a:solidFill>
                 <a:latin typeface="Microsoft JhengHei"/>
                 <a:ea typeface="Microsoft JhengHei"/>
@@ -4433,7 +4433,7 @@
             <a:r>
               <a:rPr lang="ja-JP" sz="1800" dirty="0">
                 <a:solidFill>
-                  <a:schemeClr val="accent6"/>
+                  <a:schemeClr val="accent5"/>
                 </a:solidFill>
                 <a:latin typeface="Microsoft JhengHei"/>
                 <a:ea typeface="Microsoft JhengHei"/>
@@ -4497,7 +4497,7 @@
             <a:r>
               <a:rPr lang="en-US" sz="2250" b="1" dirty="0">
                 <a:solidFill>
-                  <a:srgbClr val="FFFFFF"/>
+                  <a:srgbClr val="121314"/>
                 </a:solidFill>
                 <a:latin typeface="Microsoft JhengHei"/>
                 <a:ea typeface="Microsoft JhengHei"/>
@@ -4537,7 +4537,7 @@
             <a:r>
               <a:rPr lang="zh-TW" sz="1800" dirty="0">
                 <a:solidFill>
-                  <a:schemeClr val="accent6"/>
+                  <a:schemeClr val="accent5"/>
                 </a:solidFill>
                 <a:latin typeface="Microsoft JhengHei"/>
                 <a:ea typeface="Microsoft JhengHei"/>
@@ -4615,7 +4615,7 @@
           <a:noFill/>
           <a:ln w="28575">
             <a:solidFill>
-              <a:schemeClr val="accent2"/>
+              <a:schemeClr val="accent1"/>
             </a:solidFill>
           </a:ln>
         </p:spPr>
@@ -4672,7 +4672,7 @@
           <a:noFill/>
           <a:ln w="28575">
             <a:solidFill>
-              <a:schemeClr val="accent2"/>
+              <a:schemeClr val="accent1"/>
             </a:solidFill>
           </a:ln>
         </p:spPr>
@@ -4730,7 +4730,7 @@
             <a:r>
               <a:rPr lang="zh-TW" sz="2250" dirty="0">
                 <a:solidFill>
-                  <a:srgbClr val="FFFFFF"/>
+                  <a:srgbClr val="121314"/>
                 </a:solidFill>
                 <a:latin typeface="Microsoft JhengHei"/>
                 <a:ea typeface="Microsoft JhengHei"/>
@@ -4770,7 +4770,7 @@
             <a:r>
               <a:rPr lang="zh-TW" sz="1800" dirty="0">
                 <a:solidFill>
-                  <a:schemeClr val="accent6"/>
+                  <a:schemeClr val="accent5"/>
                 </a:solidFill>
                 <a:latin typeface="Microsoft JhengHei"/>
                 <a:ea typeface="Microsoft JhengHei"/>
@@ -4834,7 +4834,7 @@
             <a:r>
               <a:rPr lang="zh-TW" sz="1800" dirty="0">
                 <a:solidFill>
-                  <a:srgbClr val="FFFFFF"/>
+                  <a:srgbClr val="121314"/>
                 </a:solidFill>
                 <a:latin typeface="Microsoft JhengHei"/>
                 <a:ea typeface="Microsoft JhengHei"/>
@@ -4874,7 +4874,7 @@
             <a:r>
               <a:rPr lang="zh-TW" sz="1050" dirty="0">
                 <a:solidFill>
-                  <a:schemeClr val="accent6"/>
+                  <a:schemeClr val="accent5"/>
                 </a:solidFill>
                 <a:latin typeface="Microsoft JhengHei"/>
                 <a:ea typeface="Microsoft JhengHei"/>
@@ -4914,7 +4914,7 @@
             <a:r>
               <a:rPr lang="zh-TW" sz="1050" dirty="0">
                 <a:solidFill>
-                  <a:schemeClr val="accent6"/>
+                  <a:schemeClr val="accent5"/>
                 </a:solidFill>
                 <a:latin typeface="Microsoft JhengHei"/>
                 <a:ea typeface="Microsoft JhengHei"/>
@@ -5082,7 +5082,7 @@
             </a:avLst>
           </a:prstGeom>
           <a:solidFill>
-            <a:srgbClr val="F5F7FA"/>
+            <a:schemeClr val="accent3"/>
           </a:solidFill>
           <a:ln>
             <a:noFill/>
@@ -5186,7 +5186,7 @@
             </a:avLst>
           </a:prstGeom>
           <a:solidFill>
-            <a:srgbClr val="F5F7FA"/>
+            <a:schemeClr val="accent3"/>
           </a:solidFill>
           <a:ln>
             <a:noFill/>
@@ -5290,7 +5290,7 @@
             </a:avLst>
           </a:prstGeom>
           <a:solidFill>
-            <a:srgbClr val="F5F7FA"/>
+            <a:schemeClr val="accent3"/>
           </a:solidFill>
           <a:ln>
             <a:noFill/>
@@ -5514,7 +5514,7 @@
     <p:bg>
       <p:bgPr>
         <a:solidFill>
-          <a:schemeClr val="lt2"/>
+          <a:schemeClr val="lt1"/>
         </a:solidFill>
         <a:effectLst/>
       </p:bgPr>
@@ -5562,7 +5562,7 @@
             <a:r>
               <a:rPr lang="en-US" sz="1200" b="1" dirty="0">
                 <a:solidFill>
-                  <a:schemeClr val="accent2"/>
+                  <a:schemeClr val="accent1"/>
                 </a:solidFill>
                 <a:latin typeface="Microsoft JhengHei"/>
                 <a:ea typeface="Microsoft JhengHei"/>
@@ -5602,7 +5602,7 @@
             <a:r>
               <a:rPr lang="zh-TW" sz="3300" dirty="0">
                 <a:solidFill>
-                  <a:srgbClr val="FFFFFF"/>
+                  <a:srgbClr val="121314"/>
                 </a:solidFill>
                 <a:latin typeface="Microsoft JhengHei"/>
                 <a:ea typeface="Microsoft JhengHei"/>
@@ -5666,7 +5666,7 @@
             <a:r>
               <a:rPr lang="zh-TW" sz="1500" dirty="0">
                 <a:solidFill>
-                  <a:schemeClr val="accent2"/>
+                  <a:schemeClr val="accent1"/>
                 </a:solidFill>
                 <a:latin typeface="Microsoft JhengHei"/>
                 <a:ea typeface="Microsoft JhengHei"/>
@@ -5706,7 +5706,7 @@
             <a:r>
               <a:rPr lang="zh-TW" sz="2400" dirty="0">
                 <a:solidFill>
-                  <a:srgbClr val="FFFFFF"/>
+                  <a:srgbClr val="121314"/>
                 </a:solidFill>
                 <a:latin typeface="Microsoft JhengHei"/>
                 <a:ea typeface="Microsoft JhengHei"/>
@@ -5746,7 +5746,7 @@
             <a:r>
               <a:rPr lang="zh-TW" sz="1650" dirty="0">
                 <a:solidFill>
-                  <a:schemeClr val="accent6"/>
+                  <a:schemeClr val="accent5"/>
                 </a:solidFill>
                 <a:latin typeface="Microsoft JhengHei"/>
                 <a:ea typeface="Microsoft JhengHei"/>
@@ -5810,7 +5810,7 @@
             <a:r>
               <a:rPr lang="zh-TW" sz="1500" dirty="0">
                 <a:solidFill>
-                  <a:schemeClr val="accent2"/>
+                  <a:schemeClr val="accent1"/>
                 </a:solidFill>
                 <a:latin typeface="Microsoft JhengHei"/>
                 <a:ea typeface="Microsoft JhengHei"/>
@@ -5850,7 +5850,7 @@
             <a:r>
               <a:rPr lang="zh-TW" sz="2400" dirty="0">
                 <a:solidFill>
-                  <a:srgbClr val="FFFFFF"/>
+                  <a:srgbClr val="121314"/>
                 </a:solidFill>
                 <a:latin typeface="Microsoft JhengHei"/>
                 <a:ea typeface="Microsoft JhengHei"/>
@@ -5890,7 +5890,7 @@
             <a:r>
               <a:rPr lang="zh-TW" sz="1650" dirty="0">
                 <a:solidFill>
-                  <a:schemeClr val="accent6"/>
+                  <a:schemeClr val="accent5"/>
                 </a:solidFill>
                 <a:latin typeface="Microsoft JhengHei"/>
                 <a:ea typeface="Microsoft JhengHei"/>
@@ -5954,7 +5954,7 @@
             <a:r>
               <a:rPr lang="zh-TW" sz="1500" dirty="0">
                 <a:solidFill>
-                  <a:schemeClr val="accent2"/>
+                  <a:schemeClr val="accent1"/>
                 </a:solidFill>
                 <a:latin typeface="Microsoft JhengHei"/>
                 <a:ea typeface="Microsoft JhengHei"/>
@@ -5994,7 +5994,7 @@
             <a:r>
               <a:rPr lang="zh-TW" sz="2400" dirty="0">
                 <a:solidFill>
-                  <a:srgbClr val="FFFFFF"/>
+                  <a:srgbClr val="121314"/>
                 </a:solidFill>
                 <a:latin typeface="Microsoft JhengHei"/>
                 <a:ea typeface="Microsoft JhengHei"/>
@@ -6034,7 +6034,7 @@
             <a:r>
               <a:rPr lang="zh-TW" sz="1650" dirty="0">
                 <a:solidFill>
-                  <a:schemeClr val="accent6"/>
+                  <a:schemeClr val="accent5"/>
                 </a:solidFill>
                 <a:latin typeface="Microsoft JhengHei"/>
                 <a:ea typeface="Microsoft JhengHei"/>
@@ -6074,7 +6074,7 @@
             <a:r>
               <a:rPr lang="zh-TW" sz="2020" dirty="0">
                 <a:solidFill>
-                  <a:srgbClr val="FFFFFF"/>
+                  <a:srgbClr val="121314"/>
                 </a:solidFill>
                 <a:latin typeface="Microsoft JhengHei"/>
                 <a:ea typeface="Microsoft JhengHei"/>
@@ -6114,7 +6114,7 @@
             <a:r>
               <a:rPr lang="zh-TW" sz="1650" dirty="0">
                 <a:solidFill>
-                  <a:schemeClr val="accent6"/>
+                  <a:schemeClr val="accent5"/>
                 </a:solidFill>
                 <a:latin typeface="Microsoft JhengHei"/>
                 <a:ea typeface="Microsoft JhengHei"/>
@@ -6154,7 +6154,7 @@
             <a:r>
               <a:rPr lang="zh-TW" sz="1050" dirty="0">
                 <a:solidFill>
-                  <a:schemeClr val="accent6"/>
+                  <a:schemeClr val="accent5"/>
                 </a:solidFill>
                 <a:latin typeface="Microsoft JhengHei"/>
                 <a:ea typeface="Microsoft JhengHei"/>
@@ -6194,7 +6194,7 @@
             <a:r>
               <a:rPr lang="zh-TW" sz="1050" dirty="0">
                 <a:solidFill>
-                  <a:schemeClr val="accent6"/>
+                  <a:schemeClr val="accent5"/>
                 </a:solidFill>
                 <a:latin typeface="Microsoft JhengHei"/>
                 <a:ea typeface="Microsoft JhengHei"/>
@@ -6738,7 +6738,7 @@
             </a:avLst>
           </a:prstGeom>
           <a:solidFill>
-            <a:srgbClr val="F5F7FA"/>
+            <a:schemeClr val="accent3"/>
           </a:solidFill>
           <a:ln>
             <a:noFill/>
@@ -6957,6 +6957,706 @@
 </file>
 
 <file path=ppt/slides/slide7.xml><?xml version="1.0" encoding="utf-8"?>
+<p:sld xmlns:a="http://schemas.openxmlformats.org/drawingml/2006/main" xmlns:r="http://schemas.openxmlformats.org/officeDocument/2006/relationships" xmlns:p="http://schemas.openxmlformats.org/presentationml/2006/main">
+  <p:cSld>
+    <p:bg>
+      <p:bgPr>
+        <a:solidFill>
+          <a:schemeClr val="lt1"/>
+        </a:solidFill>
+        <a:effectLst/>
+      </p:bgPr>
+    </p:bg>
+    <p:spTree>
+      <p:nvGrpSpPr>
+        <p:cNvPr id="1" name=""/>
+        <p:cNvGrpSpPr/>
+        <p:nvPr/>
+      </p:nvGrpSpPr>
+      <p:grpSpPr>
+        <a:xfrm>
+          <a:off x="0" y="0"/>
+          <a:ext cx="0" cy="0"/>
+          <a:chOff x="0" y="0"/>
+          <a:chExt cx="0" cy="0"/>
+        </a:xfrm>
+      </p:grpSpPr>
+      <p:sp>
+        <p:nvSpPr>
+          <p:cNvPr id="2" name="TextBox 2"/>
+          <p:cNvSpPr txBox="1"/>
+          <p:nvPr/>
+        </p:nvSpPr>
+        <p:spPr>
+          <a:xfrm>
+            <a:off x="603504" y="390525"/>
+            <a:ext cx="1580388" cy="234696"/>
+          </a:xfrm>
+          <a:prstGeom prst="rect">
+            <a:avLst/>
+          </a:prstGeom>
+          <a:noFill/>
+          <a:ln>
+            <a:noFill/>
+          </a:ln>
+        </p:spPr>
+        <p:txBody>
+          <a:bodyPr wrap="none" lIns="0" tIns="0" rIns="0" bIns="0" anchor="t" anchorCtr="0">
+            <a:spAutoFit/>
+          </a:bodyPr>
+          <a:lstStyle/>
+          <a:p>
+            <a:pPr algn="l"/>
+            <a:r>
+              <a:rPr lang="en-US" sz="1200" b="1" dirty="0">
+                <a:solidFill>
+                  <a:schemeClr val="accent1"/>
+                </a:solidFill>
+                <a:latin typeface="Microsoft JhengHei"/>
+                <a:ea typeface="Microsoft JhengHei"/>
+                <a:cs typeface="Microsoft JhengHei"/>
+              </a:rPr>
+              <a:t>MEASURED RESULTS</a:t>
+            </a:r>
+          </a:p>
+        </p:txBody>
+      </p:sp>
+      <p:sp>
+        <p:nvSpPr>
+          <p:cNvPr id="3" name="TextBox 3"/>
+          <p:cNvSpPr txBox="1"/>
+          <p:nvPr/>
+        </p:nvSpPr>
+        <p:spPr>
+          <a:xfrm>
+            <a:off x="592836" y="736600"/>
+            <a:ext cx="6252972" cy="645414"/>
+          </a:xfrm>
+          <a:prstGeom prst="rect">
+            <a:avLst/>
+          </a:prstGeom>
+          <a:noFill/>
+          <a:ln>
+            <a:noFill/>
+          </a:ln>
+        </p:spPr>
+        <p:txBody>
+          <a:bodyPr wrap="none" lIns="0" tIns="0" rIns="0" bIns="0" anchor="t" anchorCtr="0">
+            <a:spAutoFit/>
+          </a:bodyPr>
+          <a:lstStyle/>
+          <a:p>
+            <a:pPr algn="l"/>
+            <a:r>
+              <a:rPr lang="zh-TW" sz="3300" dirty="0">
+                <a:solidFill>
+                  <a:srgbClr val="121314"/>
+                </a:solidFill>
+                <a:latin typeface="Microsoft JhengHei"/>
+                <a:ea typeface="Microsoft JhengHei"/>
+                <a:cs typeface="Microsoft JhengHei"/>
+              </a:rPr>
+              <a:t>從相似案例，走到可核對的結論</a:t>
+            </a:r>
+          </a:p>
+        </p:txBody>
+      </p:sp>
+      <p:sp>
+        <p:nvSpPr>
+          <p:cNvPr id="4" name="TextBox 4"/>
+          <p:cNvSpPr txBox="1"/>
+          <p:nvPr/>
+        </p:nvSpPr>
+        <p:spPr>
+          <a:xfrm>
+            <a:off x="590550" y="2038350"/>
+            <a:ext cx="1946338" cy="790575"/>
+          </a:xfrm>
+          <a:prstGeom prst="rect">
+            <a:avLst/>
+          </a:prstGeom>
+          <a:noFill/>
+          <a:ln>
+            <a:noFill/>
+          </a:ln>
+        </p:spPr>
+        <p:txBody>
+          <a:bodyPr wrap="none" lIns="0" tIns="0" rIns="0" bIns="0" anchor="t" anchorCtr="0">
+            <a:spAutoFit/>
+          </a:bodyPr>
+          <a:lstStyle/>
+          <a:p>
+            <a:pPr algn="l"/>
+            <a:r>
+              <a:rPr lang="zh-TW" sz="4050" dirty="0">
+                <a:solidFill>
+                  <a:srgbClr val="121314"/>
+                </a:solidFill>
+                <a:latin typeface="Microsoft JhengHei"/>
+                <a:ea typeface="Microsoft JhengHei"/>
+                <a:cs typeface="Microsoft JhengHei"/>
+              </a:rPr>
+              <a:t>97.62%</a:t>
+            </a:r>
+          </a:p>
+        </p:txBody>
+      </p:sp>
+      <p:sp>
+        <p:nvSpPr>
+          <p:cNvPr id="5" name="TextBox 5"/>
+          <p:cNvSpPr txBox="1"/>
+          <p:nvPr/>
+        </p:nvSpPr>
+        <p:spPr>
+          <a:xfrm>
+            <a:off x="598932" y="2870200"/>
+            <a:ext cx="1747952" cy="410718"/>
+          </a:xfrm>
+          <a:prstGeom prst="rect">
+            <a:avLst/>
+          </a:prstGeom>
+          <a:noFill/>
+          <a:ln>
+            <a:noFill/>
+          </a:ln>
+        </p:spPr>
+        <p:txBody>
+          <a:bodyPr wrap="none" lIns="0" tIns="0" rIns="0" bIns="0" anchor="t" anchorCtr="0">
+            <a:spAutoFit/>
+          </a:bodyPr>
+          <a:lstStyle/>
+          <a:p>
+            <a:pPr algn="l"/>
+            <a:r>
+              <a:rPr lang="zh-TW" sz="2100" dirty="0">
+                <a:solidFill>
+                  <a:srgbClr val="121314"/>
+                </a:solidFill>
+                <a:latin typeface="Microsoft JhengHei"/>
+                <a:ea typeface="Microsoft JhengHei"/>
+                <a:cs typeface="Microsoft JhengHei"/>
+              </a:rPr>
+              <a:t>Top-5 命中率</a:t>
+            </a:r>
+          </a:p>
+        </p:txBody>
+      </p:sp>
+      <p:sp>
+        <p:nvSpPr>
+          <p:cNvPr id="6" name="TextBox 6"/>
+          <p:cNvSpPr txBox="1"/>
+          <p:nvPr/>
+        </p:nvSpPr>
+        <p:spPr>
+          <a:xfrm>
+            <a:off x="602361" y="3479800"/>
+            <a:ext cx="2690724" cy="278702"/>
+          </a:xfrm>
+          <a:prstGeom prst="rect">
+            <a:avLst/>
+          </a:prstGeom>
+          <a:noFill/>
+          <a:ln>
+            <a:noFill/>
+          </a:ln>
+        </p:spPr>
+        <p:txBody>
+          <a:bodyPr wrap="none" lIns="0" tIns="0" rIns="0" bIns="0" anchor="t" anchorCtr="0">
+            <a:spAutoFit/>
+          </a:bodyPr>
+          <a:lstStyle/>
+          <a:p>
+            <a:pPr algn="l"/>
+            <a:r>
+              <a:rPr lang="zh-TW" sz="1420" dirty="0">
+                <a:solidFill>
+                  <a:schemeClr val="accent5"/>
+                </a:solidFill>
+                <a:latin typeface="Microsoft JhengHei"/>
+                <a:ea typeface="Microsoft JhengHei"/>
+                <a:cs typeface="Microsoft JhengHei"/>
+              </a:rPr>
+              <a:t>463 筆查詢／1,550 筆訓練案例</a:t>
+            </a:r>
+          </a:p>
+        </p:txBody>
+      </p:sp>
+      <p:sp>
+        <p:nvSpPr>
+          <p:cNvPr id="7" name="TextBox 7"/>
+          <p:cNvSpPr txBox="1"/>
+          <p:nvPr/>
+        </p:nvSpPr>
+        <p:spPr>
+          <a:xfrm>
+            <a:off x="4352925" y="2038350"/>
+            <a:ext cx="1946338" cy="790575"/>
+          </a:xfrm>
+          <a:prstGeom prst="rect">
+            <a:avLst/>
+          </a:prstGeom>
+          <a:noFill/>
+          <a:ln>
+            <a:noFill/>
+          </a:ln>
+        </p:spPr>
+        <p:txBody>
+          <a:bodyPr wrap="none" lIns="0" tIns="0" rIns="0" bIns="0" anchor="t" anchorCtr="0">
+            <a:spAutoFit/>
+          </a:bodyPr>
+          <a:lstStyle/>
+          <a:p>
+            <a:pPr algn="l"/>
+            <a:r>
+              <a:rPr lang="zh-TW" sz="4050" dirty="0">
+                <a:solidFill>
+                  <a:srgbClr val="121314"/>
+                </a:solidFill>
+                <a:latin typeface="Microsoft JhengHei"/>
+                <a:ea typeface="Microsoft JhengHei"/>
+                <a:cs typeface="Microsoft JhengHei"/>
+              </a:rPr>
+              <a:t>93.89%</a:t>
+            </a:r>
+          </a:p>
+        </p:txBody>
+      </p:sp>
+      <p:sp>
+        <p:nvSpPr>
+          <p:cNvPr id="8" name="TextBox 8"/>
+          <p:cNvSpPr txBox="1"/>
+          <p:nvPr/>
+        </p:nvSpPr>
+        <p:spPr>
+          <a:xfrm>
+            <a:off x="4361307" y="2870200"/>
+            <a:ext cx="902513" cy="410718"/>
+          </a:xfrm>
+          <a:prstGeom prst="rect">
+            <a:avLst/>
+          </a:prstGeom>
+          <a:noFill/>
+          <a:ln>
+            <a:noFill/>
+          </a:ln>
+        </p:spPr>
+        <p:txBody>
+          <a:bodyPr wrap="none" lIns="0" tIns="0" rIns="0" bIns="0" anchor="t" anchorCtr="0">
+            <a:spAutoFit/>
+          </a:bodyPr>
+          <a:lstStyle/>
+          <a:p>
+            <a:pPr algn="l"/>
+            <a:r>
+              <a:rPr lang="en-US" sz="2100" dirty="0">
+                <a:solidFill>
+                  <a:srgbClr val="121314"/>
+                </a:solidFill>
+                <a:latin typeface="Microsoft JhengHei"/>
+                <a:ea typeface="Microsoft JhengHei"/>
+                <a:cs typeface="Microsoft JhengHei"/>
+              </a:rPr>
+              <a:t>MRR@5</a:t>
+            </a:r>
+          </a:p>
+        </p:txBody>
+      </p:sp>
+      <p:sp>
+        <p:nvSpPr>
+          <p:cNvPr id="9" name="TextBox 9"/>
+          <p:cNvSpPr txBox="1"/>
+          <p:nvPr/>
+        </p:nvSpPr>
+        <p:spPr>
+          <a:xfrm>
+            <a:off x="4364736" y="3479800"/>
+            <a:ext cx="1926082" cy="278702"/>
+          </a:xfrm>
+          <a:prstGeom prst="rect">
+            <a:avLst/>
+          </a:prstGeom>
+          <a:noFill/>
+          <a:ln>
+            <a:noFill/>
+          </a:ln>
+        </p:spPr>
+        <p:txBody>
+          <a:bodyPr wrap="none" lIns="0" tIns="0" rIns="0" bIns="0" anchor="t" anchorCtr="0">
+            <a:spAutoFit/>
+          </a:bodyPr>
+          <a:lstStyle/>
+          <a:p>
+            <a:pPr algn="l"/>
+            <a:r>
+              <a:rPr lang="zh-TW" sz="1420" dirty="0">
+                <a:solidFill>
+                  <a:schemeClr val="accent5"/>
+                </a:solidFill>
+                <a:latin typeface="Microsoft JhengHei"/>
+                <a:ea typeface="Microsoft JhengHei"/>
+                <a:cs typeface="Microsoft JhengHei"/>
+              </a:rPr>
+              <a:t>前五筆結果的排序品質</a:t>
+            </a:r>
+          </a:p>
+        </p:txBody>
+      </p:sp>
+      <p:sp>
+        <p:nvSpPr>
+          <p:cNvPr id="10" name="TextBox 10"/>
+          <p:cNvSpPr txBox="1"/>
+          <p:nvPr/>
+        </p:nvSpPr>
+        <p:spPr>
+          <a:xfrm>
+            <a:off x="8115300" y="2038350"/>
+            <a:ext cx="1946338" cy="790575"/>
+          </a:xfrm>
+          <a:prstGeom prst="rect">
+            <a:avLst/>
+          </a:prstGeom>
+          <a:noFill/>
+          <a:ln>
+            <a:noFill/>
+          </a:ln>
+        </p:spPr>
+        <p:txBody>
+          <a:bodyPr wrap="none" lIns="0" tIns="0" rIns="0" bIns="0" anchor="t" anchorCtr="0">
+            <a:spAutoFit/>
+          </a:bodyPr>
+          <a:lstStyle/>
+          <a:p>
+            <a:pPr algn="l"/>
+            <a:r>
+              <a:rPr lang="zh-TW" sz="4050" dirty="0">
+                <a:solidFill>
+                  <a:srgbClr val="121314"/>
+                </a:solidFill>
+                <a:latin typeface="Microsoft JhengHei"/>
+                <a:ea typeface="Microsoft JhengHei"/>
+                <a:cs typeface="Microsoft JhengHei"/>
+              </a:rPr>
+              <a:t>97.11%</a:t>
+            </a:r>
+          </a:p>
+        </p:txBody>
+      </p:sp>
+      <p:sp>
+        <p:nvSpPr>
+          <p:cNvPr id="11" name="TextBox 11"/>
+          <p:cNvSpPr txBox="1"/>
+          <p:nvPr/>
+        </p:nvSpPr>
+        <p:spPr>
+          <a:xfrm>
+            <a:off x="8123682" y="2870200"/>
+            <a:ext cx="1434846" cy="410718"/>
+          </a:xfrm>
+          <a:prstGeom prst="rect">
+            <a:avLst/>
+          </a:prstGeom>
+          <a:noFill/>
+          <a:ln>
+            <a:noFill/>
+          </a:ln>
+        </p:spPr>
+        <p:txBody>
+          <a:bodyPr wrap="none" lIns="0" tIns="0" rIns="0" bIns="0" anchor="t" anchorCtr="0">
+            <a:spAutoFit/>
+          </a:bodyPr>
+          <a:lstStyle/>
+          <a:p>
+            <a:pPr algn="l"/>
+            <a:r>
+              <a:rPr lang="zh-TW" sz="2100" dirty="0">
+                <a:solidFill>
+                  <a:srgbClr val="121314"/>
+                </a:solidFill>
+                <a:latin typeface="Microsoft JhengHei"/>
+                <a:ea typeface="Microsoft JhengHei"/>
+                <a:cs typeface="Microsoft JhengHei"/>
+              </a:rPr>
+              <a:t>支持精確率</a:t>
+            </a:r>
+          </a:p>
+        </p:txBody>
+      </p:sp>
+      <p:sp>
+        <p:nvSpPr>
+          <p:cNvPr id="12" name="TextBox 12"/>
+          <p:cNvSpPr txBox="1"/>
+          <p:nvPr/>
+        </p:nvSpPr>
+        <p:spPr>
+          <a:xfrm>
+            <a:off x="8127111" y="3479800"/>
+            <a:ext cx="2642934" cy="278702"/>
+          </a:xfrm>
+          <a:prstGeom prst="rect">
+            <a:avLst/>
+          </a:prstGeom>
+          <a:noFill/>
+          <a:ln>
+            <a:noFill/>
+          </a:ln>
+        </p:spPr>
+        <p:txBody>
+          <a:bodyPr wrap="none" lIns="0" tIns="0" rIns="0" bIns="0" anchor="t" anchorCtr="0">
+            <a:spAutoFit/>
+          </a:bodyPr>
+          <a:lstStyle/>
+          <a:p>
+            <a:pPr algn="l"/>
+            <a:r>
+              <a:rPr lang="zh-TW" sz="1420" dirty="0">
+                <a:solidFill>
+                  <a:schemeClr val="accent5"/>
+                </a:solidFill>
+                <a:latin typeface="Microsoft JhengHei"/>
+                <a:ea typeface="Microsoft JhengHei"/>
+                <a:cs typeface="Microsoft JhengHei"/>
+              </a:rPr>
+              <a:t>415 支持／13 複核／35 不確定</a:t>
+            </a:r>
+          </a:p>
+        </p:txBody>
+      </p:sp>
+      <p:sp>
+        <p:nvSpPr>
+          <p:cNvPr id="13" name="Rectangle 13"/>
+          <p:cNvSpPr/>
+          <p:nvPr/>
+        </p:nvSpPr>
+        <p:spPr>
+          <a:xfrm>
+            <a:off x="609600" y="4533900"/>
+            <a:ext cx="10972800" cy="1238250"/>
+          </a:xfrm>
+          <a:prstGeom prst="roundRect">
+            <a:avLst>
+              <a:gd name="adj" fmla="val 6154"/>
+            </a:avLst>
+          </a:prstGeom>
+          <a:solidFill>
+            <a:schemeClr val="accent3"/>
+          </a:solidFill>
+          <a:ln>
+            <a:noFill/>
+          </a:ln>
+        </p:spPr>
+      </p:sp>
+      <p:sp>
+        <p:nvSpPr>
+          <p:cNvPr id="14" name="TextBox 14"/>
+          <p:cNvSpPr txBox="1"/>
+          <p:nvPr/>
+        </p:nvSpPr>
+        <p:spPr>
+          <a:xfrm>
+            <a:off x="821055" y="4581525"/>
+            <a:ext cx="1558592" cy="661035"/>
+          </a:xfrm>
+          <a:prstGeom prst="rect">
+            <a:avLst/>
+          </a:prstGeom>
+          <a:noFill/>
+          <a:ln>
+            <a:noFill/>
+          </a:ln>
+        </p:spPr>
+        <p:txBody>
+          <a:bodyPr wrap="none" lIns="0" tIns="0" rIns="0" bIns="0" anchor="t" anchorCtr="0">
+            <a:spAutoFit/>
+          </a:bodyPr>
+          <a:lstStyle/>
+          <a:p>
+            <a:pPr algn="l"/>
+            <a:r>
+              <a:rPr lang="zh-TW" sz="3380" dirty="0">
+                <a:solidFill>
+                  <a:schemeClr val="accent1"/>
+                </a:solidFill>
+                <a:latin typeface="Microsoft JhengHei"/>
+                <a:ea typeface="Microsoft JhengHei"/>
+                <a:cs typeface="Microsoft JhengHei"/>
+              </a:rPr>
+              <a:t>18 / 30</a:t>
+            </a:r>
+          </a:p>
+        </p:txBody>
+      </p:sp>
+      <p:sp>
+        <p:nvSpPr>
+          <p:cNvPr id="15" name="TextBox 15"/>
+          <p:cNvSpPr txBox="1"/>
+          <p:nvPr/>
+        </p:nvSpPr>
+        <p:spPr>
+          <a:xfrm>
+            <a:off x="3704844" y="4759325"/>
+            <a:ext cx="3432429" cy="381381"/>
+          </a:xfrm>
+          <a:prstGeom prst="rect">
+            <a:avLst/>
+          </a:prstGeom>
+          <a:noFill/>
+          <a:ln>
+            <a:noFill/>
+          </a:ln>
+        </p:spPr>
+        <p:txBody>
+          <a:bodyPr wrap="none" lIns="0" tIns="0" rIns="0" bIns="0" anchor="t" anchorCtr="0">
+            <a:spAutoFit/>
+          </a:bodyPr>
+          <a:lstStyle/>
+          <a:p>
+            <a:pPr algn="l"/>
+            <a:r>
+              <a:rPr lang="zh-TW" sz="1950" dirty="0">
+                <a:solidFill>
+                  <a:srgbClr val="121314"/>
+                </a:solidFill>
+                <a:latin typeface="Microsoft JhengHei"/>
+                <a:ea typeface="Microsoft JhengHei"/>
+                <a:cs typeface="Microsoft JhengHei"/>
+              </a:rPr>
+              <a:t>偵測誤判分流至複核或不確定</a:t>
+            </a:r>
+          </a:p>
+        </p:txBody>
+      </p:sp>
+      <p:sp>
+        <p:nvSpPr>
+          <p:cNvPr id="16" name="TextBox 16"/>
+          <p:cNvSpPr txBox="1"/>
+          <p:nvPr/>
+        </p:nvSpPr>
+        <p:spPr>
+          <a:xfrm>
+            <a:off x="829437" y="5213350"/>
+            <a:ext cx="5392898" cy="337376"/>
+          </a:xfrm>
+          <a:prstGeom prst="rect">
+            <a:avLst/>
+          </a:prstGeom>
+          <a:noFill/>
+          <a:ln>
+            <a:noFill/>
+          </a:ln>
+        </p:spPr>
+        <p:txBody>
+          <a:bodyPr wrap="none" lIns="0" tIns="0" rIns="0" bIns="0" anchor="t" anchorCtr="0">
+            <a:spAutoFit/>
+          </a:bodyPr>
+          <a:lstStyle/>
+          <a:p>
+            <a:pPr algn="l"/>
+            <a:r>
+              <a:rPr lang="zh-TW" sz="1720" dirty="0">
+                <a:solidFill>
+                  <a:schemeClr val="accent5"/>
+                </a:solidFill>
+                <a:latin typeface="Microsoft JhengHei"/>
+                <a:ea typeface="Microsoft JhengHei"/>
+                <a:cs typeface="Microsoft JhengHei"/>
+              </a:rPr>
+              <a:t>AI 依案例證據給出稽核結論；正式分類保持可追溯。</a:t>
+            </a:r>
+          </a:p>
+        </p:txBody>
+      </p:sp>
+      <p:sp>
+        <p:nvSpPr>
+          <p:cNvPr id="17" name="TextBox 17"/>
+          <p:cNvSpPr txBox="1"/>
+          <p:nvPr/>
+        </p:nvSpPr>
+        <p:spPr>
+          <a:xfrm>
+            <a:off x="604266" y="6416675"/>
+            <a:ext cx="1617135" cy="205359"/>
+          </a:xfrm>
+          <a:prstGeom prst="rect">
+            <a:avLst/>
+          </a:prstGeom>
+          <a:noFill/>
+          <a:ln>
+            <a:noFill/>
+          </a:ln>
+        </p:spPr>
+        <p:txBody>
+          <a:bodyPr wrap="none" lIns="0" tIns="0" rIns="0" bIns="0" anchor="t" anchorCtr="0">
+            <a:spAutoFit/>
+          </a:bodyPr>
+          <a:lstStyle/>
+          <a:p>
+            <a:pPr algn="l"/>
+            <a:r>
+              <a:rPr lang="zh-TW" sz="1050" dirty="0">
+                <a:solidFill>
+                  <a:schemeClr val="accent5"/>
+                </a:solidFill>
+                <a:latin typeface="Microsoft JhengHei"/>
+                <a:ea typeface="Microsoft JhengHei"/>
+                <a:cs typeface="Microsoft JhengHei"/>
+              </a:rPr>
+              <a:t>AI 資安框架 · 資安技術組</a:t>
+            </a:r>
+          </a:p>
+        </p:txBody>
+      </p:sp>
+      <p:sp>
+        <p:nvSpPr>
+          <p:cNvPr id="18" name="TextBox 18"/>
+          <p:cNvSpPr txBox="1"/>
+          <p:nvPr/>
+        </p:nvSpPr>
+        <p:spPr>
+          <a:xfrm>
+            <a:off x="11103540" y="6416675"/>
+            <a:ext cx="484194" cy="205359"/>
+          </a:xfrm>
+          <a:prstGeom prst="rect">
+            <a:avLst/>
+          </a:prstGeom>
+          <a:noFill/>
+          <a:ln>
+            <a:noFill/>
+          </a:ln>
+        </p:spPr>
+        <p:txBody>
+          <a:bodyPr wrap="none" lIns="0" tIns="0" rIns="0" bIns="0" anchor="t" anchorCtr="0">
+            <a:spAutoFit/>
+          </a:bodyPr>
+          <a:lstStyle/>
+          <a:p>
+            <a:pPr algn="r"/>
+            <a:r>
+              <a:rPr lang="zh-TW" sz="1050" dirty="0">
+                <a:solidFill>
+                  <a:schemeClr val="accent5"/>
+                </a:solidFill>
+                <a:latin typeface="Microsoft JhengHei"/>
+                <a:ea typeface="Microsoft JhengHei"/>
+                <a:cs typeface="Microsoft JhengHei"/>
+              </a:rPr>
+              <a:t>07 / 08</a:t>
+            </a:r>
+          </a:p>
+        </p:txBody>
+      </p:sp>
+    </p:spTree>
+  </p:cSld>
+  <p:clrMapOvr>
+    <a:masterClrMapping/>
+  </p:clrMapOvr>
+  <p:transition xmlns:p14="http://schemas.microsoft.com/office/powerpoint/2010/main" p14:dur="400">
+    <p:fade/>
+  </p:transition>
+</p:sld>
+</file>
+
+<file path=ppt/slides/slide8.xml><?xml version="1.0" encoding="utf-8"?>
 <p:sld xmlns:a="http://schemas.openxmlformats.org/drawingml/2006/main" xmlns:r="http://schemas.openxmlformats.org/officeDocument/2006/relationships" xmlns:p="http://schemas.openxmlformats.org/presentationml/2006/main">
   <p:cSld>
     <p:bg>
@@ -6989,706 +7689,6 @@
         </p:nvSpPr>
         <p:spPr>
           <a:xfrm>
-            <a:off x="603504" y="390525"/>
-            <a:ext cx="1580388" cy="234696"/>
-          </a:xfrm>
-          <a:prstGeom prst="rect">
-            <a:avLst/>
-          </a:prstGeom>
-          <a:noFill/>
-          <a:ln>
-            <a:noFill/>
-          </a:ln>
-        </p:spPr>
-        <p:txBody>
-          <a:bodyPr wrap="none" lIns="0" tIns="0" rIns="0" bIns="0" anchor="t" anchorCtr="0">
-            <a:spAutoFit/>
-          </a:bodyPr>
-          <a:lstStyle/>
-          <a:p>
-            <a:pPr algn="l"/>
-            <a:r>
-              <a:rPr lang="en-US" sz="1200" b="1" dirty="0">
-                <a:solidFill>
-                  <a:schemeClr val="accent2"/>
-                </a:solidFill>
-                <a:latin typeface="Microsoft JhengHei"/>
-                <a:ea typeface="Microsoft JhengHei"/>
-                <a:cs typeface="Microsoft JhengHei"/>
-              </a:rPr>
-              <a:t>MEASURED RESULTS</a:t>
-            </a:r>
-          </a:p>
-        </p:txBody>
-      </p:sp>
-      <p:sp>
-        <p:nvSpPr>
-          <p:cNvPr id="3" name="TextBox 3"/>
-          <p:cNvSpPr txBox="1"/>
-          <p:nvPr/>
-        </p:nvSpPr>
-        <p:spPr>
-          <a:xfrm>
-            <a:off x="592836" y="736600"/>
-            <a:ext cx="6252972" cy="645414"/>
-          </a:xfrm>
-          <a:prstGeom prst="rect">
-            <a:avLst/>
-          </a:prstGeom>
-          <a:noFill/>
-          <a:ln>
-            <a:noFill/>
-          </a:ln>
-        </p:spPr>
-        <p:txBody>
-          <a:bodyPr wrap="none" lIns="0" tIns="0" rIns="0" bIns="0" anchor="t" anchorCtr="0">
-            <a:spAutoFit/>
-          </a:bodyPr>
-          <a:lstStyle/>
-          <a:p>
-            <a:pPr algn="l"/>
-            <a:r>
-              <a:rPr lang="zh-TW" sz="3300" dirty="0">
-                <a:solidFill>
-                  <a:srgbClr val="FFFFFF"/>
-                </a:solidFill>
-                <a:latin typeface="Microsoft JhengHei"/>
-                <a:ea typeface="Microsoft JhengHei"/>
-                <a:cs typeface="Microsoft JhengHei"/>
-              </a:rPr>
-              <a:t>從相似案例，走到可核對的結論</a:t>
-            </a:r>
-          </a:p>
-        </p:txBody>
-      </p:sp>
-      <p:sp>
-        <p:nvSpPr>
-          <p:cNvPr id="4" name="TextBox 4"/>
-          <p:cNvSpPr txBox="1"/>
-          <p:nvPr/>
-        </p:nvSpPr>
-        <p:spPr>
-          <a:xfrm>
-            <a:off x="590550" y="2038350"/>
-            <a:ext cx="1946338" cy="790575"/>
-          </a:xfrm>
-          <a:prstGeom prst="rect">
-            <a:avLst/>
-          </a:prstGeom>
-          <a:noFill/>
-          <a:ln>
-            <a:noFill/>
-          </a:ln>
-        </p:spPr>
-        <p:txBody>
-          <a:bodyPr wrap="none" lIns="0" tIns="0" rIns="0" bIns="0" anchor="t" anchorCtr="0">
-            <a:spAutoFit/>
-          </a:bodyPr>
-          <a:lstStyle/>
-          <a:p>
-            <a:pPr algn="l"/>
-            <a:r>
-              <a:rPr lang="zh-TW" sz="4050" dirty="0">
-                <a:solidFill>
-                  <a:srgbClr val="FFFFFF"/>
-                </a:solidFill>
-                <a:latin typeface="Microsoft JhengHei"/>
-                <a:ea typeface="Microsoft JhengHei"/>
-                <a:cs typeface="Microsoft JhengHei"/>
-              </a:rPr>
-              <a:t>97.62%</a:t>
-            </a:r>
-          </a:p>
-        </p:txBody>
-      </p:sp>
-      <p:sp>
-        <p:nvSpPr>
-          <p:cNvPr id="5" name="TextBox 5"/>
-          <p:cNvSpPr txBox="1"/>
-          <p:nvPr/>
-        </p:nvSpPr>
-        <p:spPr>
-          <a:xfrm>
-            <a:off x="598932" y="2870200"/>
-            <a:ext cx="1747952" cy="410718"/>
-          </a:xfrm>
-          <a:prstGeom prst="rect">
-            <a:avLst/>
-          </a:prstGeom>
-          <a:noFill/>
-          <a:ln>
-            <a:noFill/>
-          </a:ln>
-        </p:spPr>
-        <p:txBody>
-          <a:bodyPr wrap="none" lIns="0" tIns="0" rIns="0" bIns="0" anchor="t" anchorCtr="0">
-            <a:spAutoFit/>
-          </a:bodyPr>
-          <a:lstStyle/>
-          <a:p>
-            <a:pPr algn="l"/>
-            <a:r>
-              <a:rPr lang="zh-TW" sz="2100" dirty="0">
-                <a:solidFill>
-                  <a:srgbClr val="FFFFFF"/>
-                </a:solidFill>
-                <a:latin typeface="Microsoft JhengHei"/>
-                <a:ea typeface="Microsoft JhengHei"/>
-                <a:cs typeface="Microsoft JhengHei"/>
-              </a:rPr>
-              <a:t>Top-5 命中率</a:t>
-            </a:r>
-          </a:p>
-        </p:txBody>
-      </p:sp>
-      <p:sp>
-        <p:nvSpPr>
-          <p:cNvPr id="6" name="TextBox 6"/>
-          <p:cNvSpPr txBox="1"/>
-          <p:nvPr/>
-        </p:nvSpPr>
-        <p:spPr>
-          <a:xfrm>
-            <a:off x="602361" y="3479800"/>
-            <a:ext cx="2690724" cy="278702"/>
-          </a:xfrm>
-          <a:prstGeom prst="rect">
-            <a:avLst/>
-          </a:prstGeom>
-          <a:noFill/>
-          <a:ln>
-            <a:noFill/>
-          </a:ln>
-        </p:spPr>
-        <p:txBody>
-          <a:bodyPr wrap="none" lIns="0" tIns="0" rIns="0" bIns="0" anchor="t" anchorCtr="0">
-            <a:spAutoFit/>
-          </a:bodyPr>
-          <a:lstStyle/>
-          <a:p>
-            <a:pPr algn="l"/>
-            <a:r>
-              <a:rPr lang="zh-TW" sz="1420" dirty="0">
-                <a:solidFill>
-                  <a:schemeClr val="accent6"/>
-                </a:solidFill>
-                <a:latin typeface="Microsoft JhengHei"/>
-                <a:ea typeface="Microsoft JhengHei"/>
-                <a:cs typeface="Microsoft JhengHei"/>
-              </a:rPr>
-              <a:t>463 筆查詢／1,550 筆訓練案例</a:t>
-            </a:r>
-          </a:p>
-        </p:txBody>
-      </p:sp>
-      <p:sp>
-        <p:nvSpPr>
-          <p:cNvPr id="7" name="TextBox 7"/>
-          <p:cNvSpPr txBox="1"/>
-          <p:nvPr/>
-        </p:nvSpPr>
-        <p:spPr>
-          <a:xfrm>
-            <a:off x="4352925" y="2038350"/>
-            <a:ext cx="1946338" cy="790575"/>
-          </a:xfrm>
-          <a:prstGeom prst="rect">
-            <a:avLst/>
-          </a:prstGeom>
-          <a:noFill/>
-          <a:ln>
-            <a:noFill/>
-          </a:ln>
-        </p:spPr>
-        <p:txBody>
-          <a:bodyPr wrap="none" lIns="0" tIns="0" rIns="0" bIns="0" anchor="t" anchorCtr="0">
-            <a:spAutoFit/>
-          </a:bodyPr>
-          <a:lstStyle/>
-          <a:p>
-            <a:pPr algn="l"/>
-            <a:r>
-              <a:rPr lang="zh-TW" sz="4050" dirty="0">
-                <a:solidFill>
-                  <a:srgbClr val="FFFFFF"/>
-                </a:solidFill>
-                <a:latin typeface="Microsoft JhengHei"/>
-                <a:ea typeface="Microsoft JhengHei"/>
-                <a:cs typeface="Microsoft JhengHei"/>
-              </a:rPr>
-              <a:t>93.89%</a:t>
-            </a:r>
-          </a:p>
-        </p:txBody>
-      </p:sp>
-      <p:sp>
-        <p:nvSpPr>
-          <p:cNvPr id="8" name="TextBox 8"/>
-          <p:cNvSpPr txBox="1"/>
-          <p:nvPr/>
-        </p:nvSpPr>
-        <p:spPr>
-          <a:xfrm>
-            <a:off x="4361307" y="2870200"/>
-            <a:ext cx="902513" cy="410718"/>
-          </a:xfrm>
-          <a:prstGeom prst="rect">
-            <a:avLst/>
-          </a:prstGeom>
-          <a:noFill/>
-          <a:ln>
-            <a:noFill/>
-          </a:ln>
-        </p:spPr>
-        <p:txBody>
-          <a:bodyPr wrap="none" lIns="0" tIns="0" rIns="0" bIns="0" anchor="t" anchorCtr="0">
-            <a:spAutoFit/>
-          </a:bodyPr>
-          <a:lstStyle/>
-          <a:p>
-            <a:pPr algn="l"/>
-            <a:r>
-              <a:rPr lang="en-US" sz="2100" dirty="0">
-                <a:solidFill>
-                  <a:srgbClr val="FFFFFF"/>
-                </a:solidFill>
-                <a:latin typeface="Microsoft JhengHei"/>
-                <a:ea typeface="Microsoft JhengHei"/>
-                <a:cs typeface="Microsoft JhengHei"/>
-              </a:rPr>
-              <a:t>MRR@5</a:t>
-            </a:r>
-          </a:p>
-        </p:txBody>
-      </p:sp>
-      <p:sp>
-        <p:nvSpPr>
-          <p:cNvPr id="9" name="TextBox 9"/>
-          <p:cNvSpPr txBox="1"/>
-          <p:nvPr/>
-        </p:nvSpPr>
-        <p:spPr>
-          <a:xfrm>
-            <a:off x="4364736" y="3479800"/>
-            <a:ext cx="1926082" cy="278702"/>
-          </a:xfrm>
-          <a:prstGeom prst="rect">
-            <a:avLst/>
-          </a:prstGeom>
-          <a:noFill/>
-          <a:ln>
-            <a:noFill/>
-          </a:ln>
-        </p:spPr>
-        <p:txBody>
-          <a:bodyPr wrap="none" lIns="0" tIns="0" rIns="0" bIns="0" anchor="t" anchorCtr="0">
-            <a:spAutoFit/>
-          </a:bodyPr>
-          <a:lstStyle/>
-          <a:p>
-            <a:pPr algn="l"/>
-            <a:r>
-              <a:rPr lang="zh-TW" sz="1420" dirty="0">
-                <a:solidFill>
-                  <a:schemeClr val="accent6"/>
-                </a:solidFill>
-                <a:latin typeface="Microsoft JhengHei"/>
-                <a:ea typeface="Microsoft JhengHei"/>
-                <a:cs typeface="Microsoft JhengHei"/>
-              </a:rPr>
-              <a:t>前五筆結果的排序品質</a:t>
-            </a:r>
-          </a:p>
-        </p:txBody>
-      </p:sp>
-      <p:sp>
-        <p:nvSpPr>
-          <p:cNvPr id="10" name="TextBox 10"/>
-          <p:cNvSpPr txBox="1"/>
-          <p:nvPr/>
-        </p:nvSpPr>
-        <p:spPr>
-          <a:xfrm>
-            <a:off x="8115300" y="2038350"/>
-            <a:ext cx="1946338" cy="790575"/>
-          </a:xfrm>
-          <a:prstGeom prst="rect">
-            <a:avLst/>
-          </a:prstGeom>
-          <a:noFill/>
-          <a:ln>
-            <a:noFill/>
-          </a:ln>
-        </p:spPr>
-        <p:txBody>
-          <a:bodyPr wrap="none" lIns="0" tIns="0" rIns="0" bIns="0" anchor="t" anchorCtr="0">
-            <a:spAutoFit/>
-          </a:bodyPr>
-          <a:lstStyle/>
-          <a:p>
-            <a:pPr algn="l"/>
-            <a:r>
-              <a:rPr lang="zh-TW" sz="4050" dirty="0">
-                <a:solidFill>
-                  <a:srgbClr val="FFFFFF"/>
-                </a:solidFill>
-                <a:latin typeface="Microsoft JhengHei"/>
-                <a:ea typeface="Microsoft JhengHei"/>
-                <a:cs typeface="Microsoft JhengHei"/>
-              </a:rPr>
-              <a:t>97.11%</a:t>
-            </a:r>
-          </a:p>
-        </p:txBody>
-      </p:sp>
-      <p:sp>
-        <p:nvSpPr>
-          <p:cNvPr id="11" name="TextBox 11"/>
-          <p:cNvSpPr txBox="1"/>
-          <p:nvPr/>
-        </p:nvSpPr>
-        <p:spPr>
-          <a:xfrm>
-            <a:off x="8123682" y="2870200"/>
-            <a:ext cx="1434846" cy="410718"/>
-          </a:xfrm>
-          <a:prstGeom prst="rect">
-            <a:avLst/>
-          </a:prstGeom>
-          <a:noFill/>
-          <a:ln>
-            <a:noFill/>
-          </a:ln>
-        </p:spPr>
-        <p:txBody>
-          <a:bodyPr wrap="none" lIns="0" tIns="0" rIns="0" bIns="0" anchor="t" anchorCtr="0">
-            <a:spAutoFit/>
-          </a:bodyPr>
-          <a:lstStyle/>
-          <a:p>
-            <a:pPr algn="l"/>
-            <a:r>
-              <a:rPr lang="zh-TW" sz="2100" dirty="0">
-                <a:solidFill>
-                  <a:srgbClr val="FFFFFF"/>
-                </a:solidFill>
-                <a:latin typeface="Microsoft JhengHei"/>
-                <a:ea typeface="Microsoft JhengHei"/>
-                <a:cs typeface="Microsoft JhengHei"/>
-              </a:rPr>
-              <a:t>支持精確率</a:t>
-            </a:r>
-          </a:p>
-        </p:txBody>
-      </p:sp>
-      <p:sp>
-        <p:nvSpPr>
-          <p:cNvPr id="12" name="TextBox 12"/>
-          <p:cNvSpPr txBox="1"/>
-          <p:nvPr/>
-        </p:nvSpPr>
-        <p:spPr>
-          <a:xfrm>
-            <a:off x="8127111" y="3479800"/>
-            <a:ext cx="2642934" cy="278702"/>
-          </a:xfrm>
-          <a:prstGeom prst="rect">
-            <a:avLst/>
-          </a:prstGeom>
-          <a:noFill/>
-          <a:ln>
-            <a:noFill/>
-          </a:ln>
-        </p:spPr>
-        <p:txBody>
-          <a:bodyPr wrap="none" lIns="0" tIns="0" rIns="0" bIns="0" anchor="t" anchorCtr="0">
-            <a:spAutoFit/>
-          </a:bodyPr>
-          <a:lstStyle/>
-          <a:p>
-            <a:pPr algn="l"/>
-            <a:r>
-              <a:rPr lang="zh-TW" sz="1420" dirty="0">
-                <a:solidFill>
-                  <a:schemeClr val="accent6"/>
-                </a:solidFill>
-                <a:latin typeface="Microsoft JhengHei"/>
-                <a:ea typeface="Microsoft JhengHei"/>
-                <a:cs typeface="Microsoft JhengHei"/>
-              </a:rPr>
-              <a:t>415 支持／13 複核／35 不確定</a:t>
-            </a:r>
-          </a:p>
-        </p:txBody>
-      </p:sp>
-      <p:sp>
-        <p:nvSpPr>
-          <p:cNvPr id="13" name="Rectangle 13"/>
-          <p:cNvSpPr/>
-          <p:nvPr/>
-        </p:nvSpPr>
-        <p:spPr>
-          <a:xfrm>
-            <a:off x="609600" y="4533900"/>
-            <a:ext cx="10972800" cy="1238250"/>
-          </a:xfrm>
-          <a:prstGeom prst="roundRect">
-            <a:avLst>
-              <a:gd name="adj" fmla="val 6154"/>
-            </a:avLst>
-          </a:prstGeom>
-          <a:solidFill>
-            <a:schemeClr val="accent3"/>
-          </a:solidFill>
-          <a:ln>
-            <a:noFill/>
-          </a:ln>
-        </p:spPr>
-      </p:sp>
-      <p:sp>
-        <p:nvSpPr>
-          <p:cNvPr id="14" name="TextBox 14"/>
-          <p:cNvSpPr txBox="1"/>
-          <p:nvPr/>
-        </p:nvSpPr>
-        <p:spPr>
-          <a:xfrm>
-            <a:off x="821055" y="4581525"/>
-            <a:ext cx="1558592" cy="661035"/>
-          </a:xfrm>
-          <a:prstGeom prst="rect">
-            <a:avLst/>
-          </a:prstGeom>
-          <a:noFill/>
-          <a:ln>
-            <a:noFill/>
-          </a:ln>
-        </p:spPr>
-        <p:txBody>
-          <a:bodyPr wrap="none" lIns="0" tIns="0" rIns="0" bIns="0" anchor="t" anchorCtr="0">
-            <a:spAutoFit/>
-          </a:bodyPr>
-          <a:lstStyle/>
-          <a:p>
-            <a:pPr algn="l"/>
-            <a:r>
-              <a:rPr lang="zh-TW" sz="3380" dirty="0">
-                <a:solidFill>
-                  <a:schemeClr val="accent2"/>
-                </a:solidFill>
-                <a:latin typeface="Microsoft JhengHei"/>
-                <a:ea typeface="Microsoft JhengHei"/>
-                <a:cs typeface="Microsoft JhengHei"/>
-              </a:rPr>
-              <a:t>18 / 30</a:t>
-            </a:r>
-          </a:p>
-        </p:txBody>
-      </p:sp>
-      <p:sp>
-        <p:nvSpPr>
-          <p:cNvPr id="15" name="TextBox 15"/>
-          <p:cNvSpPr txBox="1"/>
-          <p:nvPr/>
-        </p:nvSpPr>
-        <p:spPr>
-          <a:xfrm>
-            <a:off x="3704844" y="4759325"/>
-            <a:ext cx="3432429" cy="381381"/>
-          </a:xfrm>
-          <a:prstGeom prst="rect">
-            <a:avLst/>
-          </a:prstGeom>
-          <a:noFill/>
-          <a:ln>
-            <a:noFill/>
-          </a:ln>
-        </p:spPr>
-        <p:txBody>
-          <a:bodyPr wrap="none" lIns="0" tIns="0" rIns="0" bIns="0" anchor="t" anchorCtr="0">
-            <a:spAutoFit/>
-          </a:bodyPr>
-          <a:lstStyle/>
-          <a:p>
-            <a:pPr algn="l"/>
-            <a:r>
-              <a:rPr lang="zh-TW" sz="1950" dirty="0">
-                <a:solidFill>
-                  <a:srgbClr val="FFFFFF"/>
-                </a:solidFill>
-                <a:latin typeface="Microsoft JhengHei"/>
-                <a:ea typeface="Microsoft JhengHei"/>
-                <a:cs typeface="Microsoft JhengHei"/>
-              </a:rPr>
-              <a:t>偵測誤判分流至複核或不確定</a:t>
-            </a:r>
-          </a:p>
-        </p:txBody>
-      </p:sp>
-      <p:sp>
-        <p:nvSpPr>
-          <p:cNvPr id="16" name="TextBox 16"/>
-          <p:cNvSpPr txBox="1"/>
-          <p:nvPr/>
-        </p:nvSpPr>
-        <p:spPr>
-          <a:xfrm>
-            <a:off x="829437" y="5213350"/>
-            <a:ext cx="5392898" cy="337376"/>
-          </a:xfrm>
-          <a:prstGeom prst="rect">
-            <a:avLst/>
-          </a:prstGeom>
-          <a:noFill/>
-          <a:ln>
-            <a:noFill/>
-          </a:ln>
-        </p:spPr>
-        <p:txBody>
-          <a:bodyPr wrap="none" lIns="0" tIns="0" rIns="0" bIns="0" anchor="t" anchorCtr="0">
-            <a:spAutoFit/>
-          </a:bodyPr>
-          <a:lstStyle/>
-          <a:p>
-            <a:pPr algn="l"/>
-            <a:r>
-              <a:rPr lang="zh-TW" sz="1720" dirty="0">
-                <a:solidFill>
-                  <a:schemeClr val="accent6"/>
-                </a:solidFill>
-                <a:latin typeface="Microsoft JhengHei"/>
-                <a:ea typeface="Microsoft JhengHei"/>
-                <a:cs typeface="Microsoft JhengHei"/>
-              </a:rPr>
-              <a:t>AI 依案例證據給出稽核結論；正式分類保持可追溯。</a:t>
-            </a:r>
-          </a:p>
-        </p:txBody>
-      </p:sp>
-      <p:sp>
-        <p:nvSpPr>
-          <p:cNvPr id="17" name="TextBox 17"/>
-          <p:cNvSpPr txBox="1"/>
-          <p:nvPr/>
-        </p:nvSpPr>
-        <p:spPr>
-          <a:xfrm>
-            <a:off x="604266" y="6416675"/>
-            <a:ext cx="1617135" cy="205359"/>
-          </a:xfrm>
-          <a:prstGeom prst="rect">
-            <a:avLst/>
-          </a:prstGeom>
-          <a:noFill/>
-          <a:ln>
-            <a:noFill/>
-          </a:ln>
-        </p:spPr>
-        <p:txBody>
-          <a:bodyPr wrap="none" lIns="0" tIns="0" rIns="0" bIns="0" anchor="t" anchorCtr="0">
-            <a:spAutoFit/>
-          </a:bodyPr>
-          <a:lstStyle/>
-          <a:p>
-            <a:pPr algn="l"/>
-            <a:r>
-              <a:rPr lang="zh-TW" sz="1050" dirty="0">
-                <a:solidFill>
-                  <a:schemeClr val="accent6"/>
-                </a:solidFill>
-                <a:latin typeface="Microsoft JhengHei"/>
-                <a:ea typeface="Microsoft JhengHei"/>
-                <a:cs typeface="Microsoft JhengHei"/>
-              </a:rPr>
-              <a:t>AI 資安框架 · 資安技術組</a:t>
-            </a:r>
-          </a:p>
-        </p:txBody>
-      </p:sp>
-      <p:sp>
-        <p:nvSpPr>
-          <p:cNvPr id="18" name="TextBox 18"/>
-          <p:cNvSpPr txBox="1"/>
-          <p:nvPr/>
-        </p:nvSpPr>
-        <p:spPr>
-          <a:xfrm>
-            <a:off x="11103540" y="6416675"/>
-            <a:ext cx="484194" cy="205359"/>
-          </a:xfrm>
-          <a:prstGeom prst="rect">
-            <a:avLst/>
-          </a:prstGeom>
-          <a:noFill/>
-          <a:ln>
-            <a:noFill/>
-          </a:ln>
-        </p:spPr>
-        <p:txBody>
-          <a:bodyPr wrap="none" lIns="0" tIns="0" rIns="0" bIns="0" anchor="t" anchorCtr="0">
-            <a:spAutoFit/>
-          </a:bodyPr>
-          <a:lstStyle/>
-          <a:p>
-            <a:pPr algn="r"/>
-            <a:r>
-              <a:rPr lang="zh-TW" sz="1050" dirty="0">
-                <a:solidFill>
-                  <a:schemeClr val="accent6"/>
-                </a:solidFill>
-                <a:latin typeface="Microsoft JhengHei"/>
-                <a:ea typeface="Microsoft JhengHei"/>
-                <a:cs typeface="Microsoft JhengHei"/>
-              </a:rPr>
-              <a:t>07 / 08</a:t>
-            </a:r>
-          </a:p>
-        </p:txBody>
-      </p:sp>
-    </p:spTree>
-  </p:cSld>
-  <p:clrMapOvr>
-    <a:masterClrMapping/>
-  </p:clrMapOvr>
-  <p:transition xmlns:p14="http://schemas.microsoft.com/office/powerpoint/2010/main" p14:dur="400">
-    <p:fade/>
-  </p:transition>
-</p:sld>
-</file>
-
-<file path=ppt/slides/slide8.xml><?xml version="1.0" encoding="utf-8"?>
-<p:sld xmlns:a="http://schemas.openxmlformats.org/drawingml/2006/main" xmlns:r="http://schemas.openxmlformats.org/officeDocument/2006/relationships" xmlns:p="http://schemas.openxmlformats.org/presentationml/2006/main">
-  <p:cSld>
-    <p:bg>
-      <p:bgPr>
-        <a:solidFill>
-          <a:schemeClr val="accent1"/>
-        </a:solidFill>
-        <a:effectLst/>
-      </p:bgPr>
-    </p:bg>
-    <p:spTree>
-      <p:nvGrpSpPr>
-        <p:cNvPr id="1" name=""/>
-        <p:cNvGrpSpPr/>
-        <p:nvPr/>
-      </p:nvGrpSpPr>
-      <p:grpSpPr>
-        <a:xfrm>
-          <a:off x="0" y="0"/>
-          <a:ext cx="0" cy="0"/>
-          <a:chOff x="0" y="0"/>
-          <a:chExt cx="0" cy="0"/>
-        </a:xfrm>
-      </p:grpSpPr>
-      <p:sp>
-        <p:nvSpPr>
-          <p:cNvPr id="2" name="TextBox 2"/>
-          <p:cNvSpPr txBox="1"/>
-          <p:nvPr/>
-        </p:nvSpPr>
-        <p:spPr>
-          <a:xfrm>
             <a:off x="602742" y="711200"/>
             <a:ext cx="2261837" cy="264033"/>
           </a:xfrm>
@@ -7710,7 +7710,7 @@
             <a:r>
               <a:rPr lang="en-US" sz="1350" b="1" dirty="0">
                 <a:solidFill>
-                  <a:srgbClr val="FFFFFF"/>
+                  <a:srgbClr val="121314"/>
                 </a:solidFill>
                 <a:latin typeface="Microsoft JhengHei"/>
                 <a:ea typeface="Microsoft JhengHei"/>
@@ -7750,7 +7750,7 @@
             <a:r>
               <a:rPr lang="zh-TW" sz="4200" dirty="0">
                 <a:solidFill>
-                  <a:srgbClr val="FFFFFF"/>
+                  <a:srgbClr val="121314"/>
                 </a:solidFill>
                 <a:latin typeface="Microsoft JhengHei"/>
                 <a:ea typeface="Microsoft JhengHei"/>
@@ -7790,7 +7790,7 @@
             <a:r>
               <a:rPr lang="zh-TW" sz="4200" dirty="0">
                 <a:solidFill>
-                  <a:srgbClr val="FFFFFF"/>
+                  <a:srgbClr val="121314"/>
                 </a:solidFill>
                 <a:latin typeface="Microsoft JhengHei"/>
                 <a:ea typeface="Microsoft JhengHei"/>
@@ -7830,7 +7830,7 @@
             <a:r>
               <a:rPr lang="zh-TW" sz="4200" dirty="0">
                 <a:solidFill>
-                  <a:srgbClr val="FFFFFF"/>
+                  <a:srgbClr val="121314"/>
                 </a:solidFill>
                 <a:latin typeface="Microsoft JhengHei"/>
                 <a:ea typeface="Microsoft JhengHei"/>
@@ -7894,7 +7894,7 @@
             <a:r>
               <a:rPr lang="zh-TW" sz="2100" dirty="0">
                 <a:solidFill>
-                  <a:srgbClr val="FFFFFF"/>
+                  <a:srgbClr val="121314"/>
                 </a:solidFill>
                 <a:latin typeface="Microsoft JhengHei"/>
                 <a:ea typeface="Microsoft JhengHei"/>
@@ -7934,7 +7934,7 @@
             <a:r>
               <a:rPr lang="zh-TW" sz="1650" dirty="0">
                 <a:solidFill>
-                  <a:srgbClr val="FFFFFF"/>
+                  <a:srgbClr val="121314"/>
                 </a:solidFill>
                 <a:latin typeface="Microsoft JhengHei"/>
                 <a:ea typeface="Microsoft JhengHei"/>
@@ -7970,16 +7970,16 @@
         <a:srgbClr val="1F497D"/>
       </a:dk2>
       <a:lt2>
-        <a:srgbClr val="000000"/>
+        <a:srgbClr val="F2F7FC"/>
       </a:lt2>
       <a:accent1>
         <a:srgbClr val="0070D1"/>
       </a:accent1>
       <a:accent2>
-        <a:srgbClr val="53B1FF"/>
+        <a:srgbClr val="0070D1"/>
       </a:accent2>
       <a:accent3>
-        <a:srgbClr val="181818"/>
+        <a:srgbClr val="F5F7FA"/>
       </a:accent3>
       <a:accent4>
         <a:srgbClr val="0070D1"/>
@@ -7991,10 +7991,10 @@
         <a:srgbClr val="CCCCCC"/>
       </a:accent6>
       <a:hlink>
-        <a:srgbClr val="53B1FF"/>
+        <a:srgbClr val="0070D1"/>
       </a:hlink>
       <a:folHlink>
-        <a:srgbClr val="181818"/>
+        <a:srgbClr val="F5F7FA"/>
       </a:folHlink>
     </a:clrScheme>
     <a:fontScheme name="finals_editorial">
@@ -8290,16 +8290,16 @@
         <a:srgbClr val="1F497D"/>
       </a:dk2>
       <a:lt2>
-        <a:srgbClr val="000000"/>
+        <a:srgbClr val="F2F7FC"/>
       </a:lt2>
       <a:accent1>
         <a:srgbClr val="0070D1"/>
       </a:accent1>
       <a:accent2>
-        <a:srgbClr val="53B1FF"/>
+        <a:srgbClr val="0070D1"/>
       </a:accent2>
       <a:accent3>
-        <a:srgbClr val="181818"/>
+        <a:srgbClr val="F5F7FA"/>
       </a:accent3>
       <a:accent4>
         <a:srgbClr val="0070D1"/>
@@ -8311,10 +8311,10 @@
         <a:srgbClr val="CCCCCC"/>
       </a:accent6>
       <a:hlink>
-        <a:srgbClr val="53B1FF"/>
+        <a:srgbClr val="0070D1"/>
       </a:hlink>
       <a:folHlink>
-        <a:srgbClr val="181818"/>
+        <a:srgbClr val="F5F7FA"/>
       </a:folHlink>
     </a:clrScheme>
     <a:fontScheme name="finals_editorial">

</xml_diff>